<commit_message>
docs(drift): pitch deck v2, ten slides with the halt story and why BNB
Adds who needs DRIFT and how it could pay (labelled as a hypothesis,
no market figures), why BNB Chain with the cost per decision taken from
our own receipts (33,189-34,323 gas at 0.1 gwei, about 0.0000034 tBNB),
the halt story at block 134,042,283 with a gauge drawn from the two
recorded drawdowns, evidence and limits from today's test runs, and a
roadmap marked as not built. "What Dex added" stays; its speaker notes
carry the provenance sentence, now read from README.md so the two
cannot drift apart. Document properties name Dex Bennett instead of
the library's template defaults.
</commit_message>
<xml_diff>
--- a/docs/submission/DRIFT-pitch.pptx
+++ b/docs/submission/DRIFT-pitch.pptx
@@ -6,11 +6,15 @@
   </p:sldMasterIdLst>
   <p:sldIdLst>
     <p:sldId id="256" r:id="rId7"/>
-    <p:sldId id="257" r:id="rId8"/>
-    <p:sldId id="258" r:id="rId9"/>
-    <p:sldId id="259" r:id="rId10"/>
-    <p:sldId id="260" r:id="rId11"/>
+    <p:sldId id="257" r:id="rId9"/>
+    <p:sldId id="258" r:id="rId10"/>
+    <p:sldId id="259" r:id="rId11"/>
+    <p:sldId id="260" r:id="rId12"/>
     <p:sldId id="261" r:id="rId13"/>
+    <p:sldId id="262" r:id="rId14"/>
+    <p:sldId id="263" r:id="rId15"/>
+    <p:sldId id="264" r:id="rId16"/>
+    <p:sldId id="265" r:id="rId17"/>
   </p:sldIdLst>
   <p:sldSz cx="12191695" cy="6858000" type="screen4x3"/>
   <p:notesSz cx="6858000" cy="9144000"/>
@@ -507,7 +511,637 @@
           <a:lstStyle/>
           <a:p>
             <a:r>
-              <a:t>DRIFT's core (the quant engine, the cockpit and `MacroGuard.sol`) comes from the upstream DRIFT project, built for a Mantle hackathon track ("AI Trading &amp; Strategy", June 2026) and migrated to BNB Chain in `bcc-ukdw/seed-bnb` (commit `52671ce`, 29 Sep 2026). Dex Bennett's contribution in this fork: the MacroGuard transparency panel (`/dashboard/macroguard` and the public `/macroguard`), the read-only `/guard/state` API, contract reads straight from the browser over a public RPC (no engine needed), honest copy corrections, a self-owned MacroGuard deployment with an on-chain smoke test (30 Sep 2026), source verification on Sourcify, the judge-facing landing page and visual system, the PRD and the pitch deck.</a:t>
+              <a:t>DRIFT in one line: the trading bot's risk rules live in a public contract on BNB Chain, so anyone can check them.</a:t>
+            </a:r>
+          </a:p>
+        </p:txBody>
+      </p:sp>
+      <p:sp>
+        <p:nvSpPr>
+          <p:cNvPr id="4" name="Slide Number Placeholder 3"/>
+          <p:cNvSpPr>
+            <a:spLocks noGrp="1"/>
+          </p:cNvSpPr>
+          <p:nvPr>
+            <p:ph type="sldNum" idx="5" sz="quarter"/>
+          </p:nvPr>
+        </p:nvSpPr>
+        <p:spPr/>
+      </p:sp>
+    </p:spTree>
+  </p:cSld>
+  <p:clrMapOvr>
+    <a:masterClrMapping/>
+  </p:clrMapOvr>
+</p:notes>
+</file>
+
+<file path=ppt/notesSlides/notesSlide10.xml><?xml version="1.0" encoding="utf-8"?>
+<p:notes xmlns:a="http://schemas.openxmlformats.org/drawingml/2006/main" xmlns:p="http://schemas.openxmlformats.org/presentationml/2006/main" xmlns:r="http://schemas.openxmlformats.org/officeDocument/2006/relationships">
+  <p:cSld>
+    <p:spTree>
+      <p:nvGrpSpPr>
+        <p:cNvPr id="1" name=""/>
+        <p:cNvGrpSpPr/>
+        <p:nvPr/>
+      </p:nvGrpSpPr>
+      <p:grpSpPr>
+        <a:xfrm>
+          <a:off x="0" y="0"/>
+          <a:ext cx="0" cy="0"/>
+          <a:chOff x="0" y="0"/>
+          <a:chExt cx="0" cy="0"/>
+        </a:xfrm>
+      </p:grpSpPr>
+      <p:sp>
+        <p:nvSpPr>
+          <p:cNvPr id="2" name="Slide Image Placeholder 1"/>
+          <p:cNvSpPr>
+            <a:spLocks noGrp="1"/>
+          </p:cNvSpPr>
+          <p:nvPr>
+            <p:ph type="sldImg" idx="2"/>
+          </p:nvPr>
+        </p:nvSpPr>
+        <p:spPr/>
+      </p:sp>
+      <p:sp>
+        <p:nvSpPr>
+          <p:cNvPr id="3" name="Notes Placeholder 2"/>
+          <p:cNvSpPr>
+            <a:spLocks noGrp="1"/>
+          </p:cNvSpPr>
+          <p:nvPr>
+            <p:ph type="body" idx="3" sz="quarter"/>
+          </p:nvPr>
+        </p:nvSpPr>
+        <p:spPr/>
+        <p:txBody>
+          <a:bodyPr/>
+          <a:lstStyle/>
+          <a:p>
+            <a:r>
+              <a:t>Roadmap items are not built yet. The links are live today.</a:t>
+            </a:r>
+          </a:p>
+        </p:txBody>
+      </p:sp>
+      <p:sp>
+        <p:nvSpPr>
+          <p:cNvPr id="4" name="Slide Number Placeholder 3"/>
+          <p:cNvSpPr>
+            <a:spLocks noGrp="1"/>
+          </p:cNvSpPr>
+          <p:nvPr>
+            <p:ph type="sldNum" idx="5" sz="quarter"/>
+          </p:nvPr>
+        </p:nvSpPr>
+        <p:spPr/>
+      </p:sp>
+    </p:spTree>
+  </p:cSld>
+  <p:clrMapOvr>
+    <a:masterClrMapping/>
+  </p:clrMapOvr>
+</p:notes>
+</file>
+
+<file path=ppt/notesSlides/notesSlide2.xml><?xml version="1.0" encoding="utf-8"?>
+<p:notes xmlns:a="http://schemas.openxmlformats.org/drawingml/2006/main" xmlns:p="http://schemas.openxmlformats.org/presentationml/2006/main" xmlns:r="http://schemas.openxmlformats.org/officeDocument/2006/relationships">
+  <p:cSld>
+    <p:spTree>
+      <p:nvGrpSpPr>
+        <p:cNvPr id="1" name=""/>
+        <p:cNvGrpSpPr/>
+        <p:nvPr/>
+      </p:nvGrpSpPr>
+      <p:grpSpPr>
+        <a:xfrm>
+          <a:off x="0" y="0"/>
+          <a:ext cx="0" cy="0"/>
+          <a:chOff x="0" y="0"/>
+          <a:chExt cx="0" cy="0"/>
+        </a:xfrm>
+      </p:grpSpPr>
+      <p:sp>
+        <p:nvSpPr>
+          <p:cNvPr id="2" name="Slide Image Placeholder 1"/>
+          <p:cNvSpPr>
+            <a:spLocks noGrp="1"/>
+          </p:cNvSpPr>
+          <p:nvPr>
+            <p:ph type="sldImg" idx="2"/>
+          </p:nvPr>
+        </p:nvSpPr>
+        <p:spPr/>
+      </p:sp>
+      <p:sp>
+        <p:nvSpPr>
+          <p:cNvPr id="3" name="Notes Placeholder 2"/>
+          <p:cNvSpPr>
+            <a:spLocks noGrp="1"/>
+          </p:cNvSpPr>
+          <p:nvPr>
+            <p:ph type="body" idx="3" sz="quarter"/>
+          </p:nvPr>
+        </p:nvSpPr>
+        <p:spPr/>
+        <p:txBody>
+          <a:bodyPr/>
+          <a:lstStyle/>
+          <a:p>
+            <a:r>
+              <a:t>Bots ask for trust. DRIFT replaces the promise with a public rule and a public record.</a:t>
+            </a:r>
+          </a:p>
+        </p:txBody>
+      </p:sp>
+      <p:sp>
+        <p:nvSpPr>
+          <p:cNvPr id="4" name="Slide Number Placeholder 3"/>
+          <p:cNvSpPr>
+            <a:spLocks noGrp="1"/>
+          </p:cNvSpPr>
+          <p:nvPr>
+            <p:ph type="sldNum" idx="5" sz="quarter"/>
+          </p:nvPr>
+        </p:nvSpPr>
+        <p:spPr/>
+      </p:sp>
+    </p:spTree>
+  </p:cSld>
+  <p:clrMapOvr>
+    <a:masterClrMapping/>
+  </p:clrMapOvr>
+</p:notes>
+</file>
+
+<file path=ppt/notesSlides/notesSlide3.xml><?xml version="1.0" encoding="utf-8"?>
+<p:notes xmlns:a="http://schemas.openxmlformats.org/drawingml/2006/main" xmlns:p="http://schemas.openxmlformats.org/presentationml/2006/main" xmlns:r="http://schemas.openxmlformats.org/officeDocument/2006/relationships">
+  <p:cSld>
+    <p:spTree>
+      <p:nvGrpSpPr>
+        <p:cNvPr id="1" name=""/>
+        <p:cNvGrpSpPr/>
+        <p:nvPr/>
+      </p:nvGrpSpPr>
+      <p:grpSpPr>
+        <a:xfrm>
+          <a:off x="0" y="0"/>
+          <a:ext cx="0" cy="0"/>
+          <a:chOff x="0" y="0"/>
+          <a:chExt cx="0" cy="0"/>
+        </a:xfrm>
+      </p:grpSpPr>
+      <p:sp>
+        <p:nvSpPr>
+          <p:cNvPr id="2" name="Slide Image Placeholder 1"/>
+          <p:cNvSpPr>
+            <a:spLocks noGrp="1"/>
+          </p:cNvSpPr>
+          <p:nvPr>
+            <p:ph type="sldImg" idx="2"/>
+          </p:nvPr>
+        </p:nvSpPr>
+        <p:spPr/>
+      </p:sp>
+      <p:sp>
+        <p:nvSpPr>
+          <p:cNvPr id="3" name="Notes Placeholder 2"/>
+          <p:cNvSpPr>
+            <a:spLocks noGrp="1"/>
+          </p:cNvSpPr>
+          <p:nvPr>
+            <p:ph type="body" idx="3" sz="quarter"/>
+          </p:nvPr>
+        </p:nvSpPr>
+        <p:spPr/>
+        <p:txBody>
+          <a:bodyPr/>
+          <a:lstStyle/>
+          <a:p>
+            <a:r>
+              <a:t>Everything on this slide is a hypothesis: no user interviews or market sizing have been done yet. The point is the shape of the value: proof of discipline, not proof of profit.</a:t>
+            </a:r>
+          </a:p>
+        </p:txBody>
+      </p:sp>
+      <p:sp>
+        <p:nvSpPr>
+          <p:cNvPr id="4" name="Slide Number Placeholder 3"/>
+          <p:cNvSpPr>
+            <a:spLocks noGrp="1"/>
+          </p:cNvSpPr>
+          <p:nvPr>
+            <p:ph type="sldNum" idx="5" sz="quarter"/>
+          </p:nvPr>
+        </p:nvSpPr>
+        <p:spPr/>
+      </p:sp>
+    </p:spTree>
+  </p:cSld>
+  <p:clrMapOvr>
+    <a:masterClrMapping/>
+  </p:clrMapOvr>
+</p:notes>
+</file>
+
+<file path=ppt/notesSlides/notesSlide4.xml><?xml version="1.0" encoding="utf-8"?>
+<p:notes xmlns:a="http://schemas.openxmlformats.org/drawingml/2006/main" xmlns:p="http://schemas.openxmlformats.org/presentationml/2006/main" xmlns:r="http://schemas.openxmlformats.org/officeDocument/2006/relationships">
+  <p:cSld>
+    <p:spTree>
+      <p:nvGrpSpPr>
+        <p:cNvPr id="1" name=""/>
+        <p:cNvGrpSpPr/>
+        <p:nvPr/>
+      </p:nvGrpSpPr>
+      <p:grpSpPr>
+        <a:xfrm>
+          <a:off x="0" y="0"/>
+          <a:ext cx="0" cy="0"/>
+          <a:chOff x="0" y="0"/>
+          <a:chExt cx="0" cy="0"/>
+        </a:xfrm>
+      </p:grpSpPr>
+      <p:sp>
+        <p:nvSpPr>
+          <p:cNvPr id="2" name="Slide Image Placeholder 1"/>
+          <p:cNvSpPr>
+            <a:spLocks noGrp="1"/>
+          </p:cNvSpPr>
+          <p:nvPr>
+            <p:ph type="sldImg" idx="2"/>
+          </p:nvPr>
+        </p:nvSpPr>
+        <p:spPr/>
+      </p:sp>
+      <p:sp>
+        <p:nvSpPr>
+          <p:cNvPr id="3" name="Notes Placeholder 2"/>
+          <p:cNvSpPr>
+            <a:spLocks noGrp="1"/>
+          </p:cNvSpPr>
+          <p:nvPr>
+            <p:ph type="body" idx="3" sz="quarter"/>
+          </p:nvPr>
+        </p:nvSpPr>
+        <p:spPr/>
+        <p:txBody>
+          <a:bodyPr/>
+          <a:lstStyle/>
+          <a:p>
+            <a:r>
+              <a:t>Four steps: signal off-chain, ask the gate, trade on the exchange, record on-chain.</a:t>
+            </a:r>
+          </a:p>
+        </p:txBody>
+      </p:sp>
+      <p:sp>
+        <p:nvSpPr>
+          <p:cNvPr id="4" name="Slide Number Placeholder 3"/>
+          <p:cNvSpPr>
+            <a:spLocks noGrp="1"/>
+          </p:cNvSpPr>
+          <p:nvPr>
+            <p:ph type="sldNum" idx="5" sz="quarter"/>
+          </p:nvPr>
+        </p:nvSpPr>
+        <p:spPr/>
+      </p:sp>
+    </p:spTree>
+  </p:cSld>
+  <p:clrMapOvr>
+    <a:masterClrMapping/>
+  </p:clrMapOvr>
+</p:notes>
+</file>
+
+<file path=ppt/notesSlides/notesSlide5.xml><?xml version="1.0" encoding="utf-8"?>
+<p:notes xmlns:a="http://schemas.openxmlformats.org/drawingml/2006/main" xmlns:p="http://schemas.openxmlformats.org/presentationml/2006/main" xmlns:r="http://schemas.openxmlformats.org/officeDocument/2006/relationships">
+  <p:cSld>
+    <p:spTree>
+      <p:nvGrpSpPr>
+        <p:cNvPr id="1" name=""/>
+        <p:cNvGrpSpPr/>
+        <p:nvPr/>
+      </p:nvGrpSpPr>
+      <p:grpSpPr>
+        <a:xfrm>
+          <a:off x="0" y="0"/>
+          <a:ext cx="0" cy="0"/>
+          <a:chOff x="0" y="0"/>
+          <a:chExt cx="0" cy="0"/>
+        </a:xfrm>
+      </p:grpSpPr>
+      <p:sp>
+        <p:nvSpPr>
+          <p:cNvPr id="2" name="Slide Image Placeholder 1"/>
+          <p:cNvSpPr>
+            <a:spLocks noGrp="1"/>
+          </p:cNvSpPr>
+          <p:nvPr>
+            <p:ph type="sldImg" idx="2"/>
+          </p:nvPr>
+        </p:nvSpPr>
+        <p:spPr/>
+      </p:sp>
+      <p:sp>
+        <p:nvSpPr>
+          <p:cNvPr id="3" name="Notes Placeholder 2"/>
+          <p:cNvSpPr>
+            <a:spLocks noGrp="1"/>
+          </p:cNvSpPr>
+          <p:nvPr>
+            <p:ph type="body" idx="3" sz="quarter"/>
+          </p:nvPr>
+        </p:nvSpPr>
+        <p:spPr/>
+        <p:txBody>
+          <a:bodyPr/>
+          <a:lstStyle/>
+          <a:p>
+            <a:r>
+              <a:t>Public, no login, no wallet. Left: the live state read from BNB Chain in the browser. Right: ask the contract a what-if; it answers through eth_call, nothing is signed.</a:t>
+            </a:r>
+          </a:p>
+        </p:txBody>
+      </p:sp>
+      <p:sp>
+        <p:nvSpPr>
+          <p:cNvPr id="4" name="Slide Number Placeholder 3"/>
+          <p:cNvSpPr>
+            <a:spLocks noGrp="1"/>
+          </p:cNvSpPr>
+          <p:nvPr>
+            <p:ph type="sldNum" idx="5" sz="quarter"/>
+          </p:nvPr>
+        </p:nvSpPr>
+        <p:spPr/>
+      </p:sp>
+    </p:spTree>
+  </p:cSld>
+  <p:clrMapOvr>
+    <a:masterClrMapping/>
+  </p:clrMapOvr>
+</p:notes>
+</file>
+
+<file path=ppt/notesSlides/notesSlide6.xml><?xml version="1.0" encoding="utf-8"?>
+<p:notes xmlns:a="http://schemas.openxmlformats.org/drawingml/2006/main" xmlns:p="http://schemas.openxmlformats.org/presentationml/2006/main" xmlns:r="http://schemas.openxmlformats.org/officeDocument/2006/relationships">
+  <p:cSld>
+    <p:spTree>
+      <p:nvGrpSpPr>
+        <p:cNvPr id="1" name=""/>
+        <p:cNvGrpSpPr/>
+        <p:nvPr/>
+      </p:nvGrpSpPr>
+      <p:grpSpPr>
+        <a:xfrm>
+          <a:off x="0" y="0"/>
+          <a:ext cx="0" cy="0"/>
+          <a:chOff x="0" y="0"/>
+          <a:chExt cx="0" cy="0"/>
+        </a:xfrm>
+      </p:grpSpPr>
+      <p:sp>
+        <p:nvSpPr>
+          <p:cNvPr id="2" name="Slide Image Placeholder 1"/>
+          <p:cNvSpPr>
+            <a:spLocks noGrp="1"/>
+          </p:cNvSpPr>
+          <p:nvPr>
+            <p:ph type="sldImg" idx="2"/>
+          </p:nvPr>
+        </p:nvSpPr>
+        <p:spPr/>
+      </p:sp>
+      <p:sp>
+        <p:nvSpPr>
+          <p:cNvPr id="3" name="Notes Placeholder 2"/>
+          <p:cNvSpPr>
+            <a:spLocks noGrp="1"/>
+          </p:cNvSpPr>
+          <p:nvPr>
+            <p:ph type="body" idx="3" sz="quarter"/>
+          </p:nvPr>
+        </p:nvSpPr>
+        <p:spPr/>
+        <p:txBody>
+          <a:bodyPr/>
+          <a:lstStyle/>
+          <a:p>
+            <a:r>
+              <a:t>Smoke test on 30 Sep 2026. At step 3 nobody pressed a button: the rule fired inside the contract when the reported drawdown crossed 20%. Honest limit: the drawdown was reported by the agent.</a:t>
+            </a:r>
+          </a:p>
+        </p:txBody>
+      </p:sp>
+      <p:sp>
+        <p:nvSpPr>
+          <p:cNvPr id="4" name="Slide Number Placeholder 3"/>
+          <p:cNvSpPr>
+            <a:spLocks noGrp="1"/>
+          </p:cNvSpPr>
+          <p:nvPr>
+            <p:ph type="sldNum" idx="5" sz="quarter"/>
+          </p:nvPr>
+        </p:nvSpPr>
+        <p:spPr/>
+      </p:sp>
+    </p:spTree>
+  </p:cSld>
+  <p:clrMapOvr>
+    <a:masterClrMapping/>
+  </p:clrMapOvr>
+</p:notes>
+</file>
+
+<file path=ppt/notesSlides/notesSlide7.xml><?xml version="1.0" encoding="utf-8"?>
+<p:notes xmlns:a="http://schemas.openxmlformats.org/drawingml/2006/main" xmlns:p="http://schemas.openxmlformats.org/presentationml/2006/main" xmlns:r="http://schemas.openxmlformats.org/officeDocument/2006/relationships">
+  <p:cSld>
+    <p:spTree>
+      <p:nvGrpSpPr>
+        <p:cNvPr id="1" name=""/>
+        <p:cNvGrpSpPr/>
+        <p:nvPr/>
+      </p:nvGrpSpPr>
+      <p:grpSpPr>
+        <a:xfrm>
+          <a:off x="0" y="0"/>
+          <a:ext cx="0" cy="0"/>
+          <a:chOff x="0" y="0"/>
+          <a:chExt cx="0" cy="0"/>
+        </a:xfrm>
+      </p:grpSpPr>
+      <p:sp>
+        <p:nvSpPr>
+          <p:cNvPr id="2" name="Slide Image Placeholder 1"/>
+          <p:cNvSpPr>
+            <a:spLocks noGrp="1"/>
+          </p:cNvSpPr>
+          <p:nvPr>
+            <p:ph type="sldImg" idx="2"/>
+          </p:nvPr>
+        </p:nvSpPr>
+        <p:spPr/>
+      </p:sp>
+      <p:sp>
+        <p:nvSpPr>
+          <p:cNvPr id="3" name="Notes Placeholder 2"/>
+          <p:cNvSpPr>
+            <a:spLocks noGrp="1"/>
+          </p:cNvSpPr>
+          <p:nvPr>
+            <p:ph type="body" idx="3" sz="quarter"/>
+          </p:nvPr>
+        </p:nvSpPr>
+        <p:spPr/>
+        <p:txBody>
+          <a:bodyPr/>
+          <a:lstStyle/>
+          <a:p>
+            <a:r>
+              <a:t>Costs come from our own receipts on BSC Testnet at the observed 0.1 gwei; they are not a mainnet quote. The panel reads the chain from the browser because the public RPCs allow it.</a:t>
+            </a:r>
+          </a:p>
+        </p:txBody>
+      </p:sp>
+      <p:sp>
+        <p:nvSpPr>
+          <p:cNvPr id="4" name="Slide Number Placeholder 3"/>
+          <p:cNvSpPr>
+            <a:spLocks noGrp="1"/>
+          </p:cNvSpPr>
+          <p:nvPr>
+            <p:ph type="sldNum" idx="5" sz="quarter"/>
+          </p:nvPr>
+        </p:nvSpPr>
+        <p:spPr/>
+      </p:sp>
+    </p:spTree>
+  </p:cSld>
+  <p:clrMapOvr>
+    <a:masterClrMapping/>
+  </p:clrMapOvr>
+</p:notes>
+</file>
+
+<file path=ppt/notesSlides/notesSlide8.xml><?xml version="1.0" encoding="utf-8"?>
+<p:notes xmlns:a="http://schemas.openxmlformats.org/drawingml/2006/main" xmlns:p="http://schemas.openxmlformats.org/presentationml/2006/main" xmlns:r="http://schemas.openxmlformats.org/officeDocument/2006/relationships">
+  <p:cSld>
+    <p:spTree>
+      <p:nvGrpSpPr>
+        <p:cNvPr id="1" name=""/>
+        <p:cNvGrpSpPr/>
+        <p:nvPr/>
+      </p:nvGrpSpPr>
+      <p:grpSpPr>
+        <a:xfrm>
+          <a:off x="0" y="0"/>
+          <a:ext cx="0" cy="0"/>
+          <a:chOff x="0" y="0"/>
+          <a:chExt cx="0" cy="0"/>
+        </a:xfrm>
+      </p:grpSpPr>
+      <p:sp>
+        <p:nvSpPr>
+          <p:cNvPr id="2" name="Slide Image Placeholder 1"/>
+          <p:cNvSpPr>
+            <a:spLocks noGrp="1"/>
+          </p:cNvSpPr>
+          <p:nvPr>
+            <p:ph type="sldImg" idx="2"/>
+          </p:nvPr>
+        </p:nvSpPr>
+        <p:spPr/>
+      </p:sp>
+      <p:sp>
+        <p:nvSpPr>
+          <p:cNvPr id="3" name="Notes Placeholder 2"/>
+          <p:cNvSpPr>
+            <a:spLocks noGrp="1"/>
+          </p:cNvSpPr>
+          <p:nvPr>
+            <p:ph type="body" idx="3" sz="quarter"/>
+          </p:nvPr>
+        </p:nvSpPr>
+        <p:spPr/>
+        <p:txBody>
+          <a:bodyPr/>
+          <a:lstStyle/>
+          <a:p>
+            <a:r>
+              <a:t>Numbers from real runs on 3 Oct 2026. CI is set up and runs after the next push; not claimed green yet.</a:t>
+            </a:r>
+          </a:p>
+        </p:txBody>
+      </p:sp>
+      <p:sp>
+        <p:nvSpPr>
+          <p:cNvPr id="4" name="Slide Number Placeholder 3"/>
+          <p:cNvSpPr>
+            <a:spLocks noGrp="1"/>
+          </p:cNvSpPr>
+          <p:nvPr>
+            <p:ph type="sldNum" idx="5" sz="quarter"/>
+          </p:nvPr>
+        </p:nvSpPr>
+        <p:spPr/>
+      </p:sp>
+    </p:spTree>
+  </p:cSld>
+  <p:clrMapOvr>
+    <a:masterClrMapping/>
+  </p:clrMapOvr>
+</p:notes>
+</file>
+
+<file path=ppt/notesSlides/notesSlide9.xml><?xml version="1.0" encoding="utf-8"?>
+<p:notes xmlns:a="http://schemas.openxmlformats.org/drawingml/2006/main" xmlns:p="http://schemas.openxmlformats.org/presentationml/2006/main" xmlns:r="http://schemas.openxmlformats.org/officeDocument/2006/relationships">
+  <p:cSld>
+    <p:spTree>
+      <p:nvGrpSpPr>
+        <p:cNvPr id="1" name=""/>
+        <p:cNvGrpSpPr/>
+        <p:nvPr/>
+      </p:nvGrpSpPr>
+      <p:grpSpPr>
+        <a:xfrm>
+          <a:off x="0" y="0"/>
+          <a:ext cx="0" cy="0"/>
+          <a:chOff x="0" y="0"/>
+          <a:chExt cx="0" cy="0"/>
+        </a:xfrm>
+      </p:grpSpPr>
+      <p:sp>
+        <p:nvSpPr>
+          <p:cNvPr id="2" name="Slide Image Placeholder 1"/>
+          <p:cNvSpPr>
+            <a:spLocks noGrp="1"/>
+          </p:cNvSpPr>
+          <p:nvPr>
+            <p:ph type="sldImg" idx="2"/>
+          </p:nvPr>
+        </p:nvSpPr>
+        <p:spPr/>
+      </p:sp>
+      <p:sp>
+        <p:nvSpPr>
+          <p:cNvPr id="3" name="Notes Placeholder 2"/>
+          <p:cNvSpPr>
+            <a:spLocks noGrp="1"/>
+          </p:cNvSpPr>
+          <p:nvPr>
+            <p:ph type="body" idx="3" sz="quarter"/>
+          </p:nvPr>
+        </p:nvSpPr>
+        <p:spPr/>
+        <p:txBody>
+          <a:bodyPr/>
+          <a:lstStyle/>
+          <a:p>
+            <a:r>
+              <a:t>DRIFT's core (the quant engine, the cockpit and `MacroGuard.sol`) comes from the upstream DRIFT project, built for a Mantle hackathon track ("AI Trading &amp; Strategy", June 2026) and migrated to BNB Chain in `bcc-ukdw/seed-bnb` (commit `52671ce`, 29 Sep 2026). Dex Bennett's contribution in this fork: the MacroGuard transparency panel (`/dashboard/macroguard` and the public `/macroguard`), the read-only `/guard/state` API, contract reads straight from the browser over a public RPC (no engine needed), an "Ask the contract" what-if that simulates `recordDecision` with `eth_call` (nothing signed), a labelled Binance public-data fallback for the engine, honest copy corrections, a self-owned MacroGuard deployment with an on-chain smoke test (30 Sep 2026), source verification on Sourcify, contract fuzz and invariant tests, an offline engine test suite, CI, a threat model, the judge-facing landing page and visual system, the PRD and the pitch deck.</a:t>
             </a:r>
           </a:p>
         </p:txBody>
@@ -3538,12 +4172,15 @@
           <a:noFill/>
         </p:spPr>
         <p:txBody>
-          <a:bodyPr wrap="none">
+          <a:bodyPr wrap="square">
             <a:spAutoFit/>
           </a:bodyPr>
           <a:lstStyle/>
           <a:p>
             <a:pPr>
+              <a:spcAft>
+                <a:spcPts val="2100"/>
+              </a:spcAft>
               <a:defRPr sz="6000" b="1">
                 <a:solidFill>
                   <a:srgbClr val="F0B90B"/>
@@ -3574,12 +4211,15 @@
           <a:noFill/>
         </p:spPr>
         <p:txBody>
-          <a:bodyPr wrap="none">
+          <a:bodyPr wrap="square">
             <a:spAutoFit/>
           </a:bodyPr>
           <a:lstStyle/>
           <a:p>
             <a:pPr>
+              <a:spcAft>
+                <a:spcPts val="1189"/>
+              </a:spcAft>
               <a:defRPr sz="3400" b="1">
                 <a:solidFill>
                   <a:srgbClr val="F4F5F8"/>
@@ -3610,12 +4250,15 @@
           <a:noFill/>
         </p:spPr>
         <p:txBody>
-          <a:bodyPr wrap="none">
+          <a:bodyPr wrap="square">
             <a:spAutoFit/>
           </a:bodyPr>
           <a:lstStyle/>
           <a:p>
             <a:pPr>
+              <a:spcAft>
+                <a:spcPts val="769"/>
+              </a:spcAft>
               <a:defRPr sz="2200" b="0">
                 <a:solidFill>
                   <a:srgbClr val="A6ABB8"/>
@@ -3637,7 +4280,7 @@
         </p:nvSpPr>
         <p:spPr>
           <a:xfrm>
-            <a:off x="640080" y="4846320"/>
+            <a:off x="640080" y="4206240"/>
             <a:ext cx="10881360" cy="457200"/>
           </a:xfrm>
           <a:prstGeom prst="rect">
@@ -3646,21 +4289,24 @@
           <a:noFill/>
         </p:spPr>
         <p:txBody>
-          <a:bodyPr wrap="none">
+          <a:bodyPr wrap="square">
             <a:spAutoFit/>
           </a:bodyPr>
           <a:lstStyle/>
           <a:p>
             <a:pPr>
-              <a:defRPr sz="1600" b="0">
-                <a:solidFill>
-                  <a:srgbClr val="F0B90B"/>
-                </a:solidFill>
-                <a:latin typeface="Calibri"/>
-              </a:defRPr>
-            </a:pPr>
-            <a:r>
-              <a:t>Dex contract: 0x8b09ebB85Be8Ed55Bb5132d29eABc567c42aa83D</a:t>
+              <a:spcAft>
+                <a:spcPts val="630"/>
+              </a:spcAft>
+              <a:defRPr sz="1800" b="0">
+                <a:solidFill>
+                  <a:srgbClr val="F4F5F8"/>
+                </a:solidFill>
+                <a:latin typeface="Calibri"/>
+              </a:defRPr>
+            </a:pPr>
+            <a:r>
+              <a:t>Live: drift-macroguard.vercel.app/macroguard</a:t>
             </a:r>
           </a:p>
         </p:txBody>
@@ -3673,6 +4319,45 @@
         </p:nvSpPr>
         <p:spPr>
           <a:xfrm>
+            <a:off x="640080" y="4754880"/>
+            <a:ext cx="10881360" cy="457200"/>
+          </a:xfrm>
+          <a:prstGeom prst="rect">
+            <a:avLst/>
+          </a:prstGeom>
+          <a:noFill/>
+        </p:spPr>
+        <p:txBody>
+          <a:bodyPr wrap="square">
+            <a:spAutoFit/>
+          </a:bodyPr>
+          <a:lstStyle/>
+          <a:p>
+            <a:pPr>
+              <a:spcAft>
+                <a:spcPts val="560"/>
+              </a:spcAft>
+              <a:defRPr sz="1600" b="0">
+                <a:solidFill>
+                  <a:srgbClr val="F0B90B"/>
+                </a:solidFill>
+                <a:latin typeface="Calibri"/>
+              </a:defRPr>
+            </a:pPr>
+            <a:r>
+              <a:t>Dex contract (BSC Testnet): 0x8b09ebB85Be8Ed55Bb5132d29eABc567c42aa83D</a:t>
+            </a:r>
+          </a:p>
+        </p:txBody>
+      </p:sp>
+      <p:sp>
+        <p:nvSpPr>
+          <p:cNvPr id="7" name="TextBox 6"/>
+          <p:cNvSpPr txBox="1"/>
+          <p:nvPr/>
+        </p:nvSpPr>
+        <p:spPr>
+          <a:xfrm>
             <a:off x="640080" y="5852160"/>
             <a:ext cx="10881360" cy="457200"/>
           </a:xfrm>
@@ -3682,12 +4367,15 @@
           <a:noFill/>
         </p:spPr>
         <p:txBody>
-          <a:bodyPr wrap="none">
+          <a:bodyPr wrap="square">
             <a:spAutoFit/>
           </a:bodyPr>
           <a:lstStyle/>
           <a:p>
             <a:pPr>
+              <a:spcAft>
+                <a:spcPts val="630"/>
+              </a:spcAft>
               <a:defRPr sz="1800" b="0">
                 <a:solidFill>
                   <a:srgbClr val="A6ABB8"/>
@@ -3696,7 +4384,356 @@
               </a:defRPr>
             </a:pPr>
             <a:r>
-              <a:t>BSC Testnet · Indonesia Web3 Hackathon 2026 · Dex Bennett</a:t>
+              <a:t>Indonesia Web3 Hackathon 2026 · Dex Bennett</a:t>
+            </a:r>
+          </a:p>
+        </p:txBody>
+      </p:sp>
+    </p:spTree>
+  </p:cSld>
+  <p:clrMapOvr>
+    <a:masterClrMapping/>
+  </p:clrMapOvr>
+</p:sld>
+</file>
+
+<file path=ppt/slides/slide10.xml><?xml version="1.0" encoding="utf-8"?>
+<p:sld xmlns:a="http://schemas.openxmlformats.org/drawingml/2006/main" xmlns:p="http://schemas.openxmlformats.org/presentationml/2006/main" xmlns:r="http://schemas.openxmlformats.org/officeDocument/2006/relationships">
+  <p:cSld>
+    <p:bg>
+      <p:bgPr>
+        <a:solidFill>
+          <a:srgbClr val="0B0C0F"/>
+        </a:solidFill>
+        <a:effectLst/>
+      </p:bgPr>
+    </p:bg>
+    <p:spTree>
+      <p:nvGrpSpPr>
+        <p:cNvPr id="1" name=""/>
+        <p:cNvGrpSpPr/>
+        <p:nvPr/>
+      </p:nvGrpSpPr>
+      <p:grpSpPr/>
+      <p:sp>
+        <p:nvSpPr>
+          <p:cNvPr id="2" name="TextBox 1"/>
+          <p:cNvSpPr txBox="1"/>
+          <p:nvPr/>
+        </p:nvSpPr>
+        <p:spPr>
+          <a:xfrm>
+            <a:off x="640080" y="365760"/>
+            <a:ext cx="10881360" cy="822960"/>
+          </a:xfrm>
+          <a:prstGeom prst="rect">
+            <a:avLst/>
+          </a:prstGeom>
+          <a:noFill/>
+        </p:spPr>
+        <p:txBody>
+          <a:bodyPr wrap="square">
+            <a:spAutoFit/>
+          </a:bodyPr>
+          <a:lstStyle/>
+          <a:p>
+            <a:pPr>
+              <a:spcAft>
+                <a:spcPts val="1260"/>
+              </a:spcAft>
+              <a:defRPr sz="3600" b="1">
+                <a:solidFill>
+                  <a:srgbClr val="F4F5F8"/>
+                </a:solidFill>
+                <a:latin typeface="Calibri"/>
+              </a:defRPr>
+            </a:pPr>
+            <a:r>
+              <a:t>Roadmap</a:t>
+            </a:r>
+          </a:p>
+        </p:txBody>
+      </p:sp>
+      <p:sp>
+        <p:nvSpPr>
+          <p:cNvPr id="3" name="TextBox 2"/>
+          <p:cNvSpPr txBox="1"/>
+          <p:nvPr/>
+        </p:nvSpPr>
+        <p:spPr>
+          <a:xfrm>
+            <a:off x="640080" y="1188720"/>
+            <a:ext cx="10881360" cy="457200"/>
+          </a:xfrm>
+          <a:prstGeom prst="rect">
+            <a:avLst/>
+          </a:prstGeom>
+          <a:noFill/>
+        </p:spPr>
+        <p:txBody>
+          <a:bodyPr wrap="square">
+            <a:spAutoFit/>
+          </a:bodyPr>
+          <a:lstStyle/>
+          <a:p>
+            <a:pPr>
+              <a:spcAft>
+                <a:spcPts val="525"/>
+              </a:spcAft>
+              <a:defRPr sz="1500" b="1">
+                <a:solidFill>
+                  <a:srgbClr val="E5BD71"/>
+                </a:solidFill>
+                <a:latin typeface="Calibri"/>
+              </a:defRPr>
+            </a:pPr>
+            <a:r>
+              <a:t>Not built yet; listed in order of trust gained per step</a:t>
+            </a:r>
+          </a:p>
+        </p:txBody>
+      </p:sp>
+      <p:sp>
+        <p:nvSpPr>
+          <p:cNvPr id="4" name="TextBox 3"/>
+          <p:cNvSpPr txBox="1"/>
+          <p:nvPr/>
+        </p:nvSpPr>
+        <p:spPr>
+          <a:xfrm>
+            <a:off x="640080" y="1828800"/>
+            <a:ext cx="5669280" cy="3840480"/>
+          </a:xfrm>
+          <a:prstGeom prst="rect">
+            <a:avLst/>
+          </a:prstGeom>
+          <a:noFill/>
+        </p:spPr>
+        <p:txBody>
+          <a:bodyPr wrap="square">
+            <a:spAutoFit/>
+          </a:bodyPr>
+          <a:lstStyle/>
+          <a:p>
+            <a:pPr>
+              <a:spcAft>
+                <a:spcPts val="630"/>
+              </a:spcAft>
+              <a:defRPr sz="1800" b="0">
+                <a:solidFill>
+                  <a:srgbClr val="F4F5F8"/>
+                </a:solidFill>
+                <a:latin typeface="Calibri"/>
+              </a:defRPr>
+            </a:pPr>
+            <a:r>
+              <a:t>Resume through a multisig or timelock</a:t>
+            </a:r>
+          </a:p>
+          <a:p>
+            <a:pPr>
+              <a:spcAft>
+                <a:spcPts val="630"/>
+              </a:spcAft>
+              <a:defRPr sz="1800" b="0">
+                <a:solidFill>
+                  <a:srgbClr val="F4F5F8"/>
+                </a:solidFill>
+                <a:latin typeface="Calibri"/>
+              </a:defRPr>
+            </a:pPr>
+            <a:r>
+              <a:t>Fail-closed mode for the runner</a:t>
+            </a:r>
+          </a:p>
+          <a:p>
+            <a:pPr>
+              <a:spcAft>
+                <a:spcPts val="630"/>
+              </a:spcAft>
+              <a:defRPr sz="1800" b="0">
+                <a:solidFill>
+                  <a:srgbClr val="F4F5F8"/>
+                </a:solidFill>
+                <a:latin typeface="Calibri"/>
+              </a:defRPr>
+            </a:pPr>
+            <a:r>
+              <a:t>Signed regime verdicts (EIP-712) with an input hash</a:t>
+            </a:r>
+          </a:p>
+          <a:p>
+            <a:pPr>
+              <a:spcAft>
+                <a:spcPts val="630"/>
+              </a:spcAft>
+              <a:defRPr sz="1800" b="0">
+                <a:solidFill>
+                  <a:srgbClr val="F4F5F8"/>
+                </a:solidFill>
+                <a:latin typeface="Calibri"/>
+              </a:defRPr>
+            </a:pPr>
+            <a:r>
+              <a:t>Attested equity, so the drawdown is not self-reported</a:t>
+            </a:r>
+          </a:p>
+          <a:p>
+            <a:pPr>
+              <a:spcAft>
+                <a:spcPts val="630"/>
+              </a:spcAft>
+              <a:defRPr sz="1800" b="0">
+                <a:solidFill>
+                  <a:srgbClr val="F4F5F8"/>
+                </a:solidFill>
+                <a:latin typeface="Calibri"/>
+              </a:defRPr>
+            </a:pPr>
+            <a:r>
+              <a:t>Record the raw signal plus a veto flag</a:t>
+            </a:r>
+          </a:p>
+          <a:p>
+            <a:pPr>
+              <a:spcAft>
+                <a:spcPts val="630"/>
+              </a:spcAft>
+              <a:defRPr sz="1800" b="0">
+                <a:solidFill>
+                  <a:srgbClr val="F4F5F8"/>
+                </a:solidFill>
+                <a:latin typeface="Calibri"/>
+              </a:defRPr>
+            </a:pPr>
+            <a:r>
+              <a:t>Agent identity (ERC-8004), then mainnet after an audit</a:t>
+            </a:r>
+          </a:p>
+        </p:txBody>
+      </p:sp>
+      <p:sp>
+        <p:nvSpPr>
+          <p:cNvPr id="5" name="TextBox 4"/>
+          <p:cNvSpPr txBox="1"/>
+          <p:nvPr/>
+        </p:nvSpPr>
+        <p:spPr>
+          <a:xfrm>
+            <a:off x="6766560" y="1828800"/>
+            <a:ext cx="4754880" cy="548640"/>
+          </a:xfrm>
+          <a:prstGeom prst="rect">
+            <a:avLst/>
+          </a:prstGeom>
+          <a:noFill/>
+        </p:spPr>
+        <p:txBody>
+          <a:bodyPr wrap="square">
+            <a:spAutoFit/>
+          </a:bodyPr>
+          <a:lstStyle/>
+          <a:p>
+            <a:pPr>
+              <a:spcAft>
+                <a:spcPts val="839"/>
+              </a:spcAft>
+              <a:defRPr sz="2400" b="1">
+                <a:solidFill>
+                  <a:srgbClr val="F0B90B"/>
+                </a:solidFill>
+                <a:latin typeface="Calibri"/>
+              </a:defRPr>
+            </a:pPr>
+            <a:r>
+              <a:t>Check it yourself</a:t>
+            </a:r>
+          </a:p>
+        </p:txBody>
+      </p:sp>
+      <p:sp>
+        <p:nvSpPr>
+          <p:cNvPr id="6" name="TextBox 5"/>
+          <p:cNvSpPr txBox="1"/>
+          <p:nvPr/>
+        </p:nvSpPr>
+        <p:spPr>
+          <a:xfrm>
+            <a:off x="6766560" y="2560320"/>
+            <a:ext cx="4754880" cy="2743200"/>
+          </a:xfrm>
+          <a:prstGeom prst="rect">
+            <a:avLst/>
+          </a:prstGeom>
+          <a:noFill/>
+        </p:spPr>
+        <p:txBody>
+          <a:bodyPr wrap="square">
+            <a:spAutoFit/>
+          </a:bodyPr>
+          <a:lstStyle/>
+          <a:p>
+            <a:pPr>
+              <a:spcAft>
+                <a:spcPts val="560"/>
+              </a:spcAft>
+              <a:defRPr sz="1600" b="0">
+                <a:solidFill>
+                  <a:srgbClr val="F4F5F8"/>
+                </a:solidFill>
+                <a:latin typeface="Calibri"/>
+              </a:defRPr>
+            </a:pPr>
+            <a:r>
+              <a:t>drift-macroguard.vercel.app/macroguard</a:t>
+            </a:r>
+          </a:p>
+          <a:p>
+            <a:pPr>
+              <a:spcAft>
+                <a:spcPts val="560"/>
+              </a:spcAft>
+              <a:defRPr sz="1600" b="0">
+                <a:solidFill>
+                  <a:srgbClr val="F4F5F8"/>
+                </a:solidFill>
+                <a:latin typeface="Calibri"/>
+              </a:defRPr>
+            </a:pPr>
+            <a:r>
+              <a:t>github.com/Stylenecy/seed-bnb/tree/dex/drift/drift</a:t>
+            </a:r>
+          </a:p>
+          <a:p>
+            <a:pPr>
+              <a:spcAft>
+                <a:spcPts val="560"/>
+              </a:spcAft>
+              <a:defRPr sz="1600" b="0">
+                <a:solidFill>
+                  <a:srgbClr val="F4F5F8"/>
+                </a:solidFill>
+                <a:latin typeface="Calibri"/>
+              </a:defRPr>
+            </a:pPr>
+            <a:r>
+              <a:t>BscScan: 0x8b09ebB8…2aa83D</a:t>
+            </a:r>
+          </a:p>
+          <a:p>
+            <a:pPr>
+              <a:spcAft>
+                <a:spcPts val="560"/>
+              </a:spcAft>
+              <a:defRPr sz="1600" b="0">
+                <a:solidFill>
+                  <a:srgbClr val="F4F5F8"/>
+                </a:solidFill>
+                <a:latin typeface="Calibri"/>
+              </a:defRPr>
+            </a:pPr>
+            <a:r>
+              <a:t>Sourcify: repo.sourcify.dev/97/…</a:t>
             </a:r>
           </a:p>
         </p:txBody>
@@ -3744,13 +4781,16 @@
           <a:noFill/>
         </p:spPr>
         <p:txBody>
-          <a:bodyPr wrap="none">
+          <a:bodyPr wrap="square">
             <a:spAutoFit/>
           </a:bodyPr>
           <a:lstStyle/>
           <a:p>
             <a:pPr>
-              <a:defRPr sz="4000" b="1">
+              <a:spcAft>
+                <a:spcPts val="1260"/>
+              </a:spcAft>
+              <a:defRPr sz="3600" b="1">
                 <a:solidFill>
                   <a:srgbClr val="F4F5F8"/>
                 </a:solidFill>
@@ -3780,12 +4820,15 @@
           <a:noFill/>
         </p:spPr>
         <p:txBody>
-          <a:bodyPr wrap="none">
+          <a:bodyPr wrap="square">
             <a:spAutoFit/>
           </a:bodyPr>
           <a:lstStyle/>
           <a:p>
             <a:pPr>
+              <a:spcAft>
+                <a:spcPts val="839"/>
+              </a:spcAft>
               <a:defRPr sz="2400" b="0">
                 <a:solidFill>
                   <a:srgbClr val="F4F5F8"/>
@@ -3796,7 +4839,19 @@
             <a:r>
               <a:t>Trading bots ask users to trust risk rules nobody can see.</a:t>
             </a:r>
-            <a:br/>
+          </a:p>
+          <a:p>
+            <a:pPr>
+              <a:spcAft>
+                <a:spcPts val="839"/>
+              </a:spcAft>
+              <a:defRPr sz="2400" b="0">
+                <a:solidFill>
+                  <a:srgbClr val="F4F5F8"/>
+                </a:solidFill>
+                <a:latin typeface="Calibri"/>
+              </a:defRPr>
+            </a:pPr>
             <a:r>
               <a:t>Settings change silently; off-chain decision logs can be rewritten.</a:t>
             </a:r>
@@ -3820,12 +4875,15 @@
           <a:noFill/>
         </p:spPr>
         <p:txBody>
-          <a:bodyPr wrap="none">
+          <a:bodyPr wrap="square">
             <a:spAutoFit/>
           </a:bodyPr>
           <a:lstStyle/>
           <a:p>
             <a:pPr>
+              <a:spcAft>
+                <a:spcPts val="979"/>
+              </a:spcAft>
               <a:defRPr sz="2800" b="1">
                 <a:solidFill>
                   <a:srgbClr val="F0B90B"/>
@@ -3856,12 +4914,15 @@
           <a:noFill/>
         </p:spPr>
         <p:txBody>
-          <a:bodyPr wrap="none">
+          <a:bodyPr wrap="square">
             <a:spAutoFit/>
           </a:bodyPr>
           <a:lstStyle/>
           <a:p>
             <a:pPr>
+              <a:spcAft>
+                <a:spcPts val="839"/>
+              </a:spcAft>
               <a:defRPr sz="2400" b="0">
                 <a:solidFill>
                   <a:srgbClr val="F4F5F8"/>
@@ -3872,7 +4933,19 @@
             <a:r>
               <a:t>Anyone can check what DRIFT's bot is allowed to do right now,</a:t>
             </a:r>
-            <a:br/>
+          </a:p>
+          <a:p>
+            <a:pPr>
+              <a:spcAft>
+                <a:spcPts val="839"/>
+              </a:spcAft>
+              <a:defRPr sz="2400" b="0">
+                <a:solidFill>
+                  <a:srgbClr val="F4F5F8"/>
+                </a:solidFill>
+                <a:latin typeface="Calibri"/>
+              </a:defRPr>
+            </a:pPr>
             <a:r>
               <a:t>and every recorded decision is public on BscScan.</a:t>
             </a:r>
@@ -3922,13 +4995,16 @@
           <a:noFill/>
         </p:spPr>
         <p:txBody>
-          <a:bodyPr wrap="none">
+          <a:bodyPr wrap="square">
             <a:spAutoFit/>
           </a:bodyPr>
           <a:lstStyle/>
           <a:p>
             <a:pPr>
-              <a:defRPr sz="4000" b="1">
+              <a:spcAft>
+                <a:spcPts val="1260"/>
+              </a:spcAft>
+              <a:defRPr sz="3600" b="1">
                 <a:solidFill>
                   <a:srgbClr val="F4F5F8"/>
                 </a:solidFill>
@@ -3936,7 +5012,7 @@
               </a:defRPr>
             </a:pPr>
             <a:r>
-              <a:t>How DRIFT works</a:t>
+              <a:t>Who needs it, and how it could pay</a:t>
             </a:r>
           </a:p>
         </p:txBody>
@@ -3949,8 +5025,8 @@
         </p:nvSpPr>
         <p:spPr>
           <a:xfrm>
-            <a:off x="640080" y="1554480"/>
-            <a:ext cx="4754880" cy="640080"/>
+            <a:off x="640080" y="1234440"/>
+            <a:ext cx="10881360" cy="457200"/>
           </a:xfrm>
           <a:prstGeom prst="rect">
             <a:avLst/>
@@ -3958,21 +5034,24 @@
           <a:noFill/>
         </p:spPr>
         <p:txBody>
-          <a:bodyPr wrap="none">
+          <a:bodyPr wrap="square">
             <a:spAutoFit/>
           </a:bodyPr>
           <a:lstStyle/>
           <a:p>
             <a:pPr>
-              <a:defRPr sz="2600" b="1">
-                <a:solidFill>
-                  <a:srgbClr val="AEB9F4"/>
-                </a:solidFill>
-                <a:latin typeface="Calibri"/>
-              </a:defRPr>
-            </a:pPr>
-            <a:r>
-              <a:t>Off-chain: Python engine</a:t>
+              <a:spcAft>
+                <a:spcPts val="525"/>
+              </a:spcAft>
+              <a:defRPr sz="1500" b="1">
+                <a:solidFill>
+                  <a:srgbClr val="E5BD71"/>
+                </a:solidFill>
+                <a:latin typeface="Calibri"/>
+              </a:defRPr>
+            </a:pPr>
+            <a:r>
+              <a:t>HYPOTHESIS: not yet validated with users; no market figures claimed</a:t>
             </a:r>
           </a:p>
         </p:txBody>
@@ -3985,8 +5064,8 @@
         </p:nvSpPr>
         <p:spPr>
           <a:xfrm>
-            <a:off x="640080" y="2286000"/>
-            <a:ext cx="5029200" cy="1371600"/>
+            <a:off x="640080" y="1828800"/>
+            <a:ext cx="5120640" cy="548640"/>
           </a:xfrm>
           <a:prstGeom prst="rect">
             <a:avLst/>
@@ -3994,25 +5073,24 @@
           <a:noFill/>
         </p:spPr>
         <p:txBody>
-          <a:bodyPr wrap="none">
+          <a:bodyPr wrap="square">
             <a:spAutoFit/>
           </a:bodyPr>
           <a:lstStyle/>
           <a:p>
             <a:pPr>
-              <a:defRPr sz="2000" b="0">
-                <a:solidFill>
-                  <a:srgbClr val="F4F5F8"/>
-                </a:solidFill>
-                <a:latin typeface="Calibri"/>
-              </a:defRPr>
-            </a:pPr>
-            <a:r>
-              <a:t>Four strategies · point-in-time backtests</a:t>
-            </a:r>
-            <a:br/>
-            <a:r>
-              <a:t>Local drawdown stop · Bybit testnet execution</a:t>
+              <a:spcAft>
+                <a:spcPts val="839"/>
+              </a:spcAft>
+              <a:defRPr sz="2400" b="1">
+                <a:solidFill>
+                  <a:srgbClr val="AEB9F4"/>
+                </a:solidFill>
+                <a:latin typeface="Calibri"/>
+              </a:defRPr>
+            </a:pPr>
+            <a:r>
+              <a:t>Who needs it</a:t>
             </a:r>
           </a:p>
         </p:txBody>
@@ -4025,8 +5103,8 @@
         </p:nvSpPr>
         <p:spPr>
           <a:xfrm>
-            <a:off x="5669280" y="2103120"/>
-            <a:ext cx="731520" cy="914400"/>
+            <a:off x="640080" y="2468880"/>
+            <a:ext cx="5120640" cy="3291840"/>
           </a:xfrm>
           <a:prstGeom prst="rect">
             <a:avLst/>
@@ -4034,21 +5112,56 @@
           <a:noFill/>
         </p:spPr>
         <p:txBody>
-          <a:bodyPr wrap="none">
+          <a:bodyPr wrap="square">
             <a:spAutoFit/>
           </a:bodyPr>
           <a:lstStyle/>
           <a:p>
             <a:pPr>
-              <a:defRPr sz="4400" b="0">
-                <a:solidFill>
-                  <a:srgbClr val="A6ABB8"/>
-                </a:solidFill>
-                <a:latin typeface="Calibri"/>
-              </a:defRPr>
-            </a:pPr>
-            <a:r>
-              <a:t>→</a:t>
+              <a:spcAft>
+                <a:spcPts val="630"/>
+              </a:spcAft>
+              <a:defRPr sz="1800" b="0">
+                <a:solidFill>
+                  <a:srgbClr val="F4F5F8"/>
+                </a:solidFill>
+                <a:latin typeface="Calibri"/>
+              </a:defRPr>
+            </a:pPr>
+            <a:r>
+              <a:t>Retail traders who follow or rent bots: proof that the risk stop is real</a:t>
+            </a:r>
+          </a:p>
+          <a:p>
+            <a:pPr>
+              <a:spcAft>
+                <a:spcPts val="630"/>
+              </a:spcAft>
+              <a:defRPr sz="1800" b="0">
+                <a:solidFill>
+                  <a:srgbClr val="F4F5F8"/>
+                </a:solidFill>
+                <a:latin typeface="Calibri"/>
+              </a:defRPr>
+            </a:pPr>
+            <a:r>
+              <a:t>Bot builders and signal sellers: a record of discipline a screenshot cannot fake</a:t>
+            </a:r>
+          </a:p>
+          <a:p>
+            <a:pPr>
+              <a:spcAft>
+                <a:spcPts val="630"/>
+              </a:spcAft>
+              <a:defRPr sz="1800" b="0">
+                <a:solidFill>
+                  <a:srgbClr val="F4F5F8"/>
+                </a:solidFill>
+                <a:latin typeface="Calibri"/>
+              </a:defRPr>
+            </a:pPr>
+            <a:r>
+              <a:t>Communities and auditors: check a bot's rules without trusting its operator</a:t>
             </a:r>
           </a:p>
         </p:txBody>
@@ -4061,8 +5174,8 @@
         </p:nvSpPr>
         <p:spPr>
           <a:xfrm>
-            <a:off x="6492240" y="1554480"/>
-            <a:ext cx="5029200" cy="822960"/>
+            <a:off x="6309360" y="1828800"/>
+            <a:ext cx="5212080" cy="548640"/>
           </a:xfrm>
           <a:prstGeom prst="rect">
             <a:avLst/>
@@ -4070,13 +5183,16 @@
           <a:noFill/>
         </p:spPr>
         <p:txBody>
-          <a:bodyPr wrap="none">
+          <a:bodyPr wrap="square">
             <a:spAutoFit/>
           </a:bodyPr>
           <a:lstStyle/>
           <a:p>
             <a:pPr>
-              <a:defRPr sz="2600" b="1">
+              <a:spcAft>
+                <a:spcPts val="839"/>
+              </a:spcAft>
+              <a:defRPr sz="2400" b="1">
                 <a:solidFill>
                   <a:srgbClr val="F0B90B"/>
                 </a:solidFill>
@@ -4084,7 +5200,7 @@
               </a:defRPr>
             </a:pPr>
             <a:r>
-              <a:t>On-chain: MacroGuard (BSC Testnet)</a:t>
+              <a:t>How it could pay</a:t>
             </a:r>
           </a:p>
         </p:txBody>
@@ -4097,8 +5213,8 @@
         </p:nvSpPr>
         <p:spPr>
           <a:xfrm>
-            <a:off x="6492240" y="2377440"/>
-            <a:ext cx="5029200" cy="1371600"/>
+            <a:off x="6309360" y="2468880"/>
+            <a:ext cx="5212080" cy="3291840"/>
           </a:xfrm>
           <a:prstGeom prst="rect">
             <a:avLst/>
@@ -4106,13 +5222,16 @@
           <a:noFill/>
         </p:spPr>
         <p:txBody>
-          <a:bodyPr wrap="none">
+          <a:bodyPr wrap="square">
             <a:spAutoFit/>
           </a:bodyPr>
           <a:lstStyle/>
           <a:p>
             <a:pPr>
-              <a:defRPr sz="2000" b="0">
+              <a:spcAft>
+                <a:spcPts val="630"/>
+              </a:spcAft>
+              <a:defRPr sz="1800" b="0">
                 <a:solidFill>
                   <a:srgbClr val="F4F5F8"/>
                 </a:solidFill>
@@ -4120,47 +5239,39 @@
               </a:defRPr>
             </a:pPr>
             <a:r>
-              <a:t>allowed(signal) · regime · 20% drawdown halt</a:t>
-            </a:r>
-            <a:br/>
-            <a:r>
-              <a:t>recordDecision → public receipt</a:t>
-            </a:r>
-          </a:p>
-        </p:txBody>
-      </p:sp>
-      <p:sp>
-        <p:nvSpPr>
-          <p:cNvPr id="8" name="TextBox 7"/>
-          <p:cNvSpPr txBox="1"/>
-          <p:nvPr/>
-        </p:nvSpPr>
-        <p:spPr>
-          <a:xfrm>
-            <a:off x="640080" y="4389120"/>
-            <a:ext cx="10881360" cy="1097280"/>
-          </a:xfrm>
-          <a:prstGeom prst="rect">
-            <a:avLst/>
-          </a:prstGeom>
-          <a:noFill/>
-        </p:spPr>
-        <p:txBody>
-          <a:bodyPr wrap="none">
-            <a:spAutoFit/>
-          </a:bodyPr>
-          <a:lstStyle/>
-          <a:p>
-            <a:pPr>
-              <a:defRPr sz="2200" b="0">
-                <a:solidFill>
-                  <a:srgbClr val="A6ABB8"/>
-                </a:solidFill>
-                <a:latin typeface="Calibri"/>
-              </a:defRPr>
-            </a:pPr>
-            <a:r>
-              <a:t>The runner checks the public contract before orders. The contract does not control Bybit directly.</a:t>
+              <a:t>A risk gate per bot: its own MacroGuard plus a public panel, as a monthly service</a:t>
+            </a:r>
+          </a:p>
+          <a:p>
+            <a:pPr>
+              <a:spcAft>
+                <a:spcPts val="630"/>
+              </a:spcAft>
+              <a:defRPr sz="1800" b="0">
+                <a:solidFill>
+                  <a:srgbClr val="F4F5F8"/>
+                </a:solidFill>
+                <a:latin typeface="Calibri"/>
+              </a:defRPr>
+            </a:pPr>
+            <a:r>
+              <a:t>The panel link as a trust badge for strategy sellers</a:t>
+            </a:r>
+          </a:p>
+          <a:p>
+            <a:pPr>
+              <a:spcAft>
+                <a:spcPts val="630"/>
+              </a:spcAft>
+              <a:defRPr sz="1800" b="0">
+                <a:solidFill>
+                  <a:srgbClr val="F4F5F8"/>
+                </a:solidFill>
+                <a:latin typeface="Calibri"/>
+              </a:defRPr>
+            </a:pPr>
+            <a:r>
+              <a:t>No custody and no performance fee; on-chain cost per decision stays tiny (next slides)</a:t>
             </a:r>
           </a:p>
         </p:txBody>
@@ -4199,8 +5310,8 @@
         </p:nvSpPr>
         <p:spPr>
           <a:xfrm>
-            <a:off x="640080" y="274320"/>
-            <a:ext cx="10881360" cy="731520"/>
+            <a:off x="640080" y="365760"/>
+            <a:ext cx="10881360" cy="822960"/>
           </a:xfrm>
           <a:prstGeom prst="rect">
             <a:avLst/>
@@ -4208,13 +5319,16 @@
           <a:noFill/>
         </p:spPr>
         <p:txBody>
-          <a:bodyPr wrap="none">
+          <a:bodyPr wrap="square">
             <a:spAutoFit/>
           </a:bodyPr>
           <a:lstStyle/>
           <a:p>
             <a:pPr>
-              <a:defRPr sz="3000" b="1">
+              <a:spcAft>
+                <a:spcPts val="1260"/>
+              </a:spcAft>
+              <a:defRPr sz="3600" b="1">
                 <a:solidFill>
                   <a:srgbClr val="F4F5F8"/>
                 </a:solidFill>
@@ -4222,35 +5336,50 @@
               </a:defRPr>
             </a:pPr>
             <a:r>
-              <a:t>The MacroGuard panel — public, no login, no wallet</a:t>
-            </a:r>
-          </a:p>
-        </p:txBody>
-      </p:sp>
-      <p:pic>
-        <p:nvPicPr>
-          <p:cNvPr id="3" name="Picture 2" descr="public-guard-desktop.png"/>
-          <p:cNvPicPr>
-            <a:picLocks noChangeAspect="1"/>
-          </p:cNvPicPr>
+              <a:t>How DRIFT works</a:t>
+            </a:r>
+          </a:p>
+        </p:txBody>
+      </p:sp>
+      <p:sp>
+        <p:nvSpPr>
+          <p:cNvPr id="3" name="TextBox 2"/>
+          <p:cNvSpPr txBox="1"/>
           <p:nvPr/>
-        </p:nvPicPr>
-        <p:blipFill>
-          <a:blip r:embed="rId2"/>
-          <a:stretch>
-            <a:fillRect/>
-          </a:stretch>
-        </p:blipFill>
-        <p:spPr>
-          <a:xfrm>
-            <a:off x="640080" y="1097280"/>
-            <a:ext cx="6949440" cy="4343400"/>
-          </a:xfrm>
-          <a:prstGeom prst="rect">
-            <a:avLst/>
-          </a:prstGeom>
-        </p:spPr>
-      </p:pic>
+        </p:nvSpPr>
+        <p:spPr>
+          <a:xfrm>
+            <a:off x="640080" y="1463040"/>
+            <a:ext cx="2926080" cy="548640"/>
+          </a:xfrm>
+          <a:prstGeom prst="rect">
+            <a:avLst/>
+          </a:prstGeom>
+          <a:noFill/>
+        </p:spPr>
+        <p:txBody>
+          <a:bodyPr wrap="square">
+            <a:spAutoFit/>
+          </a:bodyPr>
+          <a:lstStyle/>
+          <a:p>
+            <a:pPr>
+              <a:spcAft>
+                <a:spcPts val="839"/>
+              </a:spcAft>
+              <a:defRPr sz="2400" b="1">
+                <a:solidFill>
+                  <a:srgbClr val="AEB9F4"/>
+                </a:solidFill>
+                <a:latin typeface="Calibri"/>
+              </a:defRPr>
+            </a:pPr>
+            <a:r>
+              <a:t>1  Signal</a:t>
+            </a:r>
+          </a:p>
+        </p:txBody>
+      </p:sp>
       <p:sp>
         <p:nvSpPr>
           <p:cNvPr id="4" name="TextBox 3"/>
@@ -4259,8 +5388,8 @@
         </p:nvSpPr>
         <p:spPr>
           <a:xfrm>
-            <a:off x="7863840" y="1188720"/>
-            <a:ext cx="3840480" cy="4389120"/>
+            <a:off x="3657600" y="1508760"/>
+            <a:ext cx="7863840" cy="822960"/>
           </a:xfrm>
           <a:prstGeom prst="rect">
             <a:avLst/>
@@ -4268,13 +5397,16 @@
           <a:noFill/>
         </p:spPr>
         <p:txBody>
-          <a:bodyPr wrap="none">
+          <a:bodyPr wrap="square">
             <a:spAutoFit/>
           </a:bodyPr>
           <a:lstStyle/>
           <a:p>
             <a:pPr>
-              <a:defRPr sz="1700" b="0">
+              <a:spcAft>
+                <a:spcPts val="700"/>
+              </a:spcAft>
+              <a:defRPr sz="2000" b="0">
                 <a:solidFill>
                   <a:srgbClr val="F4F5F8"/>
                 </a:solidFill>
@@ -4282,27 +5414,280 @@
               </a:defRPr>
             </a:pPr>
             <a:r>
-              <a:t>Live regime and halt state</a:t>
-            </a:r>
-            <a:br/>
-            <a:br/>
-            <a:r>
-              <a:t>Long / Short / Flat verdict with the reason</a:t>
-            </a:r>
-            <a:br/>
-            <a:br/>
-            <a:r>
-              <a:t>Contract, agent and threshold, each linked to BscScan</a:t>
-            </a:r>
-            <a:br/>
-            <a:br/>
-            <a:r>
-              <a:t>Dated trail of verified receipts</a:t>
-            </a:r>
-            <a:br/>
-            <a:br/>
-            <a:r>
-              <a:t>Honest offline state when the engine or RPC is down</a:t>
+              <a:t>Python engine: four strategies, point-in-time, no look-ahead</a:t>
+            </a:r>
+          </a:p>
+        </p:txBody>
+      </p:sp>
+      <p:sp>
+        <p:nvSpPr>
+          <p:cNvPr id="5" name="TextBox 4"/>
+          <p:cNvSpPr txBox="1"/>
+          <p:nvPr/>
+        </p:nvSpPr>
+        <p:spPr>
+          <a:xfrm>
+            <a:off x="640080" y="2514600"/>
+            <a:ext cx="2926080" cy="548640"/>
+          </a:xfrm>
+          <a:prstGeom prst="rect">
+            <a:avLst/>
+          </a:prstGeom>
+          <a:noFill/>
+        </p:spPr>
+        <p:txBody>
+          <a:bodyPr wrap="square">
+            <a:spAutoFit/>
+          </a:bodyPr>
+          <a:lstStyle/>
+          <a:p>
+            <a:pPr>
+              <a:spcAft>
+                <a:spcPts val="839"/>
+              </a:spcAft>
+              <a:defRPr sz="2400" b="1">
+                <a:solidFill>
+                  <a:srgbClr val="F0B90B"/>
+                </a:solidFill>
+                <a:latin typeface="Calibri"/>
+              </a:defRPr>
+            </a:pPr>
+            <a:r>
+              <a:t>2  Ask the gate</a:t>
+            </a:r>
+          </a:p>
+        </p:txBody>
+      </p:sp>
+      <p:sp>
+        <p:nvSpPr>
+          <p:cNvPr id="6" name="TextBox 5"/>
+          <p:cNvSpPr txBox="1"/>
+          <p:nvPr/>
+        </p:nvSpPr>
+        <p:spPr>
+          <a:xfrm>
+            <a:off x="3657600" y="2560320"/>
+            <a:ext cx="7863840" cy="822960"/>
+          </a:xfrm>
+          <a:prstGeom prst="rect">
+            <a:avLst/>
+          </a:prstGeom>
+          <a:noFill/>
+        </p:spPr>
+        <p:txBody>
+          <a:bodyPr wrap="square">
+            <a:spAutoFit/>
+          </a:bodyPr>
+          <a:lstStyle/>
+          <a:p>
+            <a:pPr>
+              <a:spcAft>
+                <a:spcPts val="700"/>
+              </a:spcAft>
+              <a:defRPr sz="2000" b="0">
+                <a:solidFill>
+                  <a:srgbClr val="F4F5F8"/>
+                </a:solidFill>
+                <a:latin typeface="Calibri"/>
+              </a:defRPr>
+            </a:pPr>
+            <a:r>
+              <a:t>MacroGuard.allowed(signal) on BSC Testnet: regime + 20% halt</a:t>
+            </a:r>
+          </a:p>
+        </p:txBody>
+      </p:sp>
+      <p:sp>
+        <p:nvSpPr>
+          <p:cNvPr id="7" name="TextBox 6"/>
+          <p:cNvSpPr txBox="1"/>
+          <p:nvPr/>
+        </p:nvSpPr>
+        <p:spPr>
+          <a:xfrm>
+            <a:off x="640080" y="3566160"/>
+            <a:ext cx="2926080" cy="548640"/>
+          </a:xfrm>
+          <a:prstGeom prst="rect">
+            <a:avLst/>
+          </a:prstGeom>
+          <a:noFill/>
+        </p:spPr>
+        <p:txBody>
+          <a:bodyPr wrap="square">
+            <a:spAutoFit/>
+          </a:bodyPr>
+          <a:lstStyle/>
+          <a:p>
+            <a:pPr>
+              <a:spcAft>
+                <a:spcPts val="839"/>
+              </a:spcAft>
+              <a:defRPr sz="2400" b="1">
+                <a:solidFill>
+                  <a:srgbClr val="AEB9F4"/>
+                </a:solidFill>
+                <a:latin typeface="Calibri"/>
+              </a:defRPr>
+            </a:pPr>
+            <a:r>
+              <a:t>3  Trade</a:t>
+            </a:r>
+          </a:p>
+        </p:txBody>
+      </p:sp>
+      <p:sp>
+        <p:nvSpPr>
+          <p:cNvPr id="8" name="TextBox 7"/>
+          <p:cNvSpPr txBox="1"/>
+          <p:nvPr/>
+        </p:nvSpPr>
+        <p:spPr>
+          <a:xfrm>
+            <a:off x="3657600" y="3611879"/>
+            <a:ext cx="7863840" cy="822960"/>
+          </a:xfrm>
+          <a:prstGeom prst="rect">
+            <a:avLst/>
+          </a:prstGeom>
+          <a:noFill/>
+        </p:spPr>
+        <p:txBody>
+          <a:bodyPr wrap="square">
+            <a:spAutoFit/>
+          </a:bodyPr>
+          <a:lstStyle/>
+          <a:p>
+            <a:pPr>
+              <a:spcAft>
+                <a:spcPts val="700"/>
+              </a:spcAft>
+              <a:defRPr sz="2000" b="0">
+                <a:solidFill>
+                  <a:srgbClr val="F4F5F8"/>
+                </a:solidFill>
+                <a:latin typeface="Calibri"/>
+              </a:defRPr>
+            </a:pPr>
+            <a:r>
+              <a:t>Runner places the order on Bybit testnet (vetoed signals go Flat)</a:t>
+            </a:r>
+          </a:p>
+        </p:txBody>
+      </p:sp>
+      <p:sp>
+        <p:nvSpPr>
+          <p:cNvPr id="9" name="TextBox 8"/>
+          <p:cNvSpPr txBox="1"/>
+          <p:nvPr/>
+        </p:nvSpPr>
+        <p:spPr>
+          <a:xfrm>
+            <a:off x="640080" y="4617720"/>
+            <a:ext cx="2926080" cy="548640"/>
+          </a:xfrm>
+          <a:prstGeom prst="rect">
+            <a:avLst/>
+          </a:prstGeom>
+          <a:noFill/>
+        </p:spPr>
+        <p:txBody>
+          <a:bodyPr wrap="square">
+            <a:spAutoFit/>
+          </a:bodyPr>
+          <a:lstStyle/>
+          <a:p>
+            <a:pPr>
+              <a:spcAft>
+                <a:spcPts val="839"/>
+              </a:spcAft>
+              <a:defRPr sz="2400" b="1">
+                <a:solidFill>
+                  <a:srgbClr val="F0B90B"/>
+                </a:solidFill>
+                <a:latin typeface="Calibri"/>
+              </a:defRPr>
+            </a:pPr>
+            <a:r>
+              <a:t>4  Record</a:t>
+            </a:r>
+          </a:p>
+        </p:txBody>
+      </p:sp>
+      <p:sp>
+        <p:nvSpPr>
+          <p:cNvPr id="10" name="TextBox 9"/>
+          <p:cNvSpPr txBox="1"/>
+          <p:nvPr/>
+        </p:nvSpPr>
+        <p:spPr>
+          <a:xfrm>
+            <a:off x="3657600" y="4663440"/>
+            <a:ext cx="7863840" cy="822960"/>
+          </a:xfrm>
+          <a:prstGeom prst="rect">
+            <a:avLst/>
+          </a:prstGeom>
+          <a:noFill/>
+        </p:spPr>
+        <p:txBody>
+          <a:bodyPr wrap="square">
+            <a:spAutoFit/>
+          </a:bodyPr>
+          <a:lstStyle/>
+          <a:p>
+            <a:pPr>
+              <a:spcAft>
+                <a:spcPts val="700"/>
+              </a:spcAft>
+              <a:defRPr sz="2000" b="0">
+                <a:solidFill>
+                  <a:srgbClr val="F4F5F8"/>
+                </a:solidFill>
+                <a:latin typeface="Calibri"/>
+              </a:defRPr>
+            </a:pPr>
+            <a:r>
+              <a:t>recordDecision(...) leaves a public receipt; a breach halts the contract</a:t>
+            </a:r>
+          </a:p>
+        </p:txBody>
+      </p:sp>
+      <p:sp>
+        <p:nvSpPr>
+          <p:cNvPr id="11" name="TextBox 10"/>
+          <p:cNvSpPr txBox="1"/>
+          <p:nvPr/>
+        </p:nvSpPr>
+        <p:spPr>
+          <a:xfrm>
+            <a:off x="640080" y="5760720"/>
+            <a:ext cx="10881360" cy="548640"/>
+          </a:xfrm>
+          <a:prstGeom prst="rect">
+            <a:avLst/>
+          </a:prstGeom>
+          <a:noFill/>
+        </p:spPr>
+        <p:txBody>
+          <a:bodyPr wrap="square">
+            <a:spAutoFit/>
+          </a:bodyPr>
+          <a:lstStyle/>
+          <a:p>
+            <a:pPr>
+              <a:spcAft>
+                <a:spcPts val="630"/>
+              </a:spcAft>
+              <a:defRPr sz="1800" b="0">
+                <a:solidFill>
+                  <a:srgbClr val="A6ABB8"/>
+                </a:solidFill>
+                <a:latin typeface="Calibri"/>
+              </a:defRPr>
+            </a:pPr>
+            <a:r>
+              <a:t>The contract never executes orders; it is the public rule and the public record.</a:t>
             </a:r>
           </a:p>
         </p:txBody>
@@ -4350,13 +5735,16 @@
           <a:noFill/>
         </p:spPr>
         <p:txBody>
-          <a:bodyPr wrap="none">
+          <a:bodyPr wrap="square">
             <a:spAutoFit/>
           </a:bodyPr>
           <a:lstStyle/>
           <a:p>
             <a:pPr>
-              <a:defRPr sz="4000" b="1">
+              <a:spcAft>
+                <a:spcPts val="1260"/>
+              </a:spcAft>
+              <a:defRPr sz="3600" b="1">
                 <a:solidFill>
                   <a:srgbClr val="F4F5F8"/>
                 </a:solidFill>
@@ -4364,95 +5752,59 @@
               </a:defRPr>
             </a:pPr>
             <a:r>
-              <a:t>What Dex added</a:t>
-            </a:r>
-          </a:p>
-        </p:txBody>
-      </p:sp>
-      <p:sp>
-        <p:nvSpPr>
-          <p:cNvPr id="3" name="TextBox 2"/>
-          <p:cNvSpPr txBox="1"/>
+              <a:t>The panel, and asking the contract</a:t>
+            </a:r>
+          </a:p>
+        </p:txBody>
+      </p:sp>
+      <p:pic>
+        <p:nvPicPr>
+          <p:cNvPr id="3" name="Picture 2" descr="public-guard-desktop.png"/>
+          <p:cNvPicPr>
+            <a:picLocks noChangeAspect="1"/>
+          </p:cNvPicPr>
           <p:nvPr/>
-        </p:nvSpPr>
-        <p:spPr>
-          <a:xfrm>
-            <a:off x="640080" y="1463040"/>
-            <a:ext cx="4754880" cy="640080"/>
-          </a:xfrm>
-          <a:prstGeom prst="rect">
-            <a:avLst/>
-          </a:prstGeom>
-          <a:noFill/>
-        </p:spPr>
-        <p:txBody>
-          <a:bodyPr wrap="none">
-            <a:spAutoFit/>
-          </a:bodyPr>
-          <a:lstStyle/>
-          <a:p>
-            <a:pPr>
-              <a:defRPr sz="2400" b="1">
-                <a:solidFill>
-                  <a:srgbClr val="A6ABB8"/>
-                </a:solidFill>
-                <a:latin typeface="Calibri"/>
-              </a:defRPr>
-            </a:pPr>
-            <a:r>
-              <a:t>Upstream DRIFT project</a:t>
-            </a:r>
-          </a:p>
-        </p:txBody>
-      </p:sp>
-      <p:sp>
-        <p:nvSpPr>
-          <p:cNvPr id="4" name="TextBox 3"/>
-          <p:cNvSpPr txBox="1"/>
+        </p:nvPicPr>
+        <p:blipFill>
+          <a:blip r:embed="rId3"/>
+          <a:stretch>
+            <a:fillRect/>
+          </a:stretch>
+        </p:blipFill>
+        <p:spPr>
+          <a:xfrm>
+            <a:off x="457200" y="1280160"/>
+            <a:ext cx="5577840" cy="3486150"/>
+          </a:xfrm>
+          <a:prstGeom prst="rect">
+            <a:avLst/>
+          </a:prstGeom>
+        </p:spPr>
+      </p:pic>
+      <p:pic>
+        <p:nvPicPr>
+          <p:cNvPr id="4" name="Picture 3" descr="ask-contract-desktop.png"/>
+          <p:cNvPicPr>
+            <a:picLocks noChangeAspect="1"/>
+          </p:cNvPicPr>
           <p:nvPr/>
-        </p:nvSpPr>
-        <p:spPr>
-          <a:xfrm>
-            <a:off x="640080" y="2194560"/>
-            <a:ext cx="5029200" cy="2560320"/>
-          </a:xfrm>
-          <a:prstGeom prst="rect">
-            <a:avLst/>
-          </a:prstGeom>
-          <a:noFill/>
-        </p:spPr>
-        <p:txBody>
-          <a:bodyPr wrap="none">
-            <a:spAutoFit/>
-          </a:bodyPr>
-          <a:lstStyle/>
-          <a:p>
-            <a:pPr>
-              <a:defRPr sz="2000" b="0">
-                <a:solidFill>
-                  <a:srgbClr val="F4F5F8"/>
-                </a:solidFill>
-                <a:latin typeface="Calibri"/>
-              </a:defRPr>
-            </a:pPr>
-            <a:r>
-              <a:t>Quant engine, cockpit and MacroGuard.sol</a:t>
-            </a:r>
-            <a:br/>
-            <a:r>
-              <a:t>Built for a Mantle hackathon track (June 2026)</a:t>
-            </a:r>
-            <a:br/>
-            <a:r>
-              <a:t>Migrated to BNB Chain in bcc-ukdw/seed-bnb</a:t>
-            </a:r>
-            <a:br/>
-            <a:r>
-              <a:t>(commit 52671ce, 29 Sep 2026)</a:t>
-            </a:r>
-          </a:p>
-        </p:txBody>
-      </p:sp>
+        </p:nvPicPr>
+        <p:blipFill>
+          <a:blip r:embed="rId4"/>
+          <a:stretch>
+            <a:fillRect/>
+          </a:stretch>
+        </p:blipFill>
+        <p:spPr>
+          <a:xfrm>
+            <a:off x="6217920" y="1280160"/>
+            <a:ext cx="5486400" cy="2704427"/>
+          </a:xfrm>
+          <a:prstGeom prst="rect">
+            <a:avLst/>
+          </a:prstGeom>
+        </p:spPr>
+      </p:pic>
       <p:sp>
         <p:nvSpPr>
           <p:cNvPr id="5" name="TextBox 4"/>
@@ -4461,8 +5813,8 @@
         </p:nvSpPr>
         <p:spPr>
           <a:xfrm>
-            <a:off x="6309360" y="1463040"/>
-            <a:ext cx="5212080" cy="640080"/>
+            <a:off x="457200" y="4937760"/>
+            <a:ext cx="5577840" cy="1280160"/>
           </a:xfrm>
           <a:prstGeom prst="rect">
             <a:avLst/>
@@ -4470,21 +5822,40 @@
           <a:noFill/>
         </p:spPr>
         <p:txBody>
-          <a:bodyPr wrap="none">
+          <a:bodyPr wrap="square">
             <a:spAutoFit/>
           </a:bodyPr>
           <a:lstStyle/>
           <a:p>
             <a:pPr>
-              <a:defRPr sz="2400" b="1">
-                <a:solidFill>
-                  <a:srgbClr val="F0B90B"/>
-                </a:solidFill>
-                <a:latin typeface="Calibri"/>
-              </a:defRPr>
-            </a:pPr>
-            <a:r>
-              <a:t>Dex work</a:t>
+              <a:spcAft>
+                <a:spcPts val="560"/>
+              </a:spcAft>
+              <a:defRPr sz="1600" b="0">
+                <a:solidFill>
+                  <a:srgbClr val="A6ABB8"/>
+                </a:solidFill>
+                <a:latin typeface="Calibri"/>
+              </a:defRPr>
+            </a:pPr>
+            <a:r>
+              <a:t>Live regime, halt, 20% line and decisions,</a:t>
+            </a:r>
+          </a:p>
+          <a:p>
+            <a:pPr>
+              <a:spcAft>
+                <a:spcPts val="560"/>
+              </a:spcAft>
+              <a:defRPr sz="1600" b="0">
+                <a:solidFill>
+                  <a:srgbClr val="A6ABB8"/>
+                </a:solidFill>
+                <a:latin typeface="Calibri"/>
+              </a:defRPr>
+            </a:pPr>
+            <a:r>
+              <a:t>read from BSC Testnet at a named block</a:t>
             </a:r>
           </a:p>
         </p:txBody>
@@ -4497,8 +5868,8 @@
         </p:nvSpPr>
         <p:spPr>
           <a:xfrm>
-            <a:off x="6309360" y="2194560"/>
-            <a:ext cx="5212080" cy="2926080"/>
+            <a:off x="6217920" y="4937760"/>
+            <a:ext cx="5486400" cy="1280160"/>
           </a:xfrm>
           <a:prstGeom prst="rect">
             <a:avLst/>
@@ -4506,77 +5877,40 @@
           <a:noFill/>
         </p:spPr>
         <p:txBody>
-          <a:bodyPr wrap="none">
+          <a:bodyPr wrap="square">
             <a:spAutoFit/>
           </a:bodyPr>
           <a:lstStyle/>
           <a:p>
             <a:pPr>
-              <a:defRPr sz="2000" b="0">
-                <a:solidFill>
-                  <a:srgbClr val="F4F5F8"/>
-                </a:solidFill>
-                <a:latin typeface="Calibri"/>
-              </a:defRPr>
-            </a:pPr>
-            <a:r>
-              <a:t>Own BSC Testnet deploy (receipt status 1)</a:t>
-            </a:r>
-            <a:br/>
-            <a:r>
-              <a:t>Smoke test: RiskOff / halt / resume / Neutral</a:t>
-            </a:r>
-            <a:br/>
-            <a:r>
-              <a:t>Source verified on Sourcify (exact match)</a:t>
-            </a:r>
-            <a:br/>
-            <a:r>
-              <a:t>Read-only /guard/state API</a:t>
-            </a:r>
-            <a:br/>
-            <a:r>
-              <a:t>Transparency panel + public /macroguard</a:t>
-            </a:r>
-            <a:br/>
-            <a:r>
-              <a:t>Judge-facing landing and visual system</a:t>
-            </a:r>
-          </a:p>
-        </p:txBody>
-      </p:sp>
-      <p:sp>
-        <p:nvSpPr>
-          <p:cNvPr id="7" name="TextBox 6"/>
-          <p:cNvSpPr txBox="1"/>
-          <p:nvPr/>
-        </p:nvSpPr>
-        <p:spPr>
-          <a:xfrm>
-            <a:off x="640080" y="5394960"/>
-            <a:ext cx="10881360" cy="457200"/>
-          </a:xfrm>
-          <a:prstGeom prst="rect">
-            <a:avLst/>
-          </a:prstGeom>
-          <a:noFill/>
-        </p:spPr>
-        <p:txBody>
-          <a:bodyPr wrap="none">
-            <a:spAutoFit/>
-          </a:bodyPr>
-          <a:lstStyle/>
-          <a:p>
-            <a:pPr>
-              <a:defRPr sz="1800" b="0">
-                <a:solidFill>
-                  <a:srgbClr val="AEB9F4"/>
-                </a:solidFill>
-                <a:latin typeface="Calibri"/>
-              </a:defRPr>
-            </a:pPr>
-            <a:r>
-              <a:t>Code: github.com/Stylenecy/seed-bnb/tree/dex/drift</a:t>
+              <a:spcAft>
+                <a:spcPts val="560"/>
+              </a:spcAft>
+              <a:defRPr sz="1600" b="0">
+                <a:solidFill>
+                  <a:srgbClr val="A6ABB8"/>
+                </a:solidFill>
+                <a:latin typeface="Calibri"/>
+              </a:defRPr>
+            </a:pPr>
+            <a:r>
+              <a:t>Long at −25%: Blocked, answered by the live contract</a:t>
+            </a:r>
+          </a:p>
+          <a:p>
+            <a:pPr>
+              <a:spcAft>
+                <a:spcPts val="560"/>
+              </a:spcAft>
+              <a:defRPr sz="1600" b="0">
+                <a:solidFill>
+                  <a:srgbClr val="A6ABB8"/>
+                </a:solidFill>
+                <a:latin typeface="Calibri"/>
+              </a:defRPr>
+            </a:pPr>
+            <a:r>
+              <a:t>via eth_call from the agent address (simulation)</a:t>
             </a:r>
           </a:p>
         </p:txBody>
@@ -4624,13 +5958,16 @@
           <a:noFill/>
         </p:spPr>
         <p:txBody>
-          <a:bodyPr wrap="none">
+          <a:bodyPr wrap="square">
             <a:spAutoFit/>
           </a:bodyPr>
           <a:lstStyle/>
           <a:p>
             <a:pPr>
-              <a:defRPr sz="4000" b="1">
+              <a:spcAft>
+                <a:spcPts val="1260"/>
+              </a:spcAft>
+              <a:defRPr sz="3600" b="1">
                 <a:solidFill>
                   <a:srgbClr val="F4F5F8"/>
                 </a:solidFill>
@@ -4638,7 +5975,1071 @@
               </a:defRPr>
             </a:pPr>
             <a:r>
-              <a:t>Evidence and current limits</a:t>
+              <a:t>−25% recorded: the contract halted itself</a:t>
+            </a:r>
+          </a:p>
+        </p:txBody>
+      </p:sp>
+      <p:sp>
+        <p:nvSpPr>
+          <p:cNvPr id="3" name="Rectangle 2"/>
+          <p:cNvSpPr/>
+          <p:nvPr/>
+        </p:nvSpPr>
+        <p:spPr>
+          <a:xfrm>
+            <a:off x="822960" y="1874519"/>
+            <a:ext cx="7010400" cy="201168"/>
+          </a:xfrm>
+          <a:prstGeom prst="rect">
+            <a:avLst/>
+          </a:prstGeom>
+          <a:solidFill>
+            <a:srgbClr val="1F4D3B"/>
+          </a:solidFill>
+          <a:ln>
+            <a:noFill/>
+          </a:ln>
+        </p:spPr>
+        <p:style>
+          <a:lnRef idx="1">
+            <a:schemeClr val="accent1"/>
+          </a:lnRef>
+          <a:fillRef idx="3">
+            <a:schemeClr val="accent1"/>
+          </a:fillRef>
+          <a:effectRef idx="2">
+            <a:schemeClr val="accent1"/>
+          </a:effectRef>
+          <a:fontRef idx="minor">
+            <a:schemeClr val="lt1"/>
+          </a:fontRef>
+        </p:style>
+        <p:txBody>
+          <a:bodyPr rtlCol="0" anchor="ctr"/>
+          <a:lstStyle/>
+          <a:p>
+            <a:pPr algn="ctr"/>
+          </a:p>
+        </p:txBody>
+      </p:sp>
+      <p:sp>
+        <p:nvSpPr>
+          <p:cNvPr id="4" name="Rectangle 3"/>
+          <p:cNvSpPr/>
+          <p:nvPr/>
+        </p:nvSpPr>
+        <p:spPr>
+          <a:xfrm>
+            <a:off x="7833360" y="1874519"/>
+            <a:ext cx="3505200" cy="201168"/>
+          </a:xfrm>
+          <a:prstGeom prst="rect">
+            <a:avLst/>
+          </a:prstGeom>
+          <a:solidFill>
+            <a:srgbClr val="5A232D"/>
+          </a:solidFill>
+          <a:ln>
+            <a:noFill/>
+          </a:ln>
+        </p:spPr>
+        <p:style>
+          <a:lnRef idx="1">
+            <a:schemeClr val="accent1"/>
+          </a:lnRef>
+          <a:fillRef idx="3">
+            <a:schemeClr val="accent1"/>
+          </a:fillRef>
+          <a:effectRef idx="2">
+            <a:schemeClr val="accent1"/>
+          </a:effectRef>
+          <a:fontRef idx="minor">
+            <a:schemeClr val="lt1"/>
+          </a:fontRef>
+        </p:style>
+        <p:txBody>
+          <a:bodyPr rtlCol="0" anchor="ctr"/>
+          <a:lstStyle/>
+          <a:p>
+            <a:pPr algn="ctr"/>
+          </a:p>
+        </p:txBody>
+      </p:sp>
+      <p:sp>
+        <p:nvSpPr>
+          <p:cNvPr id="5" name="Rectangle 4"/>
+          <p:cNvSpPr/>
+          <p:nvPr/>
+        </p:nvSpPr>
+        <p:spPr>
+          <a:xfrm>
+            <a:off x="7815072" y="1645919"/>
+            <a:ext cx="45720" cy="658368"/>
+          </a:xfrm>
+          <a:prstGeom prst="rect">
+            <a:avLst/>
+          </a:prstGeom>
+          <a:solidFill>
+            <a:srgbClr val="F0B90B"/>
+          </a:solidFill>
+          <a:ln>
+            <a:noFill/>
+          </a:ln>
+        </p:spPr>
+        <p:style>
+          <a:lnRef idx="1">
+            <a:schemeClr val="accent1"/>
+          </a:lnRef>
+          <a:fillRef idx="3">
+            <a:schemeClr val="accent1"/>
+          </a:fillRef>
+          <a:effectRef idx="2">
+            <a:schemeClr val="accent1"/>
+          </a:effectRef>
+          <a:fontRef idx="minor">
+            <a:schemeClr val="lt1"/>
+          </a:fontRef>
+        </p:style>
+        <p:txBody>
+          <a:bodyPr rtlCol="0" anchor="ctr"/>
+          <a:lstStyle/>
+          <a:p>
+            <a:pPr algn="ctr"/>
+          </a:p>
+        </p:txBody>
+      </p:sp>
+      <p:sp>
+        <p:nvSpPr>
+          <p:cNvPr id="6" name="Oval 5"/>
+          <p:cNvSpPr/>
+          <p:nvPr/>
+        </p:nvSpPr>
+        <p:spPr>
+          <a:xfrm>
+            <a:off x="1018032" y="1819655"/>
+            <a:ext cx="310896" cy="310896"/>
+          </a:xfrm>
+          <a:prstGeom prst="ellipse">
+            <a:avLst/>
+          </a:prstGeom>
+          <a:solidFill>
+            <a:srgbClr val="78D5AB"/>
+          </a:solidFill>
+          <a:ln>
+            <a:noFill/>
+          </a:ln>
+        </p:spPr>
+        <p:style>
+          <a:lnRef idx="1">
+            <a:schemeClr val="accent1"/>
+          </a:lnRef>
+          <a:fillRef idx="3">
+            <a:schemeClr val="accent1"/>
+          </a:fillRef>
+          <a:effectRef idx="2">
+            <a:schemeClr val="accent1"/>
+          </a:effectRef>
+          <a:fontRef idx="minor">
+            <a:schemeClr val="lt1"/>
+          </a:fontRef>
+        </p:style>
+        <p:txBody>
+          <a:bodyPr rtlCol="0" anchor="ctr"/>
+          <a:lstStyle/>
+          <a:p>
+            <a:pPr algn="ctr"/>
+          </a:p>
+        </p:txBody>
+      </p:sp>
+      <p:sp>
+        <p:nvSpPr>
+          <p:cNvPr id="7" name="Oval 6"/>
+          <p:cNvSpPr/>
+          <p:nvPr/>
+        </p:nvSpPr>
+        <p:spPr>
+          <a:xfrm>
+            <a:off x="9430512" y="1819655"/>
+            <a:ext cx="310896" cy="310896"/>
+          </a:xfrm>
+          <a:prstGeom prst="ellipse">
+            <a:avLst/>
+          </a:prstGeom>
+          <a:solidFill>
+            <a:srgbClr val="FB7185"/>
+          </a:solidFill>
+          <a:ln>
+            <a:noFill/>
+          </a:ln>
+        </p:spPr>
+        <p:style>
+          <a:lnRef idx="1">
+            <a:schemeClr val="accent1"/>
+          </a:lnRef>
+          <a:fillRef idx="3">
+            <a:schemeClr val="accent1"/>
+          </a:fillRef>
+          <a:effectRef idx="2">
+            <a:schemeClr val="accent1"/>
+          </a:effectRef>
+          <a:fontRef idx="minor">
+            <a:schemeClr val="lt1"/>
+          </a:fontRef>
+        </p:style>
+        <p:txBody>
+          <a:bodyPr rtlCol="0" anchor="ctr"/>
+          <a:lstStyle/>
+          <a:p>
+            <a:pPr algn="ctr"/>
+          </a:p>
+        </p:txBody>
+      </p:sp>
+      <p:sp>
+        <p:nvSpPr>
+          <p:cNvPr id="8" name="TextBox 7"/>
+          <p:cNvSpPr txBox="1"/>
+          <p:nvPr/>
+        </p:nvSpPr>
+        <p:spPr>
+          <a:xfrm>
+            <a:off x="7010399" y="1188719"/>
+            <a:ext cx="2011680" cy="365760"/>
+          </a:xfrm>
+          <a:prstGeom prst="rect">
+            <a:avLst/>
+          </a:prstGeom>
+          <a:noFill/>
+        </p:spPr>
+        <p:txBody>
+          <a:bodyPr wrap="square">
+            <a:spAutoFit/>
+          </a:bodyPr>
+          <a:lstStyle/>
+          <a:p>
+            <a:pPr>
+              <a:spcAft>
+                <a:spcPts val="489"/>
+              </a:spcAft>
+              <a:defRPr sz="1400" b="1">
+                <a:solidFill>
+                  <a:srgbClr val="F0B90B"/>
+                </a:solidFill>
+                <a:latin typeface="Calibri"/>
+              </a:defRPr>
+            </a:pPr>
+            <a:r>
+              <a:t>halt line 20%</a:t>
+            </a:r>
+          </a:p>
+        </p:txBody>
+      </p:sp>
+      <p:sp>
+        <p:nvSpPr>
+          <p:cNvPr id="9" name="TextBox 8"/>
+          <p:cNvSpPr txBox="1"/>
+          <p:nvPr/>
+        </p:nvSpPr>
+        <p:spPr>
+          <a:xfrm>
+            <a:off x="731520" y="2194560"/>
+            <a:ext cx="2743200" cy="365760"/>
+          </a:xfrm>
+          <a:prstGeom prst="rect">
+            <a:avLst/>
+          </a:prstGeom>
+          <a:noFill/>
+        </p:spPr>
+        <p:txBody>
+          <a:bodyPr wrap="square">
+            <a:spAutoFit/>
+          </a:bodyPr>
+          <a:lstStyle/>
+          <a:p>
+            <a:pPr>
+              <a:spcAft>
+                <a:spcPts val="489"/>
+              </a:spcAft>
+              <a:defRPr sz="1400" b="0">
+                <a:solidFill>
+                  <a:srgbClr val="78D5AB"/>
+                </a:solidFill>
+                <a:latin typeface="Calibri"/>
+              </a:defRPr>
+            </a:pPr>
+            <a:r>
+              <a:t>−1%: kept running</a:t>
+            </a:r>
+          </a:p>
+        </p:txBody>
+      </p:sp>
+      <p:sp>
+        <p:nvSpPr>
+          <p:cNvPr id="10" name="TextBox 9"/>
+          <p:cNvSpPr txBox="1"/>
+          <p:nvPr/>
+        </p:nvSpPr>
+        <p:spPr>
+          <a:xfrm>
+            <a:off x="8122920" y="2194560"/>
+            <a:ext cx="3108960" cy="365760"/>
+          </a:xfrm>
+          <a:prstGeom prst="rect">
+            <a:avLst/>
+          </a:prstGeom>
+          <a:noFill/>
+        </p:spPr>
+        <p:txBody>
+          <a:bodyPr wrap="square">
+            <a:spAutoFit/>
+          </a:bodyPr>
+          <a:lstStyle/>
+          <a:p>
+            <a:pPr>
+              <a:spcAft>
+                <a:spcPts val="489"/>
+              </a:spcAft>
+              <a:defRPr sz="1400" b="0">
+                <a:solidFill>
+                  <a:srgbClr val="FB7185"/>
+                </a:solidFill>
+                <a:latin typeface="Calibri"/>
+              </a:defRPr>
+            </a:pPr>
+            <a:r>
+              <a:t>−25%: halted itself</a:t>
+            </a:r>
+          </a:p>
+        </p:txBody>
+      </p:sp>
+      <p:sp>
+        <p:nvSpPr>
+          <p:cNvPr id="11" name="TextBox 10"/>
+          <p:cNvSpPr txBox="1"/>
+          <p:nvPr/>
+        </p:nvSpPr>
+        <p:spPr>
+          <a:xfrm>
+            <a:off x="731520" y="2880360"/>
+            <a:ext cx="2103120" cy="457200"/>
+          </a:xfrm>
+          <a:prstGeom prst="rect">
+            <a:avLst/>
+          </a:prstGeom>
+          <a:noFill/>
+        </p:spPr>
+        <p:txBody>
+          <a:bodyPr wrap="square">
+            <a:spAutoFit/>
+          </a:bodyPr>
+          <a:lstStyle/>
+          <a:p>
+            <a:pPr>
+              <a:spcAft>
+                <a:spcPts val="594"/>
+              </a:spcAft>
+              <a:defRPr sz="1700" b="0">
+                <a:solidFill>
+                  <a:srgbClr val="F0B90B"/>
+                </a:solidFill>
+                <a:latin typeface="Calibri"/>
+              </a:defRPr>
+            </a:pPr>
+            <a:r>
+              <a:t>#134,042,196</a:t>
+            </a:r>
+          </a:p>
+        </p:txBody>
+      </p:sp>
+      <p:sp>
+        <p:nvSpPr>
+          <p:cNvPr id="12" name="TextBox 11"/>
+          <p:cNvSpPr txBox="1"/>
+          <p:nvPr/>
+        </p:nvSpPr>
+        <p:spPr>
+          <a:xfrm>
+            <a:off x="2926080" y="2880360"/>
+            <a:ext cx="4206240" cy="457200"/>
+          </a:xfrm>
+          <a:prstGeom prst="rect">
+            <a:avLst/>
+          </a:prstGeom>
+          <a:noFill/>
+        </p:spPr>
+        <p:txBody>
+          <a:bodyPr wrap="square">
+            <a:spAutoFit/>
+          </a:bodyPr>
+          <a:lstStyle/>
+          <a:p>
+            <a:pPr>
+              <a:spcAft>
+                <a:spcPts val="594"/>
+              </a:spcAft>
+              <a:defRPr sz="1700" b="0">
+                <a:solidFill>
+                  <a:srgbClr val="F4F5F8"/>
+                </a:solidFill>
+                <a:latin typeface="Calibri"/>
+              </a:defRPr>
+            </a:pPr>
+            <a:r>
+              <a:t>setRegime(RiskOff)</a:t>
+            </a:r>
+          </a:p>
+        </p:txBody>
+      </p:sp>
+      <p:sp>
+        <p:nvSpPr>
+          <p:cNvPr id="13" name="TextBox 12"/>
+          <p:cNvSpPr txBox="1"/>
+          <p:nvPr/>
+        </p:nvSpPr>
+        <p:spPr>
+          <a:xfrm>
+            <a:off x="7223760" y="2880360"/>
+            <a:ext cx="4389120" cy="457200"/>
+          </a:xfrm>
+          <a:prstGeom prst="rect">
+            <a:avLst/>
+          </a:prstGeom>
+          <a:noFill/>
+        </p:spPr>
+        <p:txBody>
+          <a:bodyPr wrap="square">
+            <a:spAutoFit/>
+          </a:bodyPr>
+          <a:lstStyle/>
+          <a:p>
+            <a:pPr>
+              <a:spcAft>
+                <a:spcPts val="594"/>
+              </a:spcAft>
+              <a:defRPr sz="1700" b="0">
+                <a:solidFill>
+                  <a:srgbClr val="A6ABB8"/>
+                </a:solidFill>
+                <a:latin typeface="Calibri"/>
+              </a:defRPr>
+            </a:pPr>
+            <a:r>
+              <a:t>Long blocked; Short and Flat open</a:t>
+            </a:r>
+          </a:p>
+        </p:txBody>
+      </p:sp>
+      <p:sp>
+        <p:nvSpPr>
+          <p:cNvPr id="14" name="TextBox 13"/>
+          <p:cNvSpPr txBox="1"/>
+          <p:nvPr/>
+        </p:nvSpPr>
+        <p:spPr>
+          <a:xfrm>
+            <a:off x="731520" y="3502152"/>
+            <a:ext cx="2103120" cy="457200"/>
+          </a:xfrm>
+          <a:prstGeom prst="rect">
+            <a:avLst/>
+          </a:prstGeom>
+          <a:noFill/>
+        </p:spPr>
+        <p:txBody>
+          <a:bodyPr wrap="square">
+            <a:spAutoFit/>
+          </a:bodyPr>
+          <a:lstStyle/>
+          <a:p>
+            <a:pPr>
+              <a:spcAft>
+                <a:spcPts val="594"/>
+              </a:spcAft>
+              <a:defRPr sz="1700" b="0">
+                <a:solidFill>
+                  <a:srgbClr val="F0B90B"/>
+                </a:solidFill>
+                <a:latin typeface="Calibri"/>
+              </a:defRPr>
+            </a:pPr>
+            <a:r>
+              <a:t>#134,042,256</a:t>
+            </a:r>
+          </a:p>
+        </p:txBody>
+      </p:sp>
+      <p:sp>
+        <p:nvSpPr>
+          <p:cNvPr id="15" name="TextBox 14"/>
+          <p:cNvSpPr txBox="1"/>
+          <p:nvPr/>
+        </p:nvSpPr>
+        <p:spPr>
+          <a:xfrm>
+            <a:off x="2926080" y="3502152"/>
+            <a:ext cx="4206240" cy="457200"/>
+          </a:xfrm>
+          <a:prstGeom prst="rect">
+            <a:avLst/>
+          </a:prstGeom>
+          <a:noFill/>
+        </p:spPr>
+        <p:txBody>
+          <a:bodyPr wrap="square">
+            <a:spAutoFit/>
+          </a:bodyPr>
+          <a:lstStyle/>
+          <a:p>
+            <a:pPr>
+              <a:spcAft>
+                <a:spcPts val="594"/>
+              </a:spcAft>
+              <a:defRPr sz="1700" b="0">
+                <a:solidFill>
+                  <a:srgbClr val="F4F5F8"/>
+                </a:solidFill>
+                <a:latin typeface="Calibri"/>
+              </a:defRPr>
+            </a:pPr>
+            <a:r>
+              <a:t>recordDecision(BNB, Short, −1%)</a:t>
+            </a:r>
+          </a:p>
+        </p:txBody>
+      </p:sp>
+      <p:sp>
+        <p:nvSpPr>
+          <p:cNvPr id="16" name="TextBox 15"/>
+          <p:cNvSpPr txBox="1"/>
+          <p:nvPr/>
+        </p:nvSpPr>
+        <p:spPr>
+          <a:xfrm>
+            <a:off x="7223760" y="3502152"/>
+            <a:ext cx="4389120" cy="457200"/>
+          </a:xfrm>
+          <a:prstGeom prst="rect">
+            <a:avLst/>
+          </a:prstGeom>
+          <a:noFill/>
+        </p:spPr>
+        <p:txBody>
+          <a:bodyPr wrap="square">
+            <a:spAutoFit/>
+          </a:bodyPr>
+          <a:lstStyle/>
+          <a:p>
+            <a:pPr>
+              <a:spcAft>
+                <a:spcPts val="594"/>
+              </a:spcAft>
+              <a:defRPr sz="1700" b="0">
+                <a:solidFill>
+                  <a:srgbClr val="78D5AB"/>
+                </a:solidFill>
+                <a:latin typeface="Calibri"/>
+              </a:defRPr>
+            </a:pPr>
+            <a:r>
+              <a:t>Decision #1, inside the line</a:t>
+            </a:r>
+          </a:p>
+        </p:txBody>
+      </p:sp>
+      <p:sp>
+        <p:nvSpPr>
+          <p:cNvPr id="17" name="Rectangle 16"/>
+          <p:cNvSpPr/>
+          <p:nvPr/>
+        </p:nvSpPr>
+        <p:spPr>
+          <a:xfrm>
+            <a:off x="548640" y="4078224"/>
+            <a:ext cx="11064240" cy="585216"/>
+          </a:xfrm>
+          <a:prstGeom prst="rect">
+            <a:avLst/>
+          </a:prstGeom>
+          <a:solidFill>
+            <a:srgbClr val="16171B"/>
+          </a:solidFill>
+          <a:ln>
+            <a:noFill/>
+          </a:ln>
+        </p:spPr>
+        <p:style>
+          <a:lnRef idx="1">
+            <a:schemeClr val="accent1"/>
+          </a:lnRef>
+          <a:fillRef idx="3">
+            <a:schemeClr val="accent1"/>
+          </a:fillRef>
+          <a:effectRef idx="2">
+            <a:schemeClr val="accent1"/>
+          </a:effectRef>
+          <a:fontRef idx="minor">
+            <a:schemeClr val="lt1"/>
+          </a:fontRef>
+        </p:style>
+        <p:txBody>
+          <a:bodyPr rtlCol="0" anchor="ctr"/>
+          <a:lstStyle/>
+          <a:p>
+            <a:pPr algn="ctr"/>
+          </a:p>
+        </p:txBody>
+      </p:sp>
+      <p:sp>
+        <p:nvSpPr>
+          <p:cNvPr id="18" name="TextBox 17"/>
+          <p:cNvSpPr txBox="1"/>
+          <p:nvPr/>
+        </p:nvSpPr>
+        <p:spPr>
+          <a:xfrm>
+            <a:off x="731520" y="4123944"/>
+            <a:ext cx="2103120" cy="457200"/>
+          </a:xfrm>
+          <a:prstGeom prst="rect">
+            <a:avLst/>
+          </a:prstGeom>
+          <a:noFill/>
+        </p:spPr>
+        <p:txBody>
+          <a:bodyPr wrap="square">
+            <a:spAutoFit/>
+          </a:bodyPr>
+          <a:lstStyle/>
+          <a:p>
+            <a:pPr>
+              <a:spcAft>
+                <a:spcPts val="594"/>
+              </a:spcAft>
+              <a:defRPr sz="1700" b="0">
+                <a:solidFill>
+                  <a:srgbClr val="F0B90B"/>
+                </a:solidFill>
+                <a:latin typeface="Calibri"/>
+              </a:defRPr>
+            </a:pPr>
+            <a:r>
+              <a:t>#134,042,283</a:t>
+            </a:r>
+          </a:p>
+        </p:txBody>
+      </p:sp>
+      <p:sp>
+        <p:nvSpPr>
+          <p:cNvPr id="19" name="TextBox 18"/>
+          <p:cNvSpPr txBox="1"/>
+          <p:nvPr/>
+        </p:nvSpPr>
+        <p:spPr>
+          <a:xfrm>
+            <a:off x="2926080" y="4123944"/>
+            <a:ext cx="4206240" cy="457200"/>
+          </a:xfrm>
+          <a:prstGeom prst="rect">
+            <a:avLst/>
+          </a:prstGeom>
+          <a:noFill/>
+        </p:spPr>
+        <p:txBody>
+          <a:bodyPr wrap="square">
+            <a:spAutoFit/>
+          </a:bodyPr>
+          <a:lstStyle/>
+          <a:p>
+            <a:pPr>
+              <a:spcAft>
+                <a:spcPts val="594"/>
+              </a:spcAft>
+              <a:defRPr sz="1700" b="1">
+                <a:solidFill>
+                  <a:srgbClr val="F4F5F8"/>
+                </a:solidFill>
+                <a:latin typeface="Calibri"/>
+              </a:defRPr>
+            </a:pPr>
+            <a:r>
+              <a:t>recordDecision(BNB, Short, −25%)</a:t>
+            </a:r>
+          </a:p>
+        </p:txBody>
+      </p:sp>
+      <p:sp>
+        <p:nvSpPr>
+          <p:cNvPr id="20" name="TextBox 19"/>
+          <p:cNvSpPr txBox="1"/>
+          <p:nvPr/>
+        </p:nvSpPr>
+        <p:spPr>
+          <a:xfrm>
+            <a:off x="7223760" y="4123944"/>
+            <a:ext cx="4389120" cy="457200"/>
+          </a:xfrm>
+          <a:prstGeom prst="rect">
+            <a:avLst/>
+          </a:prstGeom>
+          <a:noFill/>
+        </p:spPr>
+        <p:txBody>
+          <a:bodyPr wrap="square">
+            <a:spAutoFit/>
+          </a:bodyPr>
+          <a:lstStyle/>
+          <a:p>
+            <a:pPr>
+              <a:spcAft>
+                <a:spcPts val="594"/>
+              </a:spcAft>
+              <a:defRPr sz="1700" b="0">
+                <a:solidFill>
+                  <a:srgbClr val="FB7185"/>
+                </a:solidFill>
+                <a:latin typeface="Calibri"/>
+              </a:defRPr>
+            </a:pPr>
+            <a:r>
+              <a:t>Halted event: only Flat allowed</a:t>
+            </a:r>
+          </a:p>
+        </p:txBody>
+      </p:sp>
+      <p:sp>
+        <p:nvSpPr>
+          <p:cNvPr id="21" name="TextBox 20"/>
+          <p:cNvSpPr txBox="1"/>
+          <p:nvPr/>
+        </p:nvSpPr>
+        <p:spPr>
+          <a:xfrm>
+            <a:off x="731520" y="4745736"/>
+            <a:ext cx="2103120" cy="457200"/>
+          </a:xfrm>
+          <a:prstGeom prst="rect">
+            <a:avLst/>
+          </a:prstGeom>
+          <a:noFill/>
+        </p:spPr>
+        <p:txBody>
+          <a:bodyPr wrap="square">
+            <a:spAutoFit/>
+          </a:bodyPr>
+          <a:lstStyle/>
+          <a:p>
+            <a:pPr>
+              <a:spcAft>
+                <a:spcPts val="594"/>
+              </a:spcAft>
+              <a:defRPr sz="1700" b="0">
+                <a:solidFill>
+                  <a:srgbClr val="F0B90B"/>
+                </a:solidFill>
+                <a:latin typeface="Calibri"/>
+              </a:defRPr>
+            </a:pPr>
+            <a:r>
+              <a:t>#134,042,318</a:t>
+            </a:r>
+          </a:p>
+        </p:txBody>
+      </p:sp>
+      <p:sp>
+        <p:nvSpPr>
+          <p:cNvPr id="22" name="TextBox 21"/>
+          <p:cNvSpPr txBox="1"/>
+          <p:nvPr/>
+        </p:nvSpPr>
+        <p:spPr>
+          <a:xfrm>
+            <a:off x="2926080" y="4745736"/>
+            <a:ext cx="4206240" cy="457200"/>
+          </a:xfrm>
+          <a:prstGeom prst="rect">
+            <a:avLst/>
+          </a:prstGeom>
+          <a:noFill/>
+        </p:spPr>
+        <p:txBody>
+          <a:bodyPr wrap="square">
+            <a:spAutoFit/>
+          </a:bodyPr>
+          <a:lstStyle/>
+          <a:p>
+            <a:pPr>
+              <a:spcAft>
+                <a:spcPts val="594"/>
+              </a:spcAft>
+              <a:defRPr sz="1700" b="0">
+                <a:solidFill>
+                  <a:srgbClr val="F4F5F8"/>
+                </a:solidFill>
+                <a:latin typeface="Calibri"/>
+              </a:defRPr>
+            </a:pPr>
+            <a:r>
+              <a:t>resume()</a:t>
+            </a:r>
+          </a:p>
+        </p:txBody>
+      </p:sp>
+      <p:sp>
+        <p:nvSpPr>
+          <p:cNvPr id="23" name="TextBox 22"/>
+          <p:cNvSpPr txBox="1"/>
+          <p:nvPr/>
+        </p:nvSpPr>
+        <p:spPr>
+          <a:xfrm>
+            <a:off x="7223760" y="4745736"/>
+            <a:ext cx="4389120" cy="457200"/>
+          </a:xfrm>
+          <a:prstGeom prst="rect">
+            <a:avLst/>
+          </a:prstGeom>
+          <a:noFill/>
+        </p:spPr>
+        <p:txBody>
+          <a:bodyPr wrap="square">
+            <a:spAutoFit/>
+          </a:bodyPr>
+          <a:lstStyle/>
+          <a:p>
+            <a:pPr>
+              <a:spcAft>
+                <a:spcPts val="594"/>
+              </a:spcAft>
+              <a:defRPr sz="1700" b="0">
+                <a:solidFill>
+                  <a:srgbClr val="A6ABB8"/>
+                </a:solidFill>
+                <a:latin typeface="Calibri"/>
+              </a:defRPr>
+            </a:pPr>
+            <a:r>
+              <a:t>Agent-only, on the record</a:t>
+            </a:r>
+          </a:p>
+        </p:txBody>
+      </p:sp>
+      <p:sp>
+        <p:nvSpPr>
+          <p:cNvPr id="24" name="TextBox 23"/>
+          <p:cNvSpPr txBox="1"/>
+          <p:nvPr/>
+        </p:nvSpPr>
+        <p:spPr>
+          <a:xfrm>
+            <a:off x="731520" y="5367528"/>
+            <a:ext cx="2103120" cy="457200"/>
+          </a:xfrm>
+          <a:prstGeom prst="rect">
+            <a:avLst/>
+          </a:prstGeom>
+          <a:noFill/>
+        </p:spPr>
+        <p:txBody>
+          <a:bodyPr wrap="square">
+            <a:spAutoFit/>
+          </a:bodyPr>
+          <a:lstStyle/>
+          <a:p>
+            <a:pPr>
+              <a:spcAft>
+                <a:spcPts val="594"/>
+              </a:spcAft>
+              <a:defRPr sz="1700" b="0">
+                <a:solidFill>
+                  <a:srgbClr val="F0B90B"/>
+                </a:solidFill>
+                <a:latin typeface="Calibri"/>
+              </a:defRPr>
+            </a:pPr>
+            <a:r>
+              <a:t>#134,042,328</a:t>
+            </a:r>
+          </a:p>
+        </p:txBody>
+      </p:sp>
+      <p:sp>
+        <p:nvSpPr>
+          <p:cNvPr id="25" name="TextBox 24"/>
+          <p:cNvSpPr txBox="1"/>
+          <p:nvPr/>
+        </p:nvSpPr>
+        <p:spPr>
+          <a:xfrm>
+            <a:off x="2926080" y="5367528"/>
+            <a:ext cx="4206240" cy="457200"/>
+          </a:xfrm>
+          <a:prstGeom prst="rect">
+            <a:avLst/>
+          </a:prstGeom>
+          <a:noFill/>
+        </p:spPr>
+        <p:txBody>
+          <a:bodyPr wrap="square">
+            <a:spAutoFit/>
+          </a:bodyPr>
+          <a:lstStyle/>
+          <a:p>
+            <a:pPr>
+              <a:spcAft>
+                <a:spcPts val="594"/>
+              </a:spcAft>
+              <a:defRPr sz="1700" b="0">
+                <a:solidFill>
+                  <a:srgbClr val="F4F5F8"/>
+                </a:solidFill>
+                <a:latin typeface="Calibri"/>
+              </a:defRPr>
+            </a:pPr>
+            <a:r>
+              <a:t>setRegime(Neutral)</a:t>
+            </a:r>
+          </a:p>
+        </p:txBody>
+      </p:sp>
+      <p:sp>
+        <p:nvSpPr>
+          <p:cNvPr id="26" name="TextBox 25"/>
+          <p:cNvSpPr txBox="1"/>
+          <p:nvPr/>
+        </p:nvSpPr>
+        <p:spPr>
+          <a:xfrm>
+            <a:off x="7223760" y="5367528"/>
+            <a:ext cx="4389120" cy="457200"/>
+          </a:xfrm>
+          <a:prstGeom prst="rect">
+            <a:avLst/>
+          </a:prstGeom>
+          <a:noFill/>
+        </p:spPr>
+        <p:txBody>
+          <a:bodyPr wrap="square">
+            <a:spAutoFit/>
+          </a:bodyPr>
+          <a:lstStyle/>
+          <a:p>
+            <a:pPr>
+              <a:spcAft>
+                <a:spcPts val="594"/>
+              </a:spcAft>
+              <a:defRPr sz="1700" b="0">
+                <a:solidFill>
+                  <a:srgbClr val="A6ABB8"/>
+                </a:solidFill>
+                <a:latin typeface="Calibri"/>
+              </a:defRPr>
+            </a:pPr>
+            <a:r>
+              <a:t>Long allowed again; 2 decisions on-chain</a:t>
+            </a:r>
+          </a:p>
+        </p:txBody>
+      </p:sp>
+      <p:sp>
+        <p:nvSpPr>
+          <p:cNvPr id="27" name="TextBox 26"/>
+          <p:cNvSpPr txBox="1"/>
+          <p:nvPr/>
+        </p:nvSpPr>
+        <p:spPr>
+          <a:xfrm>
+            <a:off x="640080" y="6172200"/>
+            <a:ext cx="10881360" cy="457200"/>
+          </a:xfrm>
+          <a:prstGeom prst="rect">
+            <a:avLst/>
+          </a:prstGeom>
+          <a:noFill/>
+        </p:spPr>
+        <p:txBody>
+          <a:bodyPr wrap="square">
+            <a:spAutoFit/>
+          </a:bodyPr>
+          <a:lstStyle/>
+          <a:p>
+            <a:pPr>
+              <a:spcAft>
+                <a:spcPts val="489"/>
+              </a:spcAft>
+              <a:defRPr sz="1400" b="0">
+                <a:solidFill>
+                  <a:srgbClr val="A6ABB8"/>
+                </a:solidFill>
+                <a:latin typeface="Calibri"/>
+              </a:defRPr>
+            </a:pPr>
+            <a:r>
+              <a:t>Every row is a transaction with receipt status 1 on BscScan · block 134,042,283 is the halt</a:t>
+            </a:r>
+          </a:p>
+        </p:txBody>
+      </p:sp>
+    </p:spTree>
+  </p:cSld>
+  <p:clrMapOvr>
+    <a:masterClrMapping/>
+  </p:clrMapOvr>
+</p:sld>
+</file>
+
+<file path=ppt/slides/slide7.xml><?xml version="1.0" encoding="utf-8"?>
+<p:sld xmlns:a="http://schemas.openxmlformats.org/drawingml/2006/main" xmlns:p="http://schemas.openxmlformats.org/presentationml/2006/main" xmlns:r="http://schemas.openxmlformats.org/officeDocument/2006/relationships">
+  <p:cSld>
+    <p:bg>
+      <p:bgPr>
+        <a:solidFill>
+          <a:srgbClr val="0B0C0F"/>
+        </a:solidFill>
+        <a:effectLst/>
+      </p:bgPr>
+    </p:bg>
+    <p:spTree>
+      <p:nvGrpSpPr>
+        <p:cNvPr id="1" name=""/>
+        <p:cNvGrpSpPr/>
+        <p:nvPr/>
+      </p:nvGrpSpPr>
+      <p:grpSpPr/>
+      <p:sp>
+        <p:nvSpPr>
+          <p:cNvPr id="2" name="TextBox 1"/>
+          <p:cNvSpPr txBox="1"/>
+          <p:nvPr/>
+        </p:nvSpPr>
+        <p:spPr>
+          <a:xfrm>
+            <a:off x="640080" y="365760"/>
+            <a:ext cx="10881360" cy="822960"/>
+          </a:xfrm>
+          <a:prstGeom prst="rect">
+            <a:avLst/>
+          </a:prstGeom>
+          <a:noFill/>
+        </p:spPr>
+        <p:txBody>
+          <a:bodyPr wrap="square">
+            <a:spAutoFit/>
+          </a:bodyPr>
+          <a:lstStyle/>
+          <a:p>
+            <a:pPr>
+              <a:spcAft>
+                <a:spcPts val="1260"/>
+              </a:spcAft>
+              <a:defRPr sz="3600" b="1">
+                <a:solidFill>
+                  <a:srgbClr val="F4F5F8"/>
+                </a:solidFill>
+                <a:latin typeface="Calibri"/>
+              </a:defRPr>
+            </a:pPr>
+            <a:r>
+              <a:t>Why BNB Chain</a:t>
             </a:r>
           </a:p>
         </p:txBody>
@@ -4651,8 +7052,8 @@
         </p:nvSpPr>
         <p:spPr>
           <a:xfrm>
-            <a:off x="640080" y="1554480"/>
-            <a:ext cx="3108960" cy="822960"/>
+            <a:off x="640080" y="1463040"/>
+            <a:ext cx="5394960" cy="822960"/>
           </a:xfrm>
           <a:prstGeom prst="rect">
             <a:avLst/>
@@ -4660,21 +7061,24 @@
           <a:noFill/>
         </p:spPr>
         <p:txBody>
-          <a:bodyPr wrap="none">
+          <a:bodyPr wrap="square">
             <a:spAutoFit/>
           </a:bodyPr>
           <a:lstStyle/>
           <a:p>
             <a:pPr>
-              <a:defRPr sz="4800" b="1">
-                <a:solidFill>
-                  <a:srgbClr val="78D5AB"/>
-                </a:solidFill>
-                <a:latin typeface="Calibri"/>
-              </a:defRPr>
-            </a:pPr>
-            <a:r>
-              <a:t>7 / 7</a:t>
+              <a:spcAft>
+                <a:spcPts val="1400"/>
+              </a:spcAft>
+              <a:defRPr sz="4000" b="1">
+                <a:solidFill>
+                  <a:srgbClr val="F0B90B"/>
+                </a:solidFill>
+                <a:latin typeface="Calibri"/>
+              </a:defRPr>
+            </a:pPr>
+            <a:r>
+              <a:t>≈ 0.0000034 tBNB</a:t>
             </a:r>
           </a:p>
         </p:txBody>
@@ -4687,8 +7091,8 @@
         </p:nvSpPr>
         <p:spPr>
           <a:xfrm>
-            <a:off x="640080" y="2377440"/>
-            <a:ext cx="5029200" cy="457200"/>
+            <a:off x="640080" y="2286000"/>
+            <a:ext cx="5394960" cy="1097280"/>
           </a:xfrm>
           <a:prstGeom prst="rect">
             <a:avLst/>
@@ -4696,13 +7100,16 @@
           <a:noFill/>
         </p:spPr>
         <p:txBody>
-          <a:bodyPr wrap="none">
+          <a:bodyPr wrap="square">
             <a:spAutoFit/>
           </a:bodyPr>
           <a:lstStyle/>
           <a:p>
             <a:pPr>
-              <a:defRPr sz="2000" b="0">
+              <a:spcAft>
+                <a:spcPts val="630"/>
+              </a:spcAft>
+              <a:defRPr sz="1800" b="0">
                 <a:solidFill>
                   <a:srgbClr val="F4F5F8"/>
                 </a:solidFill>
@@ -4710,7 +7117,23 @@
               </a:defRPr>
             </a:pPr>
             <a:r>
-              <a:t>contract tests passed (Foundry 1.5.1)</a:t>
+              <a:t>per recorded decision: 33,189–34,323 gas</a:t>
+            </a:r>
+          </a:p>
+          <a:p>
+            <a:pPr>
+              <a:spcAft>
+                <a:spcPts val="630"/>
+              </a:spcAft>
+              <a:defRPr sz="1800" b="0">
+                <a:solidFill>
+                  <a:srgbClr val="F4F5F8"/>
+                </a:solidFill>
+                <a:latin typeface="Calibri"/>
+              </a:defRPr>
+            </a:pPr>
+            <a:r>
+              <a:t>at 0.1 gwei (our receipts, BSC Testnet)</a:t>
             </a:r>
           </a:p>
         </p:txBody>
@@ -4723,8 +7146,8 @@
         </p:nvSpPr>
         <p:spPr>
           <a:xfrm>
-            <a:off x="6126480" y="1554480"/>
-            <a:ext cx="5394960" cy="731520"/>
+            <a:off x="640080" y="3657600"/>
+            <a:ext cx="5394960" cy="822960"/>
           </a:xfrm>
           <a:prstGeom prst="rect">
             <a:avLst/>
@@ -4732,21 +7155,24 @@
           <a:noFill/>
         </p:spPr>
         <p:txBody>
-          <a:bodyPr wrap="none">
+          <a:bodyPr wrap="square">
             <a:spAutoFit/>
           </a:bodyPr>
           <a:lstStyle/>
           <a:p>
             <a:pPr>
-              <a:defRPr sz="3200" b="1">
-                <a:solidFill>
-                  <a:srgbClr val="78D5AB"/>
-                </a:solidFill>
-                <a:latin typeface="Calibri"/>
-              </a:defRPr>
-            </a:pPr>
-            <a:r>
-              <a:t>DEPLOYED + SMOKE-TESTED</a:t>
+              <a:spcAft>
+                <a:spcPts val="1050"/>
+              </a:spcAft>
+              <a:defRPr sz="3000" b="1">
+                <a:solidFill>
+                  <a:srgbClr val="F0B90B"/>
+                </a:solidFill>
+                <a:latin typeface="Calibri"/>
+              </a:defRPr>
+            </a:pPr>
+            <a:r>
+              <a:t>≈ 0.00008 tBNB a day</a:t>
             </a:r>
           </a:p>
         </p:txBody>
@@ -4759,8 +7185,8 @@
         </p:nvSpPr>
         <p:spPr>
           <a:xfrm>
-            <a:off x="6126480" y="2377440"/>
-            <a:ext cx="5394960" cy="457200"/>
+            <a:off x="640080" y="4389120"/>
+            <a:ext cx="5394960" cy="914400"/>
           </a:xfrm>
           <a:prstGeom prst="rect">
             <a:avLst/>
@@ -4768,13 +7194,16 @@
           <a:noFill/>
         </p:spPr>
         <p:txBody>
-          <a:bodyPr wrap="none">
+          <a:bodyPr wrap="square">
             <a:spAutoFit/>
           </a:bodyPr>
           <a:lstStyle/>
           <a:p>
             <a:pPr>
-              <a:defRPr sz="2000" b="0">
+              <a:spcAft>
+                <a:spcPts val="630"/>
+              </a:spcAft>
+              <a:defRPr sz="1800" b="0">
                 <a:solidFill>
                   <a:srgbClr val="F4F5F8"/>
                 </a:solidFill>
@@ -4782,7 +7211,23 @@
               </a:defRPr>
             </a:pPr>
             <a:r>
-              <a:t>Dex contract: deploy + 5 smoke txs status 1; unauthorized call reverts</a:t>
+              <a:t>for an hourly bot (24 decisions);</a:t>
+            </a:r>
+          </a:p>
+          <a:p>
+            <a:pPr>
+              <a:spcAft>
+                <a:spcPts val="630"/>
+              </a:spcAft>
+              <a:defRPr sz="1800" b="0">
+                <a:solidFill>
+                  <a:srgbClr val="F4F5F8"/>
+                </a:solidFill>
+                <a:latin typeface="Calibri"/>
+              </a:defRPr>
+            </a:pPr>
+            <a:r>
+              <a:t>deploy: 449,207 gas ≈ 0.000045 tBNB</a:t>
             </a:r>
           </a:p>
         </p:txBody>
@@ -4795,8 +7240,8 @@
         </p:nvSpPr>
         <p:spPr>
           <a:xfrm>
-            <a:off x="640080" y="3566160"/>
-            <a:ext cx="10881360" cy="1188720"/>
+            <a:off x="6400800" y="1463040"/>
+            <a:ext cx="5120640" cy="548640"/>
           </a:xfrm>
           <a:prstGeom prst="rect">
             <a:avLst/>
@@ -4804,25 +7249,24 @@
           <a:noFill/>
         </p:spPr>
         <p:txBody>
-          <a:bodyPr wrap="none">
+          <a:bodyPr wrap="square">
             <a:spAutoFit/>
           </a:bodyPr>
           <a:lstStyle/>
           <a:p>
             <a:pPr>
-              <a:defRPr sz="2200" b="0">
-                <a:solidFill>
-                  <a:srgbClr val="F4F5F8"/>
-                </a:solidFill>
-                <a:latin typeface="Calibri"/>
-              </a:defRPr>
-            </a:pPr>
-            <a:r>
-              <a:t>Panel reads live Dex state (read 2 Oct 2026): Neutral, not halted, 20% limit, 2 decisions.</a:t>
-            </a:r>
-            <a:br/>
-            <a:r>
-              <a:t>Deploy + smoke receipts on BscScan testnet.</a:t>
+              <a:spcAft>
+                <a:spcPts val="839"/>
+              </a:spcAft>
+              <a:defRPr sz="2400" b="1">
+                <a:solidFill>
+                  <a:srgbClr val="AEB9F4"/>
+                </a:solidFill>
+                <a:latin typeface="Calibri"/>
+              </a:defRPr>
+            </a:pPr>
+            <a:r>
+              <a:t>What else it gives us</a:t>
             </a:r>
           </a:p>
         </p:txBody>
@@ -4835,8 +7279,8 @@
         </p:nvSpPr>
         <p:spPr>
           <a:xfrm>
-            <a:off x="640080" y="5212080"/>
-            <a:ext cx="10881360" cy="914400"/>
+            <a:off x="6400800" y="2194560"/>
+            <a:ext cx="5120640" cy="3291840"/>
           </a:xfrm>
           <a:prstGeom prst="rect">
             <a:avLst/>
@@ -4844,21 +7288,1050 @@
           <a:noFill/>
         </p:spPr>
         <p:txBody>
-          <a:bodyPr wrap="none">
+          <a:bodyPr wrap="square">
             <a:spAutoFit/>
           </a:bodyPr>
           <a:lstStyle/>
           <a:p>
             <a:pPr>
+              <a:spcAft>
+                <a:spcPts val="630"/>
+              </a:spcAft>
               <a:defRPr sz="1800" b="0">
                 <a:solidFill>
+                  <a:srgbClr val="F4F5F8"/>
+                </a:solidFill>
+                <a:latin typeface="Calibri"/>
+              </a:defRPr>
+            </a:pPr>
+            <a:r>
+              <a:t>EVM: Foundry tests and Sourcify verification on chain 97</a:t>
+            </a:r>
+          </a:p>
+          <a:p>
+            <a:pPr>
+              <a:spcAft>
+                <a:spcPts val="630"/>
+              </a:spcAft>
+              <a:defRPr sz="1800" b="0">
+                <a:solidFill>
+                  <a:srgbClr val="F4F5F8"/>
+                </a:solidFill>
+                <a:latin typeface="Calibri"/>
+              </a:defRPr>
+            </a:pPr>
+            <a:r>
+              <a:t>Public RPCs a browser can call: the panel needs no backend</a:t>
+            </a:r>
+          </a:p>
+          <a:p>
+            <a:pPr>
+              <a:spcAft>
+                <a:spcPts val="630"/>
+              </a:spcAft>
+              <a:defRPr sz="1800" b="0">
+                <a:solidFill>
+                  <a:srgbClr val="F4F5F8"/>
+                </a:solidFill>
+                <a:latin typeface="Calibri"/>
+              </a:defRPr>
+            </a:pPr>
+            <a:r>
+              <a:t>Five smoke-test transactions within 132 blocks</a:t>
+            </a:r>
+          </a:p>
+          <a:p>
+            <a:pPr>
+              <a:spcAft>
+                <a:spcPts val="630"/>
+              </a:spcAft>
+              <a:defRPr sz="1800" b="0">
+                <a:solidFill>
+                  <a:srgbClr val="F4F5F8"/>
+                </a:solidFill>
+                <a:latin typeface="Calibri"/>
+              </a:defRPr>
+            </a:pPr>
+            <a:r>
+              <a:t>Mainnet (chain 56) is a config switch; not deployed there</a:t>
+            </a:r>
+          </a:p>
+        </p:txBody>
+      </p:sp>
+      <p:sp>
+        <p:nvSpPr>
+          <p:cNvPr id="9" name="TextBox 8"/>
+          <p:cNvSpPr txBox="1"/>
+          <p:nvPr/>
+        </p:nvSpPr>
+        <p:spPr>
+          <a:xfrm>
+            <a:off x="640080" y="5943600"/>
+            <a:ext cx="10881360" cy="457200"/>
+          </a:xfrm>
+          <a:prstGeom prst="rect">
+            <a:avLst/>
+          </a:prstGeom>
+          <a:noFill/>
+        </p:spPr>
+        <p:txBody>
+          <a:bodyPr wrap="square">
+            <a:spAutoFit/>
+          </a:bodyPr>
+          <a:lstStyle/>
+          <a:p>
+            <a:pPr>
+              <a:spcAft>
+                <a:spcPts val="489"/>
+              </a:spcAft>
+              <a:defRPr sz="1400" b="0">
+                <a:solidFill>
+                  <a:srgbClr val="A6ABB8"/>
+                </a:solidFill>
+                <a:latin typeface="Calibri"/>
+              </a:defRPr>
+            </a:pPr>
+            <a:r>
+              <a:t>Testnet gas price, not a mainnet quote. Mainnet is on the roadmap, after an audit.</a:t>
+            </a:r>
+          </a:p>
+        </p:txBody>
+      </p:sp>
+    </p:spTree>
+  </p:cSld>
+  <p:clrMapOvr>
+    <a:masterClrMapping/>
+  </p:clrMapOvr>
+</p:sld>
+</file>
+
+<file path=ppt/slides/slide8.xml><?xml version="1.0" encoding="utf-8"?>
+<p:sld xmlns:a="http://schemas.openxmlformats.org/drawingml/2006/main" xmlns:p="http://schemas.openxmlformats.org/presentationml/2006/main" xmlns:r="http://schemas.openxmlformats.org/officeDocument/2006/relationships">
+  <p:cSld>
+    <p:bg>
+      <p:bgPr>
+        <a:solidFill>
+          <a:srgbClr val="0B0C0F"/>
+        </a:solidFill>
+        <a:effectLst/>
+      </p:bgPr>
+    </p:bg>
+    <p:spTree>
+      <p:nvGrpSpPr>
+        <p:cNvPr id="1" name=""/>
+        <p:cNvGrpSpPr/>
+        <p:nvPr/>
+      </p:nvGrpSpPr>
+      <p:grpSpPr/>
+      <p:sp>
+        <p:nvSpPr>
+          <p:cNvPr id="2" name="TextBox 1"/>
+          <p:cNvSpPr txBox="1"/>
+          <p:nvPr/>
+        </p:nvSpPr>
+        <p:spPr>
+          <a:xfrm>
+            <a:off x="640080" y="365760"/>
+            <a:ext cx="10881360" cy="822960"/>
+          </a:xfrm>
+          <a:prstGeom prst="rect">
+            <a:avLst/>
+          </a:prstGeom>
+          <a:noFill/>
+        </p:spPr>
+        <p:txBody>
+          <a:bodyPr wrap="square">
+            <a:spAutoFit/>
+          </a:bodyPr>
+          <a:lstStyle/>
+          <a:p>
+            <a:pPr>
+              <a:spcAft>
+                <a:spcPts val="1260"/>
+              </a:spcAft>
+              <a:defRPr sz="3600" b="1">
+                <a:solidFill>
+                  <a:srgbClr val="F4F5F8"/>
+                </a:solidFill>
+                <a:latin typeface="Calibri"/>
+              </a:defRPr>
+            </a:pPr>
+            <a:r>
+              <a:t>Evidence and current limits</a:t>
+            </a:r>
+          </a:p>
+        </p:txBody>
+      </p:sp>
+      <p:sp>
+        <p:nvSpPr>
+          <p:cNvPr id="3" name="TextBox 2"/>
+          <p:cNvSpPr txBox="1"/>
+          <p:nvPr/>
+        </p:nvSpPr>
+        <p:spPr>
+          <a:xfrm>
+            <a:off x="640080" y="1463040"/>
+            <a:ext cx="2743200" cy="731520"/>
+          </a:xfrm>
+          <a:prstGeom prst="rect">
+            <a:avLst/>
+          </a:prstGeom>
+          <a:noFill/>
+        </p:spPr>
+        <p:txBody>
+          <a:bodyPr wrap="square">
+            <a:spAutoFit/>
+          </a:bodyPr>
+          <a:lstStyle/>
+          <a:p>
+            <a:pPr>
+              <a:spcAft>
+                <a:spcPts val="1189"/>
+              </a:spcAft>
+              <a:defRPr sz="3400" b="1">
+                <a:solidFill>
+                  <a:srgbClr val="78D5AB"/>
+                </a:solidFill>
+                <a:latin typeface="Calibri"/>
+              </a:defRPr>
+            </a:pPr>
+            <a:r>
+              <a:t>30 / 30</a:t>
+            </a:r>
+          </a:p>
+        </p:txBody>
+      </p:sp>
+      <p:sp>
+        <p:nvSpPr>
+          <p:cNvPr id="4" name="TextBox 3"/>
+          <p:cNvSpPr txBox="1"/>
+          <p:nvPr/>
+        </p:nvSpPr>
+        <p:spPr>
+          <a:xfrm>
+            <a:off x="640080" y="2286000"/>
+            <a:ext cx="2743200" cy="1280160"/>
+          </a:xfrm>
+          <a:prstGeom prst="rect">
+            <a:avLst/>
+          </a:prstGeom>
+          <a:noFill/>
+        </p:spPr>
+        <p:txBody>
+          <a:bodyPr wrap="square">
+            <a:spAutoFit/>
+          </a:bodyPr>
+          <a:lstStyle/>
+          <a:p>
+            <a:pPr>
+              <a:spcAft>
+                <a:spcPts val="489"/>
+              </a:spcAft>
+              <a:defRPr sz="1400" b="0">
+                <a:solidFill>
+                  <a:srgbClr val="F4F5F8"/>
+                </a:solidFill>
+                <a:latin typeface="Calibri"/>
+              </a:defRPr>
+            </a:pPr>
+            <a:r>
+              <a:t>contract tests: unit, fuzz, invariant</a:t>
+            </a:r>
+          </a:p>
+          <a:p>
+            <a:pPr>
+              <a:spcAft>
+                <a:spcPts val="489"/>
+              </a:spcAft>
+              <a:defRPr sz="1400" b="0">
+                <a:solidFill>
+                  <a:srgbClr val="F4F5F8"/>
+                </a:solidFill>
+                <a:latin typeface="Calibri"/>
+              </a:defRPr>
+            </a:pPr>
+            <a:r>
+              <a:t>100% coverage of MacroGuard.sol</a:t>
+            </a:r>
+          </a:p>
+        </p:txBody>
+      </p:sp>
+      <p:sp>
+        <p:nvSpPr>
+          <p:cNvPr id="5" name="TextBox 4"/>
+          <p:cNvSpPr txBox="1"/>
+          <p:nvPr/>
+        </p:nvSpPr>
+        <p:spPr>
+          <a:xfrm>
+            <a:off x="3474720" y="1463040"/>
+            <a:ext cx="2743200" cy="731520"/>
+          </a:xfrm>
+          <a:prstGeom prst="rect">
+            <a:avLst/>
+          </a:prstGeom>
+          <a:noFill/>
+        </p:spPr>
+        <p:txBody>
+          <a:bodyPr wrap="square">
+            <a:spAutoFit/>
+          </a:bodyPr>
+          <a:lstStyle/>
+          <a:p>
+            <a:pPr>
+              <a:spcAft>
+                <a:spcPts val="1189"/>
+              </a:spcAft>
+              <a:defRPr sz="3400" b="1">
+                <a:solidFill>
+                  <a:srgbClr val="78D5AB"/>
+                </a:solidFill>
+                <a:latin typeface="Calibri"/>
+              </a:defRPr>
+            </a:pPr>
+            <a:r>
+              <a:t>45</a:t>
+            </a:r>
+          </a:p>
+        </p:txBody>
+      </p:sp>
+      <p:sp>
+        <p:nvSpPr>
+          <p:cNvPr id="6" name="TextBox 5"/>
+          <p:cNvSpPr txBox="1"/>
+          <p:nvPr/>
+        </p:nvSpPr>
+        <p:spPr>
+          <a:xfrm>
+            <a:off x="3474720" y="2286000"/>
+            <a:ext cx="2743200" cy="1280160"/>
+          </a:xfrm>
+          <a:prstGeom prst="rect">
+            <a:avLst/>
+          </a:prstGeom>
+          <a:noFill/>
+        </p:spPr>
+        <p:txBody>
+          <a:bodyPr wrap="square">
+            <a:spAutoFit/>
+          </a:bodyPr>
+          <a:lstStyle/>
+          <a:p>
+            <a:pPr>
+              <a:spcAft>
+                <a:spcPts val="489"/>
+              </a:spcAft>
+              <a:defRPr sz="1400" b="0">
+                <a:solidFill>
+                  <a:srgbClr val="F4F5F8"/>
+                </a:solidFill>
+                <a:latin typeface="Calibri"/>
+              </a:defRPr>
+            </a:pPr>
+            <a:r>
+              <a:t>offline engine tests;</a:t>
+            </a:r>
+          </a:p>
+          <a:p>
+            <a:pPr>
+              <a:spcAft>
+                <a:spcPts val="489"/>
+              </a:spcAft>
+              <a:defRPr sz="1400" b="0">
+                <a:solidFill>
+                  <a:srgbClr val="F4F5F8"/>
+                </a:solidFill>
+                <a:latin typeface="Calibri"/>
+              </a:defRPr>
+            </a:pPr>
+            <a:r>
+              <a:t>no look-ahead tested as a property</a:t>
+            </a:r>
+          </a:p>
+        </p:txBody>
+      </p:sp>
+      <p:sp>
+        <p:nvSpPr>
+          <p:cNvPr id="7" name="TextBox 6"/>
+          <p:cNvSpPr txBox="1"/>
+          <p:nvPr/>
+        </p:nvSpPr>
+        <p:spPr>
+          <a:xfrm>
+            <a:off x="6309360" y="1463040"/>
+            <a:ext cx="2743200" cy="731520"/>
+          </a:xfrm>
+          <a:prstGeom prst="rect">
+            <a:avLst/>
+          </a:prstGeom>
+          <a:noFill/>
+        </p:spPr>
+        <p:txBody>
+          <a:bodyPr wrap="square">
+            <a:spAutoFit/>
+          </a:bodyPr>
+          <a:lstStyle/>
+          <a:p>
+            <a:pPr>
+              <a:spcAft>
+                <a:spcPts val="1189"/>
+              </a:spcAft>
+              <a:defRPr sz="3400" b="1">
+                <a:solidFill>
+                  <a:srgbClr val="78D5AB"/>
+                </a:solidFill>
+                <a:latin typeface="Calibri"/>
+              </a:defRPr>
+            </a:pPr>
+            <a:r>
+              <a:t>15</a:t>
+            </a:r>
+          </a:p>
+        </p:txBody>
+      </p:sp>
+      <p:sp>
+        <p:nvSpPr>
+          <p:cNvPr id="8" name="TextBox 7"/>
+          <p:cNvSpPr txBox="1"/>
+          <p:nvPr/>
+        </p:nvSpPr>
+        <p:spPr>
+          <a:xfrm>
+            <a:off x="6309360" y="2286000"/>
+            <a:ext cx="2743200" cy="1280160"/>
+          </a:xfrm>
+          <a:prstGeom prst="rect">
+            <a:avLst/>
+          </a:prstGeom>
+          <a:noFill/>
+        </p:spPr>
+        <p:txBody>
+          <a:bodyPr wrap="square">
+            <a:spAutoFit/>
+          </a:bodyPr>
+          <a:lstStyle/>
+          <a:p>
+            <a:pPr>
+              <a:spcAft>
+                <a:spcPts val="489"/>
+              </a:spcAft>
+              <a:defRPr sz="1400" b="0">
+                <a:solidFill>
+                  <a:srgbClr val="F4F5F8"/>
+                </a:solidFill>
+                <a:latin typeface="Calibri"/>
+              </a:defRPr>
+            </a:pPr>
+            <a:r>
+              <a:t>web tests: contract reads and the</a:t>
+            </a:r>
+          </a:p>
+          <a:p>
+            <a:pPr>
+              <a:spcAft>
+                <a:spcPts val="489"/>
+              </a:spcAft>
+              <a:defRPr sz="1400" b="0">
+                <a:solidFill>
+                  <a:srgbClr val="F4F5F8"/>
+                </a:solidFill>
+                <a:latin typeface="Calibri"/>
+              </a:defRPr>
+            </a:pPr>
+            <a:r>
+              <a:t>what-if encoder against cast</a:t>
+            </a:r>
+          </a:p>
+        </p:txBody>
+      </p:sp>
+      <p:sp>
+        <p:nvSpPr>
+          <p:cNvPr id="9" name="TextBox 8"/>
+          <p:cNvSpPr txBox="1"/>
+          <p:nvPr/>
+        </p:nvSpPr>
+        <p:spPr>
+          <a:xfrm>
+            <a:off x="9144000" y="1463040"/>
+            <a:ext cx="2743200" cy="731520"/>
+          </a:xfrm>
+          <a:prstGeom prst="rect">
+            <a:avLst/>
+          </a:prstGeom>
+          <a:noFill/>
+        </p:spPr>
+        <p:txBody>
+          <a:bodyPr wrap="square">
+            <a:spAutoFit/>
+          </a:bodyPr>
+          <a:lstStyle/>
+          <a:p>
+            <a:pPr>
+              <a:spcAft>
+                <a:spcPts val="1189"/>
+              </a:spcAft>
+              <a:defRPr sz="3400" b="1">
+                <a:solidFill>
+                  <a:srgbClr val="F0B90B"/>
+                </a:solidFill>
+                <a:latin typeface="Calibri"/>
+              </a:defRPr>
+            </a:pPr>
+            <a:r>
+              <a:t>exact match</a:t>
+            </a:r>
+          </a:p>
+        </p:txBody>
+      </p:sp>
+      <p:sp>
+        <p:nvSpPr>
+          <p:cNvPr id="10" name="TextBox 9"/>
+          <p:cNvSpPr txBox="1"/>
+          <p:nvPr/>
+        </p:nvSpPr>
+        <p:spPr>
+          <a:xfrm>
+            <a:off x="9144000" y="2286000"/>
+            <a:ext cx="2743200" cy="1280160"/>
+          </a:xfrm>
+          <a:prstGeom prst="rect">
+            <a:avLst/>
+          </a:prstGeom>
+          <a:noFill/>
+        </p:spPr>
+        <p:txBody>
+          <a:bodyPr wrap="square">
+            <a:spAutoFit/>
+          </a:bodyPr>
+          <a:lstStyle/>
+          <a:p>
+            <a:pPr>
+              <a:spcAft>
+                <a:spcPts val="489"/>
+              </a:spcAft>
+              <a:defRPr sz="1400" b="0">
+                <a:solidFill>
+                  <a:srgbClr val="F4F5F8"/>
+                </a:solidFill>
+                <a:latin typeface="Calibri"/>
+              </a:defRPr>
+            </a:pPr>
+            <a:r>
+              <a:t>source verified on Sourcify</a:t>
+            </a:r>
+          </a:p>
+          <a:p>
+            <a:pPr>
+              <a:spcAft>
+                <a:spcPts val="489"/>
+              </a:spcAft>
+              <a:defRPr sz="1400" b="0">
+                <a:solidFill>
+                  <a:srgbClr val="F4F5F8"/>
+                </a:solidFill>
+                <a:latin typeface="Calibri"/>
+              </a:defRPr>
+            </a:pPr>
+            <a:r>
+              <a:t>6 receipts, all status 1</a:t>
+            </a:r>
+          </a:p>
+        </p:txBody>
+      </p:sp>
+      <p:sp>
+        <p:nvSpPr>
+          <p:cNvPr id="11" name="TextBox 10"/>
+          <p:cNvSpPr txBox="1"/>
+          <p:nvPr/>
+        </p:nvSpPr>
+        <p:spPr>
+          <a:xfrm>
+            <a:off x="640080" y="4023360"/>
+            <a:ext cx="10881360" cy="548640"/>
+          </a:xfrm>
+          <a:prstGeom prst="rect">
+            <a:avLst/>
+          </a:prstGeom>
+          <a:noFill/>
+        </p:spPr>
+        <p:txBody>
+          <a:bodyPr wrap="square">
+            <a:spAutoFit/>
+          </a:bodyPr>
+          <a:lstStyle/>
+          <a:p>
+            <a:pPr>
+              <a:spcAft>
+                <a:spcPts val="769"/>
+              </a:spcAft>
+              <a:defRPr sz="2200" b="1">
+                <a:solidFill>
                   <a:srgbClr val="E5BD71"/>
                 </a:solidFill>
                 <a:latin typeface="Calibri"/>
               </a:defRPr>
             </a:pPr>
             <a:r>
-              <a:t>Limits: contract never executes orders; RPC fail-open in runner; agent can resume(); no live bot tick or profit verified.</a:t>
+              <a:t>Limits, said plainly</a:t>
+            </a:r>
+          </a:p>
+        </p:txBody>
+      </p:sp>
+      <p:sp>
+        <p:nvSpPr>
+          <p:cNvPr id="12" name="TextBox 11"/>
+          <p:cNvSpPr txBox="1"/>
+          <p:nvPr/>
+        </p:nvSpPr>
+        <p:spPr>
+          <a:xfrm>
+            <a:off x="640080" y="4572000"/>
+            <a:ext cx="10881360" cy="1737360"/>
+          </a:xfrm>
+          <a:prstGeom prst="rect">
+            <a:avLst/>
+          </a:prstGeom>
+          <a:noFill/>
+        </p:spPr>
+        <p:txBody>
+          <a:bodyPr wrap="square">
+            <a:spAutoFit/>
+          </a:bodyPr>
+          <a:lstStyle/>
+          <a:p>
+            <a:pPr>
+              <a:spcAft>
+                <a:spcPts val="560"/>
+              </a:spcAft>
+              <a:defRPr sz="1600" b="0">
+                <a:solidFill>
+                  <a:srgbClr val="F4F5F8"/>
+                </a:solidFill>
+                <a:latin typeface="Calibri"/>
+              </a:defRPr>
+            </a:pPr>
+            <a:r>
+              <a:t>The contract never executes orders · the runner fails open if the RPC is down · the agent can resume() at once</a:t>
+            </a:r>
+          </a:p>
+          <a:p>
+            <a:pPr>
+              <a:spcAft>
+                <a:spcPts val="560"/>
+              </a:spcAft>
+              <a:defRPr sz="1600" b="0">
+                <a:solidFill>
+                  <a:srgbClr val="F4F5F8"/>
+                </a:solidFill>
+                <a:latin typeface="Calibri"/>
+              </a:defRPr>
+            </a:pPr>
+            <a:r>
+              <a:t>The drawdown is reported by the agent · no live bot tick and no profit claimed; backtests are research</a:t>
+            </a:r>
+          </a:p>
+        </p:txBody>
+      </p:sp>
+    </p:spTree>
+  </p:cSld>
+  <p:clrMapOvr>
+    <a:masterClrMapping/>
+  </p:clrMapOvr>
+</p:sld>
+</file>
+
+<file path=ppt/slides/slide9.xml><?xml version="1.0" encoding="utf-8"?>
+<p:sld xmlns:a="http://schemas.openxmlformats.org/drawingml/2006/main" xmlns:p="http://schemas.openxmlformats.org/presentationml/2006/main" xmlns:r="http://schemas.openxmlformats.org/officeDocument/2006/relationships">
+  <p:cSld>
+    <p:bg>
+      <p:bgPr>
+        <a:solidFill>
+          <a:srgbClr val="0B0C0F"/>
+        </a:solidFill>
+        <a:effectLst/>
+      </p:bgPr>
+    </p:bg>
+    <p:spTree>
+      <p:nvGrpSpPr>
+        <p:cNvPr id="1" name=""/>
+        <p:cNvGrpSpPr/>
+        <p:nvPr/>
+      </p:nvGrpSpPr>
+      <p:grpSpPr/>
+      <p:sp>
+        <p:nvSpPr>
+          <p:cNvPr id="2" name="TextBox 1"/>
+          <p:cNvSpPr txBox="1"/>
+          <p:nvPr/>
+        </p:nvSpPr>
+        <p:spPr>
+          <a:xfrm>
+            <a:off x="640080" y="365760"/>
+            <a:ext cx="10881360" cy="822960"/>
+          </a:xfrm>
+          <a:prstGeom prst="rect">
+            <a:avLst/>
+          </a:prstGeom>
+          <a:noFill/>
+        </p:spPr>
+        <p:txBody>
+          <a:bodyPr wrap="square">
+            <a:spAutoFit/>
+          </a:bodyPr>
+          <a:lstStyle/>
+          <a:p>
+            <a:pPr>
+              <a:spcAft>
+                <a:spcPts val="1260"/>
+              </a:spcAft>
+              <a:defRPr sz="3600" b="1">
+                <a:solidFill>
+                  <a:srgbClr val="F4F5F8"/>
+                </a:solidFill>
+                <a:latin typeface="Calibri"/>
+              </a:defRPr>
+            </a:pPr>
+            <a:r>
+              <a:t>What Dex added</a:t>
+            </a:r>
+          </a:p>
+        </p:txBody>
+      </p:sp>
+      <p:sp>
+        <p:nvSpPr>
+          <p:cNvPr id="3" name="TextBox 2"/>
+          <p:cNvSpPr txBox="1"/>
+          <p:nvPr/>
+        </p:nvSpPr>
+        <p:spPr>
+          <a:xfrm>
+            <a:off x="640080" y="1371600"/>
+            <a:ext cx="4754880" cy="640080"/>
+          </a:xfrm>
+          <a:prstGeom prst="rect">
+            <a:avLst/>
+          </a:prstGeom>
+          <a:noFill/>
+        </p:spPr>
+        <p:txBody>
+          <a:bodyPr wrap="square">
+            <a:spAutoFit/>
+          </a:bodyPr>
+          <a:lstStyle/>
+          <a:p>
+            <a:pPr>
+              <a:spcAft>
+                <a:spcPts val="839"/>
+              </a:spcAft>
+              <a:defRPr sz="2400" b="1">
+                <a:solidFill>
+                  <a:srgbClr val="A6ABB8"/>
+                </a:solidFill>
+                <a:latin typeface="Calibri"/>
+              </a:defRPr>
+            </a:pPr>
+            <a:r>
+              <a:t>Upstream DRIFT project</a:t>
+            </a:r>
+          </a:p>
+        </p:txBody>
+      </p:sp>
+      <p:sp>
+        <p:nvSpPr>
+          <p:cNvPr id="4" name="TextBox 3"/>
+          <p:cNvSpPr txBox="1"/>
+          <p:nvPr/>
+        </p:nvSpPr>
+        <p:spPr>
+          <a:xfrm>
+            <a:off x="640080" y="2103120"/>
+            <a:ext cx="5029200" cy="2560320"/>
+          </a:xfrm>
+          <a:prstGeom prst="rect">
+            <a:avLst/>
+          </a:prstGeom>
+          <a:noFill/>
+        </p:spPr>
+        <p:txBody>
+          <a:bodyPr wrap="square">
+            <a:spAutoFit/>
+          </a:bodyPr>
+          <a:lstStyle/>
+          <a:p>
+            <a:pPr>
+              <a:spcAft>
+                <a:spcPts val="630"/>
+              </a:spcAft>
+              <a:defRPr sz="1800" b="0">
+                <a:solidFill>
+                  <a:srgbClr val="F4F5F8"/>
+                </a:solidFill>
+                <a:latin typeface="Calibri"/>
+              </a:defRPr>
+            </a:pPr>
+            <a:r>
+              <a:t>Quant engine, cockpit and MacroGuard.sol</a:t>
+            </a:r>
+          </a:p>
+          <a:p>
+            <a:pPr>
+              <a:spcAft>
+                <a:spcPts val="630"/>
+              </a:spcAft>
+              <a:defRPr sz="1800" b="0">
+                <a:solidFill>
+                  <a:srgbClr val="F4F5F8"/>
+                </a:solidFill>
+                <a:latin typeface="Calibri"/>
+              </a:defRPr>
+            </a:pPr>
+            <a:r>
+              <a:t>Built for a Mantle hackathon track (June 2026)</a:t>
+            </a:r>
+          </a:p>
+          <a:p>
+            <a:pPr>
+              <a:spcAft>
+                <a:spcPts val="630"/>
+              </a:spcAft>
+              <a:defRPr sz="1800" b="0">
+                <a:solidFill>
+                  <a:srgbClr val="F4F5F8"/>
+                </a:solidFill>
+                <a:latin typeface="Calibri"/>
+              </a:defRPr>
+            </a:pPr>
+            <a:r>
+              <a:t>Migrated to BNB Chain in bcc-ukdw/seed-bnb</a:t>
+            </a:r>
+          </a:p>
+          <a:p>
+            <a:pPr>
+              <a:spcAft>
+                <a:spcPts val="630"/>
+              </a:spcAft>
+              <a:defRPr sz="1800" b="0">
+                <a:solidFill>
+                  <a:srgbClr val="F4F5F8"/>
+                </a:solidFill>
+                <a:latin typeface="Calibri"/>
+              </a:defRPr>
+            </a:pPr>
+            <a:r>
+              <a:t>(commit 52671ce, 29 Sep 2026)</a:t>
+            </a:r>
+          </a:p>
+        </p:txBody>
+      </p:sp>
+      <p:sp>
+        <p:nvSpPr>
+          <p:cNvPr id="5" name="TextBox 4"/>
+          <p:cNvSpPr txBox="1"/>
+          <p:nvPr/>
+        </p:nvSpPr>
+        <p:spPr>
+          <a:xfrm>
+            <a:off x="6035040" y="1371600"/>
+            <a:ext cx="5486400" cy="640080"/>
+          </a:xfrm>
+          <a:prstGeom prst="rect">
+            <a:avLst/>
+          </a:prstGeom>
+          <a:noFill/>
+        </p:spPr>
+        <p:txBody>
+          <a:bodyPr wrap="square">
+            <a:spAutoFit/>
+          </a:bodyPr>
+          <a:lstStyle/>
+          <a:p>
+            <a:pPr>
+              <a:spcAft>
+                <a:spcPts val="839"/>
+              </a:spcAft>
+              <a:defRPr sz="2400" b="1">
+                <a:solidFill>
+                  <a:srgbClr val="F0B90B"/>
+                </a:solidFill>
+                <a:latin typeface="Calibri"/>
+              </a:defRPr>
+            </a:pPr>
+            <a:r>
+              <a:t>Dex's work in this fork</a:t>
+            </a:r>
+          </a:p>
+        </p:txBody>
+      </p:sp>
+      <p:sp>
+        <p:nvSpPr>
+          <p:cNvPr id="6" name="TextBox 5"/>
+          <p:cNvSpPr txBox="1"/>
+          <p:nvPr/>
+        </p:nvSpPr>
+        <p:spPr>
+          <a:xfrm>
+            <a:off x="6035040" y="2103120"/>
+            <a:ext cx="5486400" cy="3657600"/>
+          </a:xfrm>
+          <a:prstGeom prst="rect">
+            <a:avLst/>
+          </a:prstGeom>
+          <a:noFill/>
+        </p:spPr>
+        <p:txBody>
+          <a:bodyPr wrap="square">
+            <a:spAutoFit/>
+          </a:bodyPr>
+          <a:lstStyle/>
+          <a:p>
+            <a:pPr>
+              <a:spcAft>
+                <a:spcPts val="594"/>
+              </a:spcAft>
+              <a:defRPr sz="1700" b="0">
+                <a:solidFill>
+                  <a:srgbClr val="F4F5F8"/>
+                </a:solidFill>
+                <a:latin typeface="Calibri"/>
+              </a:defRPr>
+            </a:pPr>
+            <a:r>
+              <a:t>Own BSC Testnet deploy + 5-tx smoke test (status 1)</a:t>
+            </a:r>
+          </a:p>
+          <a:p>
+            <a:pPr>
+              <a:spcAft>
+                <a:spcPts val="594"/>
+              </a:spcAft>
+              <a:defRPr sz="1700" b="0">
+                <a:solidFill>
+                  <a:srgbClr val="F4F5F8"/>
+                </a:solidFill>
+                <a:latin typeface="Calibri"/>
+              </a:defRPr>
+            </a:pPr>
+            <a:r>
+              <a:t>Source verified on Sourcify (exact match)</a:t>
+            </a:r>
+          </a:p>
+          <a:p>
+            <a:pPr>
+              <a:spcAft>
+                <a:spcPts val="594"/>
+              </a:spcAft>
+              <a:defRPr sz="1700" b="0">
+                <a:solidFill>
+                  <a:srgbClr val="F4F5F8"/>
+                </a:solidFill>
+                <a:latin typeface="Calibri"/>
+              </a:defRPr>
+            </a:pPr>
+            <a:r>
+              <a:t>Public panel: live browser reads, receipts, limits</a:t>
+            </a:r>
+          </a:p>
+          <a:p>
+            <a:pPr>
+              <a:spcAft>
+                <a:spcPts val="594"/>
+              </a:spcAft>
+              <a:defRPr sz="1700" b="0">
+                <a:solidFill>
+                  <a:srgbClr val="F4F5F8"/>
+                </a:solidFill>
+                <a:latin typeface="Calibri"/>
+              </a:defRPr>
+            </a:pPr>
+            <a:r>
+              <a:t>Ask the contract: eth_call what-if, nothing signed</a:t>
+            </a:r>
+          </a:p>
+          <a:p>
+            <a:pPr>
+              <a:spcAft>
+                <a:spcPts val="594"/>
+              </a:spcAft>
+              <a:defRPr sz="1700" b="0">
+                <a:solidFill>
+                  <a:srgbClr val="F4F5F8"/>
+                </a:solidFill>
+                <a:latin typeface="Calibri"/>
+              </a:defRPr>
+            </a:pPr>
+            <a:r>
+              <a:t>23 contract + 45 engine + 8 web tests, CI</a:t>
+            </a:r>
+          </a:p>
+          <a:p>
+            <a:pPr>
+              <a:spcAft>
+                <a:spcPts val="594"/>
+              </a:spcAft>
+              <a:defRPr sz="1700" b="0">
+                <a:solidFill>
+                  <a:srgbClr val="F4F5F8"/>
+                </a:solidFill>
+                <a:latin typeface="Calibri"/>
+              </a:defRPr>
+            </a:pPr>
+            <a:r>
+              <a:t>Labelled Binance data fallback · threat model</a:t>
+            </a:r>
+          </a:p>
+          <a:p>
+            <a:pPr>
+              <a:spcAft>
+                <a:spcPts val="594"/>
+              </a:spcAft>
+              <a:defRPr sz="1700" b="0">
+                <a:solidFill>
+                  <a:srgbClr val="F4F5F8"/>
+                </a:solidFill>
+                <a:latin typeface="Calibri"/>
+              </a:defRPr>
+            </a:pPr>
+            <a:r>
+              <a:t>Landing, visual system, PRD, this deck</a:t>
+            </a:r>
+          </a:p>
+        </p:txBody>
+      </p:sp>
+      <p:sp>
+        <p:nvSpPr>
+          <p:cNvPr id="7" name="TextBox 6"/>
+          <p:cNvSpPr txBox="1"/>
+          <p:nvPr/>
+        </p:nvSpPr>
+        <p:spPr>
+          <a:xfrm>
+            <a:off x="640080" y="5852160"/>
+            <a:ext cx="10881360" cy="457200"/>
+          </a:xfrm>
+          <a:prstGeom prst="rect">
+            <a:avLst/>
+          </a:prstGeom>
+          <a:noFill/>
+        </p:spPr>
+        <p:txBody>
+          <a:bodyPr wrap="square">
+            <a:spAutoFit/>
+          </a:bodyPr>
+          <a:lstStyle/>
+          <a:p>
+            <a:pPr>
+              <a:spcAft>
+                <a:spcPts val="560"/>
+              </a:spcAft>
+              <a:defRPr sz="1600" b="0">
+                <a:solidFill>
+                  <a:srgbClr val="AEB9F4"/>
+                </a:solidFill>
+                <a:latin typeface="Calibri"/>
+              </a:defRPr>
+            </a:pPr>
+            <a:r>
+              <a:t>Code: github.com/Stylenecy/seed-bnb/tree/dex/drift/drift</a:t>
             </a:r>
           </a:p>
         </p:txBody>

</xml_diff>

<commit_message>
docs(drift): deck on the brand tokens, with a PDF that embeds its fonts
Headings are white; gold marks only what can be checked on-chain (the
contract address, block numbers, the halt line, "exact match", the
"check it yourself" links) and periwinkle only the off-chain engine
steps. Colours are the VISUAL-DIRECTION tokens (or token over ink, as
the web composes them); addresses, blocks, calls and URLs are set in
mono. Calibri and Consolas stand in for Geist because a .pptx renders
with the viewer's installed fonts; the reason is written in
build-deck.py and VISUAL-DIRECTION.md, and DRIFT-pitch.pdf embeds them.
Slide 9 now counts all 15 web tests and the 47 engine tests as Dex's.
</commit_message>
<xml_diff>
--- a/docs/submission/DRIFT-pitch.pptx
+++ b/docs/submission/DRIFT-pitch.pptx
@@ -4183,7 +4183,7 @@
               </a:spcAft>
               <a:defRPr sz="6000" b="1">
                 <a:solidFill>
-                  <a:srgbClr val="F0B90B"/>
+                  <a:srgbClr val="FFFFFF"/>
                 </a:solidFill>
                 <a:latin typeface="Calibri"/>
               </a:defRPr>
@@ -4222,7 +4222,7 @@
               </a:spcAft>
               <a:defRPr sz="3400" b="1">
                 <a:solidFill>
-                  <a:srgbClr val="F4F5F8"/>
+                  <a:srgbClr val="FFFFFF"/>
                 </a:solidFill>
                 <a:latin typeface="Calibri"/>
               </a:defRPr>
@@ -4261,7 +4261,7 @@
               </a:spcAft>
               <a:defRPr sz="2200" b="0">
                 <a:solidFill>
-                  <a:srgbClr val="A6ABB8"/>
+                  <a:srgbClr val="AAAAAB"/>
                 </a:solidFill>
                 <a:latin typeface="Calibri"/>
               </a:defRPr>
@@ -4296,17 +4296,17 @@
           <a:p>
             <a:pPr>
               <a:spcAft>
-                <a:spcPts val="630"/>
-              </a:spcAft>
-              <a:defRPr sz="1800" b="0">
-                <a:solidFill>
-                  <a:srgbClr val="F4F5F8"/>
-                </a:solidFill>
-                <a:latin typeface="Calibri"/>
-              </a:defRPr>
-            </a:pPr>
-            <a:r>
-              <a:t>Live: drift-macroguard.vercel.app/macroguard</a:t>
+                <a:spcPts val="560"/>
+              </a:spcAft>
+              <a:defRPr sz="1600" b="0">
+                <a:solidFill>
+                  <a:srgbClr val="AAAAAB"/>
+                </a:solidFill>
+                <a:latin typeface="Calibri"/>
+              </a:defRPr>
+            </a:pPr>
+            <a:r>
+              <a:t>Live demo</a:t>
             </a:r>
           </a:p>
         </p:txBody>
@@ -4319,7 +4319,7 @@
         </p:nvSpPr>
         <p:spPr>
           <a:xfrm>
-            <a:off x="640080" y="4754880"/>
+            <a:off x="640080" y="4572000"/>
             <a:ext cx="10881360" cy="457200"/>
           </a:xfrm>
           <a:prstGeom prst="rect">
@@ -4335,17 +4335,17 @@
           <a:p>
             <a:pPr>
               <a:spcAft>
-                <a:spcPts val="560"/>
-              </a:spcAft>
-              <a:defRPr sz="1600" b="0">
-                <a:solidFill>
-                  <a:srgbClr val="F0B90B"/>
-                </a:solidFill>
-                <a:latin typeface="Calibri"/>
-              </a:defRPr>
-            </a:pPr>
-            <a:r>
-              <a:t>Dex contract (BSC Testnet): 0x8b09ebB85Be8Ed55Bb5132d29eABc567c42aa83D</a:t>
+                <a:spcPts val="630"/>
+              </a:spcAft>
+              <a:defRPr sz="1800" b="0">
+                <a:solidFill>
+                  <a:srgbClr val="FFFFFF"/>
+                </a:solidFill>
+                <a:latin typeface="Consolas"/>
+              </a:defRPr>
+            </a:pPr>
+            <a:r>
+              <a:t>drift-macroguard.vercel.app/macroguard</a:t>
             </a:r>
           </a:p>
         </p:txBody>
@@ -4358,7 +4358,7 @@
         </p:nvSpPr>
         <p:spPr>
           <a:xfrm>
-            <a:off x="640080" y="5852160"/>
+            <a:off x="640080" y="5120640"/>
             <a:ext cx="10881360" cy="457200"/>
           </a:xfrm>
           <a:prstGeom prst="rect">
@@ -4374,11 +4374,89 @@
           <a:p>
             <a:pPr>
               <a:spcAft>
+                <a:spcPts val="560"/>
+              </a:spcAft>
+              <a:defRPr sz="1600" b="0">
+                <a:solidFill>
+                  <a:srgbClr val="AAAAAB"/>
+                </a:solidFill>
+                <a:latin typeface="Calibri"/>
+              </a:defRPr>
+            </a:pPr>
+            <a:r>
+              <a:t>Dex's contract on BSC Testnet</a:t>
+            </a:r>
+          </a:p>
+        </p:txBody>
+      </p:sp>
+      <p:sp>
+        <p:nvSpPr>
+          <p:cNvPr id="8" name="TextBox 7"/>
+          <p:cNvSpPr txBox="1"/>
+          <p:nvPr/>
+        </p:nvSpPr>
+        <p:spPr>
+          <a:xfrm>
+            <a:off x="640080" y="5486400"/>
+            <a:ext cx="10881360" cy="457200"/>
+          </a:xfrm>
+          <a:prstGeom prst="rect">
+            <a:avLst/>
+          </a:prstGeom>
+          <a:noFill/>
+        </p:spPr>
+        <p:txBody>
+          <a:bodyPr wrap="square">
+            <a:spAutoFit/>
+          </a:bodyPr>
+          <a:lstStyle/>
+          <a:p>
+            <a:pPr>
+              <a:spcAft>
                 <a:spcPts val="630"/>
               </a:spcAft>
               <a:defRPr sz="1800" b="0">
                 <a:solidFill>
-                  <a:srgbClr val="A6ABB8"/>
+                  <a:srgbClr val="F0B90B"/>
+                </a:solidFill>
+                <a:latin typeface="Consolas"/>
+              </a:defRPr>
+            </a:pPr>
+            <a:r>
+              <a:t>0x8b09ebB85Be8Ed55Bb5132d29eABc567c42aa83D</a:t>
+            </a:r>
+          </a:p>
+        </p:txBody>
+      </p:sp>
+      <p:sp>
+        <p:nvSpPr>
+          <p:cNvPr id="9" name="TextBox 8"/>
+          <p:cNvSpPr txBox="1"/>
+          <p:nvPr/>
+        </p:nvSpPr>
+        <p:spPr>
+          <a:xfrm>
+            <a:off x="640080" y="6172200"/>
+            <a:ext cx="10881360" cy="457200"/>
+          </a:xfrm>
+          <a:prstGeom prst="rect">
+            <a:avLst/>
+          </a:prstGeom>
+          <a:noFill/>
+        </p:spPr>
+        <p:txBody>
+          <a:bodyPr wrap="square">
+            <a:spAutoFit/>
+          </a:bodyPr>
+          <a:lstStyle/>
+          <a:p>
+            <a:pPr>
+              <a:spcAft>
+                <a:spcPts val="560"/>
+              </a:spcAft>
+              <a:defRPr sz="1600" b="0">
+                <a:solidFill>
+                  <a:srgbClr val="AAAAAB"/>
                 </a:solidFill>
                 <a:latin typeface="Calibri"/>
               </a:defRPr>
@@ -4443,7 +4521,7 @@
               </a:spcAft>
               <a:defRPr sz="3600" b="1">
                 <a:solidFill>
-                  <a:srgbClr val="F4F5F8"/>
+                  <a:srgbClr val="FFFFFF"/>
                 </a:solidFill>
                 <a:latin typeface="Calibri"/>
               </a:defRPr>
@@ -4482,7 +4560,7 @@
               </a:spcAft>
               <a:defRPr sz="1500" b="1">
                 <a:solidFill>
-                  <a:srgbClr val="E5BD71"/>
+                  <a:srgbClr val="FBBF24"/>
                 </a:solidFill>
                 <a:latin typeface="Calibri"/>
               </a:defRPr>
@@ -4521,7 +4599,7 @@
               </a:spcAft>
               <a:defRPr sz="1800" b="0">
                 <a:solidFill>
-                  <a:srgbClr val="F4F5F8"/>
+                  <a:srgbClr val="FFFFFF"/>
                 </a:solidFill>
                 <a:latin typeface="Calibri"/>
               </a:defRPr>
@@ -4537,7 +4615,7 @@
               </a:spcAft>
               <a:defRPr sz="1800" b="0">
                 <a:solidFill>
-                  <a:srgbClr val="F4F5F8"/>
+                  <a:srgbClr val="FFFFFF"/>
                 </a:solidFill>
                 <a:latin typeface="Calibri"/>
               </a:defRPr>
@@ -4553,7 +4631,7 @@
               </a:spcAft>
               <a:defRPr sz="1800" b="0">
                 <a:solidFill>
-                  <a:srgbClr val="F4F5F8"/>
+                  <a:srgbClr val="FFFFFF"/>
                 </a:solidFill>
                 <a:latin typeface="Calibri"/>
               </a:defRPr>
@@ -4569,7 +4647,7 @@
               </a:spcAft>
               <a:defRPr sz="1800" b="0">
                 <a:solidFill>
-                  <a:srgbClr val="F4F5F8"/>
+                  <a:srgbClr val="FFFFFF"/>
                 </a:solidFill>
                 <a:latin typeface="Calibri"/>
               </a:defRPr>
@@ -4585,7 +4663,7 @@
               </a:spcAft>
               <a:defRPr sz="1800" b="0">
                 <a:solidFill>
-                  <a:srgbClr val="F4F5F8"/>
+                  <a:srgbClr val="FFFFFF"/>
                 </a:solidFill>
                 <a:latin typeface="Calibri"/>
               </a:defRPr>
@@ -4601,7 +4679,7 @@
               </a:spcAft>
               <a:defRPr sz="1800" b="0">
                 <a:solidFill>
-                  <a:srgbClr val="F4F5F8"/>
+                  <a:srgbClr val="FFFFFF"/>
                 </a:solidFill>
                 <a:latin typeface="Calibri"/>
               </a:defRPr>
@@ -4660,7 +4738,7 @@
         <p:spPr>
           <a:xfrm>
             <a:off x="6766560" y="2560320"/>
-            <a:ext cx="4754880" cy="2743200"/>
+            <a:ext cx="4937760" cy="2743200"/>
           </a:xfrm>
           <a:prstGeom prst="rect">
             <a:avLst/>
@@ -4675,13 +4753,13 @@
           <a:p>
             <a:pPr>
               <a:spcAft>
-                <a:spcPts val="560"/>
-              </a:spcAft>
-              <a:defRPr sz="1600" b="0">
-                <a:solidFill>
-                  <a:srgbClr val="F4F5F8"/>
-                </a:solidFill>
-                <a:latin typeface="Calibri"/>
+                <a:spcPts val="525"/>
+              </a:spcAft>
+              <a:defRPr sz="1500" b="0">
+                <a:solidFill>
+                  <a:srgbClr val="FFFFFF"/>
+                </a:solidFill>
+                <a:latin typeface="Consolas"/>
               </a:defRPr>
             </a:pPr>
             <a:r>
@@ -4691,13 +4769,13 @@
           <a:p>
             <a:pPr>
               <a:spcAft>
-                <a:spcPts val="560"/>
-              </a:spcAft>
-              <a:defRPr sz="1600" b="0">
-                <a:solidFill>
-                  <a:srgbClr val="F4F5F8"/>
-                </a:solidFill>
-                <a:latin typeface="Calibri"/>
+                <a:spcPts val="525"/>
+              </a:spcAft>
+              <a:defRPr sz="1500" b="0">
+                <a:solidFill>
+                  <a:srgbClr val="FFFFFF"/>
+                </a:solidFill>
+                <a:latin typeface="Consolas"/>
               </a:defRPr>
             </a:pPr>
             <a:r>
@@ -4707,13 +4785,13 @@
           <a:p>
             <a:pPr>
               <a:spcAft>
-                <a:spcPts val="560"/>
-              </a:spcAft>
-              <a:defRPr sz="1600" b="0">
-                <a:solidFill>
-                  <a:srgbClr val="F4F5F8"/>
-                </a:solidFill>
-                <a:latin typeface="Calibri"/>
+                <a:spcPts val="525"/>
+              </a:spcAft>
+              <a:defRPr sz="1500" b="0">
+                <a:solidFill>
+                  <a:srgbClr val="FFFFFF"/>
+                </a:solidFill>
+                <a:latin typeface="Consolas"/>
               </a:defRPr>
             </a:pPr>
             <a:r>
@@ -4723,13 +4801,13 @@
           <a:p>
             <a:pPr>
               <a:spcAft>
-                <a:spcPts val="560"/>
-              </a:spcAft>
-              <a:defRPr sz="1600" b="0">
-                <a:solidFill>
-                  <a:srgbClr val="F4F5F8"/>
-                </a:solidFill>
-                <a:latin typeface="Calibri"/>
+                <a:spcPts val="525"/>
+              </a:spcAft>
+              <a:defRPr sz="1500" b="0">
+                <a:solidFill>
+                  <a:srgbClr val="FFFFFF"/>
+                </a:solidFill>
+                <a:latin typeface="Consolas"/>
               </a:defRPr>
             </a:pPr>
             <a:r>
@@ -4792,7 +4870,7 @@
               </a:spcAft>
               <a:defRPr sz="3600" b="1">
                 <a:solidFill>
-                  <a:srgbClr val="F4F5F8"/>
+                  <a:srgbClr val="FFFFFF"/>
                 </a:solidFill>
                 <a:latin typeface="Calibri"/>
               </a:defRPr>
@@ -4831,7 +4909,7 @@
               </a:spcAft>
               <a:defRPr sz="2400" b="0">
                 <a:solidFill>
-                  <a:srgbClr val="F4F5F8"/>
+                  <a:srgbClr val="FFFFFF"/>
                 </a:solidFill>
                 <a:latin typeface="Calibri"/>
               </a:defRPr>
@@ -4847,7 +4925,7 @@
               </a:spcAft>
               <a:defRPr sz="2400" b="0">
                 <a:solidFill>
-                  <a:srgbClr val="F4F5F8"/>
+                  <a:srgbClr val="FFFFFF"/>
                 </a:solidFill>
                 <a:latin typeface="Calibri"/>
               </a:defRPr>
@@ -4886,7 +4964,7 @@
               </a:spcAft>
               <a:defRPr sz="2800" b="1">
                 <a:solidFill>
-                  <a:srgbClr val="F0B90B"/>
+                  <a:srgbClr val="FFFFFF"/>
                 </a:solidFill>
                 <a:latin typeface="Calibri"/>
               </a:defRPr>
@@ -4925,7 +5003,7 @@
               </a:spcAft>
               <a:defRPr sz="2400" b="0">
                 <a:solidFill>
-                  <a:srgbClr val="F4F5F8"/>
+                  <a:srgbClr val="FFFFFF"/>
                 </a:solidFill>
                 <a:latin typeface="Calibri"/>
               </a:defRPr>
@@ -4941,7 +5019,7 @@
               </a:spcAft>
               <a:defRPr sz="2400" b="0">
                 <a:solidFill>
-                  <a:srgbClr val="F4F5F8"/>
+                  <a:srgbClr val="FFFFFF"/>
                 </a:solidFill>
                 <a:latin typeface="Calibri"/>
               </a:defRPr>
@@ -5006,7 +5084,7 @@
               </a:spcAft>
               <a:defRPr sz="3600" b="1">
                 <a:solidFill>
-                  <a:srgbClr val="F4F5F8"/>
+                  <a:srgbClr val="FFFFFF"/>
                 </a:solidFill>
                 <a:latin typeface="Calibri"/>
               </a:defRPr>
@@ -5045,7 +5123,7 @@
               </a:spcAft>
               <a:defRPr sz="1500" b="1">
                 <a:solidFill>
-                  <a:srgbClr val="E5BD71"/>
+                  <a:srgbClr val="FBBF24"/>
                 </a:solidFill>
                 <a:latin typeface="Calibri"/>
               </a:defRPr>
@@ -5084,7 +5162,7 @@
               </a:spcAft>
               <a:defRPr sz="2400" b="1">
                 <a:solidFill>
-                  <a:srgbClr val="AEB9F4"/>
+                  <a:srgbClr val="FFFFFF"/>
                 </a:solidFill>
                 <a:latin typeface="Calibri"/>
               </a:defRPr>
@@ -5123,7 +5201,7 @@
               </a:spcAft>
               <a:defRPr sz="1800" b="0">
                 <a:solidFill>
-                  <a:srgbClr val="F4F5F8"/>
+                  <a:srgbClr val="FFFFFF"/>
                 </a:solidFill>
                 <a:latin typeface="Calibri"/>
               </a:defRPr>
@@ -5139,7 +5217,7 @@
               </a:spcAft>
               <a:defRPr sz="1800" b="0">
                 <a:solidFill>
-                  <a:srgbClr val="F4F5F8"/>
+                  <a:srgbClr val="FFFFFF"/>
                 </a:solidFill>
                 <a:latin typeface="Calibri"/>
               </a:defRPr>
@@ -5155,7 +5233,7 @@
               </a:spcAft>
               <a:defRPr sz="1800" b="0">
                 <a:solidFill>
-                  <a:srgbClr val="F4F5F8"/>
+                  <a:srgbClr val="FFFFFF"/>
                 </a:solidFill>
                 <a:latin typeface="Calibri"/>
               </a:defRPr>
@@ -5194,7 +5272,7 @@
               </a:spcAft>
               <a:defRPr sz="2400" b="1">
                 <a:solidFill>
-                  <a:srgbClr val="F0B90B"/>
+                  <a:srgbClr val="FFFFFF"/>
                 </a:solidFill>
                 <a:latin typeface="Calibri"/>
               </a:defRPr>
@@ -5233,7 +5311,7 @@
               </a:spcAft>
               <a:defRPr sz="1800" b="0">
                 <a:solidFill>
-                  <a:srgbClr val="F4F5F8"/>
+                  <a:srgbClr val="FFFFFF"/>
                 </a:solidFill>
                 <a:latin typeface="Calibri"/>
               </a:defRPr>
@@ -5249,7 +5327,7 @@
               </a:spcAft>
               <a:defRPr sz="1800" b="0">
                 <a:solidFill>
-                  <a:srgbClr val="F4F5F8"/>
+                  <a:srgbClr val="FFFFFF"/>
                 </a:solidFill>
                 <a:latin typeface="Calibri"/>
               </a:defRPr>
@@ -5265,13 +5343,13 @@
               </a:spcAft>
               <a:defRPr sz="1800" b="0">
                 <a:solidFill>
-                  <a:srgbClr val="F4F5F8"/>
-                </a:solidFill>
-                <a:latin typeface="Calibri"/>
-              </a:defRPr>
-            </a:pPr>
-            <a:r>
-              <a:t>No custody and no performance fee; on-chain cost per decision stays tiny (next slides)</a:t>
+                  <a:srgbClr val="FFFFFF"/>
+                </a:solidFill>
+                <a:latin typeface="Calibri"/>
+              </a:defRPr>
+            </a:pPr>
+            <a:r>
+              <a:t>No custody and no performance fee; on-chain cost per decision stays tiny (slide 7)</a:t>
             </a:r>
           </a:p>
         </p:txBody>
@@ -5330,7 +5408,7 @@
               </a:spcAft>
               <a:defRPr sz="3600" b="1">
                 <a:solidFill>
-                  <a:srgbClr val="F4F5F8"/>
+                  <a:srgbClr val="FFFFFF"/>
                 </a:solidFill>
                 <a:latin typeface="Calibri"/>
               </a:defRPr>
@@ -5369,7 +5447,7 @@
               </a:spcAft>
               <a:defRPr sz="2400" b="1">
                 <a:solidFill>
-                  <a:srgbClr val="AEB9F4"/>
+                  <a:srgbClr val="9AA8F0"/>
                 </a:solidFill>
                 <a:latin typeface="Calibri"/>
               </a:defRPr>
@@ -5408,7 +5486,7 @@
               </a:spcAft>
               <a:defRPr sz="2000" b="0">
                 <a:solidFill>
-                  <a:srgbClr val="F4F5F8"/>
+                  <a:srgbClr val="FFFFFF"/>
                 </a:solidFill>
                 <a:latin typeface="Calibri"/>
               </a:defRPr>
@@ -5447,7 +5525,7 @@
               </a:spcAft>
               <a:defRPr sz="2400" b="1">
                 <a:solidFill>
-                  <a:srgbClr val="F0B90B"/>
+                  <a:srgbClr val="FFFFFF"/>
                 </a:solidFill>
                 <a:latin typeface="Calibri"/>
               </a:defRPr>
@@ -5486,7 +5564,7 @@
               </a:spcAft>
               <a:defRPr sz="2000" b="0">
                 <a:solidFill>
-                  <a:srgbClr val="F4F5F8"/>
+                  <a:srgbClr val="FFFFFF"/>
                 </a:solidFill>
                 <a:latin typeface="Calibri"/>
               </a:defRPr>
@@ -5525,7 +5603,7 @@
               </a:spcAft>
               <a:defRPr sz="2400" b="1">
                 <a:solidFill>
-                  <a:srgbClr val="AEB9F4"/>
+                  <a:srgbClr val="9AA8F0"/>
                 </a:solidFill>
                 <a:latin typeface="Calibri"/>
               </a:defRPr>
@@ -5564,7 +5642,7 @@
               </a:spcAft>
               <a:defRPr sz="2000" b="0">
                 <a:solidFill>
-                  <a:srgbClr val="F4F5F8"/>
+                  <a:srgbClr val="FFFFFF"/>
                 </a:solidFill>
                 <a:latin typeface="Calibri"/>
               </a:defRPr>
@@ -5603,7 +5681,7 @@
               </a:spcAft>
               <a:defRPr sz="2400" b="1">
                 <a:solidFill>
-                  <a:srgbClr val="F0B90B"/>
+                  <a:srgbClr val="FFFFFF"/>
                 </a:solidFill>
                 <a:latin typeface="Calibri"/>
               </a:defRPr>
@@ -5642,7 +5720,7 @@
               </a:spcAft>
               <a:defRPr sz="2000" b="0">
                 <a:solidFill>
-                  <a:srgbClr val="F4F5F8"/>
+                  <a:srgbClr val="FFFFFF"/>
                 </a:solidFill>
                 <a:latin typeface="Calibri"/>
               </a:defRPr>
@@ -5661,8 +5739,8 @@
         </p:nvSpPr>
         <p:spPr>
           <a:xfrm>
-            <a:off x="640080" y="5760720"/>
-            <a:ext cx="10881360" cy="548640"/>
+            <a:off x="640080" y="5577840"/>
+            <a:ext cx="10881360" cy="457200"/>
           </a:xfrm>
           <a:prstGeom prst="rect">
             <a:avLst/>
@@ -5677,11 +5755,50 @@
           <a:p>
             <a:pPr>
               <a:spcAft>
+                <a:spcPts val="489"/>
+              </a:spcAft>
+              <a:defRPr sz="1400" b="0">
+                <a:solidFill>
+                  <a:srgbClr val="AAAAAB"/>
+                </a:solidFill>
+                <a:latin typeface="Calibri"/>
+              </a:defRPr>
+            </a:pPr>
+            <a:r>
+              <a:t>Periwinkle: off-chain engine · white: on-chain contract</a:t>
+            </a:r>
+          </a:p>
+        </p:txBody>
+      </p:sp>
+      <p:sp>
+        <p:nvSpPr>
+          <p:cNvPr id="12" name="TextBox 11"/>
+          <p:cNvSpPr txBox="1"/>
+          <p:nvPr/>
+        </p:nvSpPr>
+        <p:spPr>
+          <a:xfrm>
+            <a:off x="640080" y="5943600"/>
+            <a:ext cx="10881360" cy="548640"/>
+          </a:xfrm>
+          <a:prstGeom prst="rect">
+            <a:avLst/>
+          </a:prstGeom>
+          <a:noFill/>
+        </p:spPr>
+        <p:txBody>
+          <a:bodyPr wrap="square">
+            <a:spAutoFit/>
+          </a:bodyPr>
+          <a:lstStyle/>
+          <a:p>
+            <a:pPr>
+              <a:spcAft>
                 <a:spcPts val="630"/>
               </a:spcAft>
               <a:defRPr sz="1800" b="0">
                 <a:solidFill>
-                  <a:srgbClr val="A6ABB8"/>
+                  <a:srgbClr val="AAAAAB"/>
                 </a:solidFill>
                 <a:latin typeface="Calibri"/>
               </a:defRPr>
@@ -5746,7 +5863,7 @@
               </a:spcAft>
               <a:defRPr sz="3600" b="1">
                 <a:solidFill>
-                  <a:srgbClr val="F4F5F8"/>
+                  <a:srgbClr val="FFFFFF"/>
                 </a:solidFill>
                 <a:latin typeface="Calibri"/>
               </a:defRPr>
@@ -5833,7 +5950,7 @@
               </a:spcAft>
               <a:defRPr sz="1600" b="0">
                 <a:solidFill>
-                  <a:srgbClr val="A6ABB8"/>
+                  <a:srgbClr val="AAAAAB"/>
                 </a:solidFill>
                 <a:latin typeface="Calibri"/>
               </a:defRPr>
@@ -5849,7 +5966,7 @@
               </a:spcAft>
               <a:defRPr sz="1600" b="0">
                 <a:solidFill>
-                  <a:srgbClr val="A6ABB8"/>
+                  <a:srgbClr val="AAAAAB"/>
                 </a:solidFill>
                 <a:latin typeface="Calibri"/>
               </a:defRPr>
@@ -5888,7 +6005,7 @@
               </a:spcAft>
               <a:defRPr sz="1600" b="0">
                 <a:solidFill>
-                  <a:srgbClr val="A6ABB8"/>
+                  <a:srgbClr val="AAAAAB"/>
                 </a:solidFill>
                 <a:latin typeface="Calibri"/>
               </a:defRPr>
@@ -5904,7 +6021,7 @@
               </a:spcAft>
               <a:defRPr sz="1600" b="0">
                 <a:solidFill>
-                  <a:srgbClr val="A6ABB8"/>
+                  <a:srgbClr val="AAAAAB"/>
                 </a:solidFill>
                 <a:latin typeface="Calibri"/>
               </a:defRPr>
@@ -5969,7 +6086,7 @@
               </a:spcAft>
               <a:defRPr sz="3600" b="1">
                 <a:solidFill>
-                  <a:srgbClr val="F4F5F8"/>
+                  <a:srgbClr val="FFFFFF"/>
                 </a:solidFill>
                 <a:latin typeface="Calibri"/>
               </a:defRPr>
@@ -5995,7 +6112,7 @@
             <a:avLst/>
           </a:prstGeom>
           <a:solidFill>
-            <a:srgbClr val="1F4D3B"/>
+            <a:srgbClr val="153E32"/>
           </a:solidFill>
           <a:ln>
             <a:noFill/>
@@ -6038,7 +6155,7 @@
             <a:avLst/>
           </a:prstGeom>
           <a:solidFill>
-            <a:srgbClr val="5A232D"/>
+            <a:srgbClr val="47252C"/>
           </a:solidFill>
           <a:ln>
             <a:noFill/>
@@ -6124,7 +6241,7 @@
             <a:avLst/>
           </a:prstGeom>
           <a:solidFill>
-            <a:srgbClr val="78D5AB"/>
+            <a:srgbClr val="34D399"/>
           </a:solidFill>
           <a:ln>
             <a:noFill/>
@@ -6262,7 +6379,7 @@
               </a:spcAft>
               <a:defRPr sz="1400" b="0">
                 <a:solidFill>
-                  <a:srgbClr val="78D5AB"/>
+                  <a:srgbClr val="34D399"/>
                 </a:solidFill>
                 <a:latin typeface="Calibri"/>
               </a:defRPr>
@@ -6336,13 +6453,13 @@
           <a:p>
             <a:pPr>
               <a:spcAft>
-                <a:spcPts val="594"/>
-              </a:spcAft>
-              <a:defRPr sz="1700" b="0">
+                <a:spcPts val="560"/>
+              </a:spcAft>
+              <a:defRPr sz="1600" b="0">
                 <a:solidFill>
                   <a:srgbClr val="F0B90B"/>
                 </a:solidFill>
-                <a:latin typeface="Calibri"/>
+                <a:latin typeface="Consolas"/>
               </a:defRPr>
             </a:pPr>
             <a:r>
@@ -6375,13 +6492,13 @@
           <a:p>
             <a:pPr>
               <a:spcAft>
-                <a:spcPts val="594"/>
-              </a:spcAft>
-              <a:defRPr sz="1700" b="0">
-                <a:solidFill>
-                  <a:srgbClr val="F4F5F8"/>
-                </a:solidFill>
-                <a:latin typeface="Calibri"/>
+                <a:spcPts val="560"/>
+              </a:spcAft>
+              <a:defRPr sz="1600" b="0">
+                <a:solidFill>
+                  <a:srgbClr val="FFFFFF"/>
+                </a:solidFill>
+                <a:latin typeface="Consolas"/>
               </a:defRPr>
             </a:pPr>
             <a:r>
@@ -6418,7 +6535,7 @@
               </a:spcAft>
               <a:defRPr sz="1700" b="0">
                 <a:solidFill>
-                  <a:srgbClr val="A6ABB8"/>
+                  <a:srgbClr val="AAAAAB"/>
                 </a:solidFill>
                 <a:latin typeface="Calibri"/>
               </a:defRPr>
@@ -6453,13 +6570,13 @@
           <a:p>
             <a:pPr>
               <a:spcAft>
-                <a:spcPts val="594"/>
-              </a:spcAft>
-              <a:defRPr sz="1700" b="0">
+                <a:spcPts val="560"/>
+              </a:spcAft>
+              <a:defRPr sz="1600" b="0">
                 <a:solidFill>
                   <a:srgbClr val="F0B90B"/>
                 </a:solidFill>
-                <a:latin typeface="Calibri"/>
+                <a:latin typeface="Consolas"/>
               </a:defRPr>
             </a:pPr>
             <a:r>
@@ -6492,13 +6609,13 @@
           <a:p>
             <a:pPr>
               <a:spcAft>
-                <a:spcPts val="594"/>
-              </a:spcAft>
-              <a:defRPr sz="1700" b="0">
-                <a:solidFill>
-                  <a:srgbClr val="F4F5F8"/>
-                </a:solidFill>
-                <a:latin typeface="Calibri"/>
+                <a:spcPts val="560"/>
+              </a:spcAft>
+              <a:defRPr sz="1600" b="0">
+                <a:solidFill>
+                  <a:srgbClr val="FFFFFF"/>
+                </a:solidFill>
+                <a:latin typeface="Consolas"/>
               </a:defRPr>
             </a:pPr>
             <a:r>
@@ -6535,7 +6652,7 @@
               </a:spcAft>
               <a:defRPr sz="1700" b="0">
                 <a:solidFill>
-                  <a:srgbClr val="78D5AB"/>
+                  <a:srgbClr val="34D399"/>
                 </a:solidFill>
                 <a:latin typeface="Calibri"/>
               </a:defRPr>
@@ -6561,7 +6678,7 @@
             <a:avLst/>
           </a:prstGeom>
           <a:solidFill>
-            <a:srgbClr val="16171B"/>
+            <a:srgbClr val="1A1B1D"/>
           </a:solidFill>
           <a:ln>
             <a:noFill/>
@@ -6613,13 +6730,13 @@
           <a:p>
             <a:pPr>
               <a:spcAft>
-                <a:spcPts val="594"/>
-              </a:spcAft>
-              <a:defRPr sz="1700" b="0">
+                <a:spcPts val="560"/>
+              </a:spcAft>
+              <a:defRPr sz="1600" b="0">
                 <a:solidFill>
                   <a:srgbClr val="F0B90B"/>
                 </a:solidFill>
-                <a:latin typeface="Calibri"/>
+                <a:latin typeface="Consolas"/>
               </a:defRPr>
             </a:pPr>
             <a:r>
@@ -6652,13 +6769,13 @@
           <a:p>
             <a:pPr>
               <a:spcAft>
-                <a:spcPts val="594"/>
-              </a:spcAft>
-              <a:defRPr sz="1700" b="1">
-                <a:solidFill>
-                  <a:srgbClr val="F4F5F8"/>
-                </a:solidFill>
-                <a:latin typeface="Calibri"/>
+                <a:spcPts val="560"/>
+              </a:spcAft>
+              <a:defRPr sz="1600" b="1">
+                <a:solidFill>
+                  <a:srgbClr val="FFFFFF"/>
+                </a:solidFill>
+                <a:latin typeface="Consolas"/>
               </a:defRPr>
             </a:pPr>
             <a:r>
@@ -6730,13 +6847,13 @@
           <a:p>
             <a:pPr>
               <a:spcAft>
-                <a:spcPts val="594"/>
-              </a:spcAft>
-              <a:defRPr sz="1700" b="0">
+                <a:spcPts val="560"/>
+              </a:spcAft>
+              <a:defRPr sz="1600" b="0">
                 <a:solidFill>
                   <a:srgbClr val="F0B90B"/>
                 </a:solidFill>
-                <a:latin typeface="Calibri"/>
+                <a:latin typeface="Consolas"/>
               </a:defRPr>
             </a:pPr>
             <a:r>
@@ -6769,13 +6886,13 @@
           <a:p>
             <a:pPr>
               <a:spcAft>
-                <a:spcPts val="594"/>
-              </a:spcAft>
-              <a:defRPr sz="1700" b="0">
-                <a:solidFill>
-                  <a:srgbClr val="F4F5F8"/>
-                </a:solidFill>
-                <a:latin typeface="Calibri"/>
+                <a:spcPts val="560"/>
+              </a:spcAft>
+              <a:defRPr sz="1600" b="0">
+                <a:solidFill>
+                  <a:srgbClr val="FFFFFF"/>
+                </a:solidFill>
+                <a:latin typeface="Consolas"/>
               </a:defRPr>
             </a:pPr>
             <a:r>
@@ -6812,7 +6929,7 @@
               </a:spcAft>
               <a:defRPr sz="1700" b="0">
                 <a:solidFill>
-                  <a:srgbClr val="A6ABB8"/>
+                  <a:srgbClr val="AAAAAB"/>
                 </a:solidFill>
                 <a:latin typeface="Calibri"/>
               </a:defRPr>
@@ -6847,13 +6964,13 @@
           <a:p>
             <a:pPr>
               <a:spcAft>
-                <a:spcPts val="594"/>
-              </a:spcAft>
-              <a:defRPr sz="1700" b="0">
+                <a:spcPts val="560"/>
+              </a:spcAft>
+              <a:defRPr sz="1600" b="0">
                 <a:solidFill>
                   <a:srgbClr val="F0B90B"/>
                 </a:solidFill>
-                <a:latin typeface="Calibri"/>
+                <a:latin typeface="Consolas"/>
               </a:defRPr>
             </a:pPr>
             <a:r>
@@ -6886,13 +7003,13 @@
           <a:p>
             <a:pPr>
               <a:spcAft>
-                <a:spcPts val="594"/>
-              </a:spcAft>
-              <a:defRPr sz="1700" b="0">
-                <a:solidFill>
-                  <a:srgbClr val="F4F5F8"/>
-                </a:solidFill>
-                <a:latin typeface="Calibri"/>
+                <a:spcPts val="560"/>
+              </a:spcAft>
+              <a:defRPr sz="1600" b="0">
+                <a:solidFill>
+                  <a:srgbClr val="FFFFFF"/>
+                </a:solidFill>
+                <a:latin typeface="Consolas"/>
               </a:defRPr>
             </a:pPr>
             <a:r>
@@ -6929,7 +7046,7 @@
               </a:spcAft>
               <a:defRPr sz="1700" b="0">
                 <a:solidFill>
-                  <a:srgbClr val="A6ABB8"/>
+                  <a:srgbClr val="AAAAAB"/>
                 </a:solidFill>
                 <a:latin typeface="Calibri"/>
               </a:defRPr>
@@ -6968,7 +7085,7 @@
               </a:spcAft>
               <a:defRPr sz="1400" b="0">
                 <a:solidFill>
-                  <a:srgbClr val="A6ABB8"/>
+                  <a:srgbClr val="AAAAAB"/>
                 </a:solidFill>
                 <a:latin typeface="Calibri"/>
               </a:defRPr>
@@ -7033,7 +7150,7 @@
               </a:spcAft>
               <a:defRPr sz="3600" b="1">
                 <a:solidFill>
-                  <a:srgbClr val="F4F5F8"/>
+                  <a:srgbClr val="FFFFFF"/>
                 </a:solidFill>
                 <a:latin typeface="Calibri"/>
               </a:defRPr>
@@ -7072,7 +7189,7 @@
               </a:spcAft>
               <a:defRPr sz="4000" b="1">
                 <a:solidFill>
-                  <a:srgbClr val="F0B90B"/>
+                  <a:srgbClr val="FFFFFF"/>
                 </a:solidFill>
                 <a:latin typeface="Calibri"/>
               </a:defRPr>
@@ -7111,7 +7228,7 @@
               </a:spcAft>
               <a:defRPr sz="1800" b="0">
                 <a:solidFill>
-                  <a:srgbClr val="F4F5F8"/>
+                  <a:srgbClr val="AAAAAB"/>
                 </a:solidFill>
                 <a:latin typeface="Calibri"/>
               </a:defRPr>
@@ -7127,7 +7244,7 @@
               </a:spcAft>
               <a:defRPr sz="1800" b="0">
                 <a:solidFill>
-                  <a:srgbClr val="F4F5F8"/>
+                  <a:srgbClr val="AAAAAB"/>
                 </a:solidFill>
                 <a:latin typeface="Calibri"/>
               </a:defRPr>
@@ -7166,7 +7283,7 @@
               </a:spcAft>
               <a:defRPr sz="3000" b="1">
                 <a:solidFill>
-                  <a:srgbClr val="F0B90B"/>
+                  <a:srgbClr val="FFFFFF"/>
                 </a:solidFill>
                 <a:latin typeface="Calibri"/>
               </a:defRPr>
@@ -7205,7 +7322,7 @@
               </a:spcAft>
               <a:defRPr sz="1800" b="0">
                 <a:solidFill>
-                  <a:srgbClr val="F4F5F8"/>
+                  <a:srgbClr val="AAAAAB"/>
                 </a:solidFill>
                 <a:latin typeface="Calibri"/>
               </a:defRPr>
@@ -7221,7 +7338,7 @@
               </a:spcAft>
               <a:defRPr sz="1800" b="0">
                 <a:solidFill>
-                  <a:srgbClr val="F4F5F8"/>
+                  <a:srgbClr val="AAAAAB"/>
                 </a:solidFill>
                 <a:latin typeface="Calibri"/>
               </a:defRPr>
@@ -7260,7 +7377,7 @@
               </a:spcAft>
               <a:defRPr sz="2400" b="1">
                 <a:solidFill>
-                  <a:srgbClr val="AEB9F4"/>
+                  <a:srgbClr val="FFFFFF"/>
                 </a:solidFill>
                 <a:latin typeface="Calibri"/>
               </a:defRPr>
@@ -7299,7 +7416,7 @@
               </a:spcAft>
               <a:defRPr sz="1800" b="0">
                 <a:solidFill>
-                  <a:srgbClr val="F4F5F8"/>
+                  <a:srgbClr val="FFFFFF"/>
                 </a:solidFill>
                 <a:latin typeface="Calibri"/>
               </a:defRPr>
@@ -7315,7 +7432,7 @@
               </a:spcAft>
               <a:defRPr sz="1800" b="0">
                 <a:solidFill>
-                  <a:srgbClr val="F4F5F8"/>
+                  <a:srgbClr val="FFFFFF"/>
                 </a:solidFill>
                 <a:latin typeface="Calibri"/>
               </a:defRPr>
@@ -7331,7 +7448,7 @@
               </a:spcAft>
               <a:defRPr sz="1800" b="0">
                 <a:solidFill>
-                  <a:srgbClr val="F4F5F8"/>
+                  <a:srgbClr val="FFFFFF"/>
                 </a:solidFill>
                 <a:latin typeface="Calibri"/>
               </a:defRPr>
@@ -7347,7 +7464,7 @@
               </a:spcAft>
               <a:defRPr sz="1800" b="0">
                 <a:solidFill>
-                  <a:srgbClr val="F4F5F8"/>
+                  <a:srgbClr val="FFFFFF"/>
                 </a:solidFill>
                 <a:latin typeface="Calibri"/>
               </a:defRPr>
@@ -7386,7 +7503,7 @@
               </a:spcAft>
               <a:defRPr sz="1400" b="0">
                 <a:solidFill>
-                  <a:srgbClr val="A6ABB8"/>
+                  <a:srgbClr val="AAAAAB"/>
                 </a:solidFill>
                 <a:latin typeface="Calibri"/>
               </a:defRPr>
@@ -7451,7 +7568,7 @@
               </a:spcAft>
               <a:defRPr sz="3600" b="1">
                 <a:solidFill>
-                  <a:srgbClr val="F4F5F8"/>
+                  <a:srgbClr val="FFFFFF"/>
                 </a:solidFill>
                 <a:latin typeface="Calibri"/>
               </a:defRPr>
@@ -7490,7 +7607,7 @@
               </a:spcAft>
               <a:defRPr sz="3400" b="1">
                 <a:solidFill>
-                  <a:srgbClr val="78D5AB"/>
+                  <a:srgbClr val="34D399"/>
                 </a:solidFill>
                 <a:latin typeface="Calibri"/>
               </a:defRPr>
@@ -7529,7 +7646,7 @@
               </a:spcAft>
               <a:defRPr sz="1400" b="0">
                 <a:solidFill>
-                  <a:srgbClr val="F4F5F8"/>
+                  <a:srgbClr val="FFFFFF"/>
                 </a:solidFill>
                 <a:latin typeface="Calibri"/>
               </a:defRPr>
@@ -7545,7 +7662,7 @@
               </a:spcAft>
               <a:defRPr sz="1400" b="0">
                 <a:solidFill>
-                  <a:srgbClr val="F4F5F8"/>
+                  <a:srgbClr val="FFFFFF"/>
                 </a:solidFill>
                 <a:latin typeface="Calibri"/>
               </a:defRPr>
@@ -7584,13 +7701,13 @@
               </a:spcAft>
               <a:defRPr sz="3400" b="1">
                 <a:solidFill>
-                  <a:srgbClr val="78D5AB"/>
-                </a:solidFill>
-                <a:latin typeface="Calibri"/>
-              </a:defRPr>
-            </a:pPr>
-            <a:r>
-              <a:t>45</a:t>
+                  <a:srgbClr val="34D399"/>
+                </a:solidFill>
+                <a:latin typeface="Calibri"/>
+              </a:defRPr>
+            </a:pPr>
+            <a:r>
+              <a:t>47</a:t>
             </a:r>
           </a:p>
         </p:txBody>
@@ -7623,7 +7740,7 @@
               </a:spcAft>
               <a:defRPr sz="1400" b="0">
                 <a:solidFill>
-                  <a:srgbClr val="F4F5F8"/>
+                  <a:srgbClr val="FFFFFF"/>
                 </a:solidFill>
                 <a:latin typeface="Calibri"/>
               </a:defRPr>
@@ -7639,7 +7756,7 @@
               </a:spcAft>
               <a:defRPr sz="1400" b="0">
                 <a:solidFill>
-                  <a:srgbClr val="F4F5F8"/>
+                  <a:srgbClr val="FFFFFF"/>
                 </a:solidFill>
                 <a:latin typeface="Calibri"/>
               </a:defRPr>
@@ -7678,7 +7795,7 @@
               </a:spcAft>
               <a:defRPr sz="3400" b="1">
                 <a:solidFill>
-                  <a:srgbClr val="78D5AB"/>
+                  <a:srgbClr val="34D399"/>
                 </a:solidFill>
                 <a:latin typeface="Calibri"/>
               </a:defRPr>
@@ -7717,7 +7834,7 @@
               </a:spcAft>
               <a:defRPr sz="1400" b="0">
                 <a:solidFill>
-                  <a:srgbClr val="F4F5F8"/>
+                  <a:srgbClr val="FFFFFF"/>
                 </a:solidFill>
                 <a:latin typeface="Calibri"/>
               </a:defRPr>
@@ -7733,7 +7850,7 @@
               </a:spcAft>
               <a:defRPr sz="1400" b="0">
                 <a:solidFill>
-                  <a:srgbClr val="F4F5F8"/>
+                  <a:srgbClr val="FFFFFF"/>
                 </a:solidFill>
                 <a:latin typeface="Calibri"/>
               </a:defRPr>
@@ -7811,7 +7928,7 @@
               </a:spcAft>
               <a:defRPr sz="1400" b="0">
                 <a:solidFill>
-                  <a:srgbClr val="F4F5F8"/>
+                  <a:srgbClr val="FFFFFF"/>
                 </a:solidFill>
                 <a:latin typeface="Calibri"/>
               </a:defRPr>
@@ -7827,7 +7944,7 @@
               </a:spcAft>
               <a:defRPr sz="1400" b="0">
                 <a:solidFill>
-                  <a:srgbClr val="F4F5F8"/>
+                  <a:srgbClr val="FFFFFF"/>
                 </a:solidFill>
                 <a:latin typeface="Calibri"/>
               </a:defRPr>
@@ -7866,7 +7983,7 @@
               </a:spcAft>
               <a:defRPr sz="2200" b="1">
                 <a:solidFill>
-                  <a:srgbClr val="E5BD71"/>
+                  <a:srgbClr val="FBBF24"/>
                 </a:solidFill>
                 <a:latin typeface="Calibri"/>
               </a:defRPr>
@@ -7905,7 +8022,7 @@
               </a:spcAft>
               <a:defRPr sz="1600" b="0">
                 <a:solidFill>
-                  <a:srgbClr val="F4F5F8"/>
+                  <a:srgbClr val="FFFFFF"/>
                 </a:solidFill>
                 <a:latin typeface="Calibri"/>
               </a:defRPr>
@@ -7921,7 +8038,7 @@
               </a:spcAft>
               <a:defRPr sz="1600" b="0">
                 <a:solidFill>
-                  <a:srgbClr val="F4F5F8"/>
+                  <a:srgbClr val="FFFFFF"/>
                 </a:solidFill>
                 <a:latin typeface="Calibri"/>
               </a:defRPr>
@@ -7986,7 +8103,7 @@
               </a:spcAft>
               <a:defRPr sz="3600" b="1">
                 <a:solidFill>
-                  <a:srgbClr val="F4F5F8"/>
+                  <a:srgbClr val="FFFFFF"/>
                 </a:solidFill>
                 <a:latin typeface="Calibri"/>
               </a:defRPr>
@@ -8025,7 +8142,7 @@
               </a:spcAft>
               <a:defRPr sz="2400" b="1">
                 <a:solidFill>
-                  <a:srgbClr val="A6ABB8"/>
+                  <a:srgbClr val="AAAAAB"/>
                 </a:solidFill>
                 <a:latin typeface="Calibri"/>
               </a:defRPr>
@@ -8064,7 +8181,7 @@
               </a:spcAft>
               <a:defRPr sz="1800" b="0">
                 <a:solidFill>
-                  <a:srgbClr val="F4F5F8"/>
+                  <a:srgbClr val="FFFFFF"/>
                 </a:solidFill>
                 <a:latin typeface="Calibri"/>
               </a:defRPr>
@@ -8080,7 +8197,23 @@
               </a:spcAft>
               <a:defRPr sz="1800" b="0">
                 <a:solidFill>
-                  <a:srgbClr val="F4F5F8"/>
+                  <a:srgbClr val="FFFFFF"/>
+                </a:solidFill>
+                <a:latin typeface="Calibri"/>
+              </a:defRPr>
+            </a:pPr>
+            <a:r>
+              <a:t>7 contract tests</a:t>
+            </a:r>
+          </a:p>
+          <a:p>
+            <a:pPr>
+              <a:spcAft>
+                <a:spcPts val="630"/>
+              </a:spcAft>
+              <a:defRPr sz="1800" b="0">
+                <a:solidFill>
+                  <a:srgbClr val="FFFFFF"/>
                 </a:solidFill>
                 <a:latin typeface="Calibri"/>
               </a:defRPr>
@@ -8096,7 +8229,7 @@
               </a:spcAft>
               <a:defRPr sz="1800" b="0">
                 <a:solidFill>
-                  <a:srgbClr val="F4F5F8"/>
+                  <a:srgbClr val="FFFFFF"/>
                 </a:solidFill>
                 <a:latin typeface="Calibri"/>
               </a:defRPr>
@@ -8112,7 +8245,7 @@
               </a:spcAft>
               <a:defRPr sz="1800" b="0">
                 <a:solidFill>
-                  <a:srgbClr val="F4F5F8"/>
+                  <a:srgbClr val="FFFFFF"/>
                 </a:solidFill>
                 <a:latin typeface="Calibri"/>
               </a:defRPr>
@@ -8151,7 +8284,7 @@
               </a:spcAft>
               <a:defRPr sz="2400" b="1">
                 <a:solidFill>
-                  <a:srgbClr val="F0B90B"/>
+                  <a:srgbClr val="FFFFFF"/>
                 </a:solidFill>
                 <a:latin typeface="Calibri"/>
               </a:defRPr>
@@ -8190,7 +8323,7 @@
               </a:spcAft>
               <a:defRPr sz="1700" b="0">
                 <a:solidFill>
-                  <a:srgbClr val="F4F5F8"/>
+                  <a:srgbClr val="FFFFFF"/>
                 </a:solidFill>
                 <a:latin typeface="Calibri"/>
               </a:defRPr>
@@ -8206,7 +8339,7 @@
               </a:spcAft>
               <a:defRPr sz="1700" b="0">
                 <a:solidFill>
-                  <a:srgbClr val="F4F5F8"/>
+                  <a:srgbClr val="FFFFFF"/>
                 </a:solidFill>
                 <a:latin typeface="Calibri"/>
               </a:defRPr>
@@ -8222,7 +8355,7 @@
               </a:spcAft>
               <a:defRPr sz="1700" b="0">
                 <a:solidFill>
-                  <a:srgbClr val="F4F5F8"/>
+                  <a:srgbClr val="FFFFFF"/>
                 </a:solidFill>
                 <a:latin typeface="Calibri"/>
               </a:defRPr>
@@ -8238,7 +8371,7 @@
               </a:spcAft>
               <a:defRPr sz="1700" b="0">
                 <a:solidFill>
-                  <a:srgbClr val="F4F5F8"/>
+                  <a:srgbClr val="FFFFFF"/>
                 </a:solidFill>
                 <a:latin typeface="Calibri"/>
               </a:defRPr>
@@ -8254,13 +8387,13 @@
               </a:spcAft>
               <a:defRPr sz="1700" b="0">
                 <a:solidFill>
-                  <a:srgbClr val="F4F5F8"/>
-                </a:solidFill>
-                <a:latin typeface="Calibri"/>
-              </a:defRPr>
-            </a:pPr>
-            <a:r>
-              <a:t>23 contract + 45 engine + 8 web tests, CI</a:t>
+                  <a:srgbClr val="FFFFFF"/>
+                </a:solidFill>
+                <a:latin typeface="Calibri"/>
+              </a:defRPr>
+            </a:pPr>
+            <a:r>
+              <a:t>+23 contract tests, 47 engine tests, 15 web tests, CI</a:t>
             </a:r>
           </a:p>
           <a:p>
@@ -8270,7 +8403,7 @@
               </a:spcAft>
               <a:defRPr sz="1700" b="0">
                 <a:solidFill>
-                  <a:srgbClr val="F4F5F8"/>
+                  <a:srgbClr val="FFFFFF"/>
                 </a:solidFill>
                 <a:latin typeface="Calibri"/>
               </a:defRPr>
@@ -8286,7 +8419,7 @@
               </a:spcAft>
               <a:defRPr sz="1700" b="0">
                 <a:solidFill>
-                  <a:srgbClr val="F4F5F8"/>
+                  <a:srgbClr val="FFFFFF"/>
                 </a:solidFill>
                 <a:latin typeface="Calibri"/>
               </a:defRPr>
@@ -8325,9 +8458,9 @@
               </a:spcAft>
               <a:defRPr sz="1600" b="0">
                 <a:solidFill>
-                  <a:srgbClr val="AEB9F4"/>
-                </a:solidFill>
-                <a:latin typeface="Calibri"/>
+                  <a:srgbClr val="AAAAAB"/>
+                </a:solidFill>
+                <a:latin typeface="Consolas"/>
               </a:defRPr>
             </a:pPr>
             <a:r>

</xml_diff>

<commit_message>
docs(drift): deck sets machine text in mono and links the on-chain sources
box() now sets every backticked span as a mono run, used for
MacroGuard.allowed(signal), recordDecision(...), block 134,042,283,
gas figures, chain IDs and commit 52671ce. Slide 10's "Check it
yourself" heading is white; the BscScan and Sourcify rows are full,
clickable URLs in gold mono (the theme's link colour is gold, since
PowerPoint draws links in it). The panel screenshot on slide 5 is
cropped to the panel, and docProps/app.xml now describes this deck
(widescreen, 10 slides) instead of the template. PDF rebuilt.
</commit_message>
<xml_diff>
--- a/docs/submission/DRIFT-pitch.pptx
+++ b/docs/submission/DRIFT-pitch.pptx
@@ -581,7 +581,7 @@
           <a:lstStyle/>
           <a:p>
             <a:r>
-              <a:t>Roadmap items are not built yet. The links are live today.</a:t>
+              <a:t>Roadmap items are not built yet. The links are live today and clickable in the deck.</a:t>
             </a:r>
           </a:p>
         </p:txBody>
@@ -4181,14 +4181,14 @@
               <a:spcAft>
                 <a:spcPts val="2100"/>
               </a:spcAft>
-              <a:defRPr sz="6000" b="1">
+            </a:pPr>
+            <a:r>
+              <a:rPr sz="6000" b="1">
                 <a:solidFill>
                   <a:srgbClr val="FFFFFF"/>
                 </a:solidFill>
                 <a:latin typeface="Calibri"/>
-              </a:defRPr>
-            </a:pPr>
-            <a:r>
+              </a:rPr>
               <a:t>DRIFT</a:t>
             </a:r>
           </a:p>
@@ -4220,14 +4220,14 @@
               <a:spcAft>
                 <a:spcPts val="1189"/>
               </a:spcAft>
-              <a:defRPr sz="3400" b="1">
+            </a:pPr>
+            <a:r>
+              <a:rPr sz="3400" b="1">
                 <a:solidFill>
                   <a:srgbClr val="FFFFFF"/>
                 </a:solidFill>
                 <a:latin typeface="Calibri"/>
-              </a:defRPr>
-            </a:pPr>
-            <a:r>
+              </a:rPr>
               <a:t>A trading bot whose risk rules you can verify</a:t>
             </a:r>
           </a:p>
@@ -4259,14 +4259,14 @@
               <a:spcAft>
                 <a:spcPts val="769"/>
               </a:spcAft>
-              <a:defRPr sz="2200" b="0">
+            </a:pPr>
+            <a:r>
+              <a:rPr sz="2200" b="0">
                 <a:solidFill>
                   <a:srgbClr val="AAAAAB"/>
                 </a:solidFill>
                 <a:latin typeface="Calibri"/>
-              </a:defRPr>
-            </a:pPr>
-            <a:r>
+              </a:rPr>
               <a:t>Off-chain quant research · on-chain risk gate on BNB Chain</a:t>
             </a:r>
           </a:p>
@@ -4298,14 +4298,14 @@
               <a:spcAft>
                 <a:spcPts val="560"/>
               </a:spcAft>
-              <a:defRPr sz="1600" b="0">
+            </a:pPr>
+            <a:r>
+              <a:rPr sz="1600" b="0">
                 <a:solidFill>
                   <a:srgbClr val="AAAAAB"/>
                 </a:solidFill>
                 <a:latin typeface="Calibri"/>
-              </a:defRPr>
-            </a:pPr>
-            <a:r>
+              </a:rPr>
               <a:t>Live demo</a:t>
             </a:r>
           </a:p>
@@ -4337,14 +4337,14 @@
               <a:spcAft>
                 <a:spcPts val="630"/>
               </a:spcAft>
-              <a:defRPr sz="1800" b="0">
+            </a:pPr>
+            <a:r>
+              <a:rPr sz="1800" b="0">
                 <a:solidFill>
                   <a:srgbClr val="FFFFFF"/>
                 </a:solidFill>
                 <a:latin typeface="Consolas"/>
-              </a:defRPr>
-            </a:pPr>
-            <a:r>
+              </a:rPr>
               <a:t>drift-macroguard.vercel.app/macroguard</a:t>
             </a:r>
           </a:p>
@@ -4376,14 +4376,14 @@
               <a:spcAft>
                 <a:spcPts val="560"/>
               </a:spcAft>
-              <a:defRPr sz="1600" b="0">
+            </a:pPr>
+            <a:r>
+              <a:rPr sz="1600" b="0">
                 <a:solidFill>
                   <a:srgbClr val="AAAAAB"/>
                 </a:solidFill>
                 <a:latin typeface="Calibri"/>
-              </a:defRPr>
-            </a:pPr>
-            <a:r>
+              </a:rPr>
               <a:t>Dex's contract on BSC Testnet</a:t>
             </a:r>
           </a:p>
@@ -4415,14 +4415,14 @@
               <a:spcAft>
                 <a:spcPts val="630"/>
               </a:spcAft>
-              <a:defRPr sz="1800" b="0">
+            </a:pPr>
+            <a:r>
+              <a:rPr sz="1800" b="0">
                 <a:solidFill>
                   <a:srgbClr val="F0B90B"/>
                 </a:solidFill>
                 <a:latin typeface="Consolas"/>
-              </a:defRPr>
-            </a:pPr>
-            <a:r>
+              </a:rPr>
               <a:t>0x8b09ebB85Be8Ed55Bb5132d29eABc567c42aa83D</a:t>
             </a:r>
           </a:p>
@@ -4454,14 +4454,14 @@
               <a:spcAft>
                 <a:spcPts val="560"/>
               </a:spcAft>
-              <a:defRPr sz="1600" b="0">
+            </a:pPr>
+            <a:r>
+              <a:rPr sz="1600" b="0">
                 <a:solidFill>
                   <a:srgbClr val="AAAAAB"/>
                 </a:solidFill>
                 <a:latin typeface="Calibri"/>
-              </a:defRPr>
-            </a:pPr>
-            <a:r>
+              </a:rPr>
               <a:t>Indonesia Web3 Hackathon 2026 · Dex Bennett</a:t>
             </a:r>
           </a:p>
@@ -4519,14 +4519,14 @@
               <a:spcAft>
                 <a:spcPts val="1260"/>
               </a:spcAft>
-              <a:defRPr sz="3600" b="1">
+            </a:pPr>
+            <a:r>
+              <a:rPr sz="3600" b="1">
                 <a:solidFill>
                   <a:srgbClr val="FFFFFF"/>
                 </a:solidFill>
                 <a:latin typeface="Calibri"/>
-              </a:defRPr>
-            </a:pPr>
-            <a:r>
+              </a:rPr>
               <a:t>Roadmap</a:t>
             </a:r>
           </a:p>
@@ -4558,14 +4558,14 @@
               <a:spcAft>
                 <a:spcPts val="525"/>
               </a:spcAft>
-              <a:defRPr sz="1500" b="1">
+            </a:pPr>
+            <a:r>
+              <a:rPr sz="1500" b="1">
                 <a:solidFill>
                   <a:srgbClr val="FBBF24"/>
                 </a:solidFill>
                 <a:latin typeface="Calibri"/>
-              </a:defRPr>
-            </a:pPr>
-            <a:r>
+              </a:rPr>
               <a:t>Not built yet; listed in order of trust gained per step</a:t>
             </a:r>
           </a:p>
@@ -4579,8 +4579,8 @@
         </p:nvSpPr>
         <p:spPr>
           <a:xfrm>
-            <a:off x="640080" y="1828800"/>
-            <a:ext cx="5669280" cy="3840480"/>
+            <a:off x="640080" y="1737360"/>
+            <a:ext cx="5486400" cy="2011680"/>
           </a:xfrm>
           <a:prstGeom prst="rect">
             <a:avLst/>
@@ -4597,14 +4597,14 @@
               <a:spcAft>
                 <a:spcPts val="630"/>
               </a:spcAft>
-              <a:defRPr sz="1800" b="0">
+            </a:pPr>
+            <a:r>
+              <a:rPr sz="1800" b="0">
                 <a:solidFill>
                   <a:srgbClr val="FFFFFF"/>
                 </a:solidFill>
                 <a:latin typeface="Calibri"/>
-              </a:defRPr>
-            </a:pPr>
-            <a:r>
+              </a:rPr>
               <a:t>Resume through a multisig or timelock</a:t>
             </a:r>
           </a:p>
@@ -4613,14 +4613,14 @@
               <a:spcAft>
                 <a:spcPts val="630"/>
               </a:spcAft>
-              <a:defRPr sz="1800" b="0">
+            </a:pPr>
+            <a:r>
+              <a:rPr sz="1800" b="0">
                 <a:solidFill>
                   <a:srgbClr val="FFFFFF"/>
                 </a:solidFill>
                 <a:latin typeface="Calibri"/>
-              </a:defRPr>
-            </a:pPr>
-            <a:r>
+              </a:rPr>
               <a:t>Fail-closed mode for the runner</a:t>
             </a:r>
           </a:p>
@@ -4629,63 +4629,15 @@
               <a:spcAft>
                 <a:spcPts val="630"/>
               </a:spcAft>
-              <a:defRPr sz="1800" b="0">
+            </a:pPr>
+            <a:r>
+              <a:rPr sz="1800" b="0">
                 <a:solidFill>
                   <a:srgbClr val="FFFFFF"/>
                 </a:solidFill>
                 <a:latin typeface="Calibri"/>
-              </a:defRPr>
-            </a:pPr>
-            <a:r>
+              </a:rPr>
               <a:t>Signed regime verdicts (EIP-712) with an input hash</a:t>
-            </a:r>
-          </a:p>
-          <a:p>
-            <a:pPr>
-              <a:spcAft>
-                <a:spcPts val="630"/>
-              </a:spcAft>
-              <a:defRPr sz="1800" b="0">
-                <a:solidFill>
-                  <a:srgbClr val="FFFFFF"/>
-                </a:solidFill>
-                <a:latin typeface="Calibri"/>
-              </a:defRPr>
-            </a:pPr>
-            <a:r>
-              <a:t>Attested equity, so the drawdown is not self-reported</a:t>
-            </a:r>
-          </a:p>
-          <a:p>
-            <a:pPr>
-              <a:spcAft>
-                <a:spcPts val="630"/>
-              </a:spcAft>
-              <a:defRPr sz="1800" b="0">
-                <a:solidFill>
-                  <a:srgbClr val="FFFFFF"/>
-                </a:solidFill>
-                <a:latin typeface="Calibri"/>
-              </a:defRPr>
-            </a:pPr>
-            <a:r>
-              <a:t>Record the raw signal plus a veto flag</a:t>
-            </a:r>
-          </a:p>
-          <a:p>
-            <a:pPr>
-              <a:spcAft>
-                <a:spcPts val="630"/>
-              </a:spcAft>
-              <a:defRPr sz="1800" b="0">
-                <a:solidFill>
-                  <a:srgbClr val="FFFFFF"/>
-                </a:solidFill>
-                <a:latin typeface="Calibri"/>
-              </a:defRPr>
-            </a:pPr>
-            <a:r>
-              <a:t>Agent identity (ERC-8004), then mainnet after an audit</a:t>
             </a:r>
           </a:p>
         </p:txBody>
@@ -4698,8 +4650,8 @@
         </p:nvSpPr>
         <p:spPr>
           <a:xfrm>
-            <a:off x="6766560" y="1828800"/>
-            <a:ext cx="4754880" cy="548640"/>
+            <a:off x="6309360" y="1737360"/>
+            <a:ext cx="5486400" cy="2011680"/>
           </a:xfrm>
           <a:prstGeom prst="rect">
             <a:avLst/>
@@ -4714,17 +4666,49 @@
           <a:p>
             <a:pPr>
               <a:spcAft>
-                <a:spcPts val="839"/>
-              </a:spcAft>
-              <a:defRPr sz="2400" b="1">
-                <a:solidFill>
-                  <a:srgbClr val="F0B90B"/>
-                </a:solidFill>
-                <a:latin typeface="Calibri"/>
-              </a:defRPr>
-            </a:pPr>
-            <a:r>
-              <a:t>Check it yourself</a:t>
+                <a:spcPts val="630"/>
+              </a:spcAft>
+            </a:pPr>
+            <a:r>
+              <a:rPr sz="1800" b="0">
+                <a:solidFill>
+                  <a:srgbClr val="FFFFFF"/>
+                </a:solidFill>
+                <a:latin typeface="Calibri"/>
+              </a:rPr>
+              <a:t>Attested equity, so the drawdown is not self-reported</a:t>
+            </a:r>
+          </a:p>
+          <a:p>
+            <a:pPr>
+              <a:spcAft>
+                <a:spcPts val="630"/>
+              </a:spcAft>
+            </a:pPr>
+            <a:r>
+              <a:rPr sz="1800" b="0">
+                <a:solidFill>
+                  <a:srgbClr val="FFFFFF"/>
+                </a:solidFill>
+                <a:latin typeface="Calibri"/>
+              </a:rPr>
+              <a:t>Record the raw signal plus a veto flag</a:t>
+            </a:r>
+          </a:p>
+          <a:p>
+            <a:pPr>
+              <a:spcAft>
+                <a:spcPts val="630"/>
+              </a:spcAft>
+            </a:pPr>
+            <a:r>
+              <a:rPr sz="1800" b="0">
+                <a:solidFill>
+                  <a:srgbClr val="FFFFFF"/>
+                </a:solidFill>
+                <a:latin typeface="Calibri"/>
+              </a:rPr>
+              <a:t>Agent identity (ERC-8004), then mainnet after an audit</a:t>
             </a:r>
           </a:p>
         </p:txBody>
@@ -4737,8 +4721,8 @@
         </p:nvSpPr>
         <p:spPr>
           <a:xfrm>
-            <a:off x="6766560" y="2560320"/>
-            <a:ext cx="4937760" cy="2743200"/>
+            <a:off x="640080" y="3931920"/>
+            <a:ext cx="10881360" cy="548640"/>
           </a:xfrm>
           <a:prstGeom prst="rect">
             <a:avLst/>
@@ -4753,65 +4737,311 @@
           <a:p>
             <a:pPr>
               <a:spcAft>
-                <a:spcPts val="525"/>
-              </a:spcAft>
-              <a:defRPr sz="1500" b="0">
+                <a:spcPts val="839"/>
+              </a:spcAft>
+            </a:pPr>
+            <a:r>
+              <a:rPr sz="2400" b="1">
                 <a:solidFill>
                   <a:srgbClr val="FFFFFF"/>
                 </a:solidFill>
+                <a:latin typeface="Calibri"/>
+              </a:rPr>
+              <a:t>Check it yourself</a:t>
+            </a:r>
+          </a:p>
+        </p:txBody>
+      </p:sp>
+      <p:sp>
+        <p:nvSpPr>
+          <p:cNvPr id="7" name="TextBox 6"/>
+          <p:cNvSpPr txBox="1"/>
+          <p:nvPr/>
+        </p:nvSpPr>
+        <p:spPr>
+          <a:xfrm>
+            <a:off x="640080" y="4599432"/>
+            <a:ext cx="1737360" cy="411480"/>
+          </a:xfrm>
+          <a:prstGeom prst="rect">
+            <a:avLst/>
+          </a:prstGeom>
+          <a:noFill/>
+        </p:spPr>
+        <p:txBody>
+          <a:bodyPr wrap="square">
+            <a:spAutoFit/>
+          </a:bodyPr>
+          <a:lstStyle/>
+          <a:p>
+            <a:pPr>
+              <a:spcAft>
+                <a:spcPts val="455"/>
+              </a:spcAft>
+            </a:pPr>
+            <a:r>
+              <a:rPr sz="1300" b="0">
+                <a:solidFill>
+                  <a:srgbClr val="AAAAAB"/>
+                </a:solidFill>
+                <a:latin typeface="Calibri"/>
+              </a:rPr>
+              <a:t>Live demo</a:t>
+            </a:r>
+          </a:p>
+        </p:txBody>
+      </p:sp>
+      <p:sp>
+        <p:nvSpPr>
+          <p:cNvPr id="8" name="TextBox 7"/>
+          <p:cNvSpPr txBox="1"/>
+          <p:nvPr/>
+        </p:nvSpPr>
+        <p:spPr>
+          <a:xfrm>
+            <a:off x="2286000" y="4572000"/>
+            <a:ext cx="9418320" cy="411480"/>
+          </a:xfrm>
+          <a:prstGeom prst="rect">
+            <a:avLst/>
+          </a:prstGeom>
+          <a:noFill/>
+        </p:spPr>
+        <p:txBody>
+          <a:bodyPr wrap="none">
+            <a:spAutoFit/>
+          </a:bodyPr>
+          <a:lstStyle/>
+          <a:p>
+            <a:r>
+              <a:rPr sz="1400">
+                <a:solidFill>
+                  <a:srgbClr val="FFFFFF"/>
+                </a:solidFill>
                 <a:latin typeface="Consolas"/>
-              </a:defRPr>
-            </a:pPr>
-            <a:r>
-              <a:t>drift-macroguard.vercel.app/macroguard</a:t>
-            </a:r>
-          </a:p>
-          <a:p>
-            <a:pPr>
-              <a:spcAft>
-                <a:spcPts val="525"/>
-              </a:spcAft>
-              <a:defRPr sz="1500" b="0">
+              </a:rPr>
+              <a:t>https://drift-macroguard.vercel.app/macroguard</a:t>
+            </a:r>
+          </a:p>
+        </p:txBody>
+      </p:sp>
+      <p:sp>
+        <p:nvSpPr>
+          <p:cNvPr id="9" name="TextBox 8"/>
+          <p:cNvSpPr txBox="1"/>
+          <p:nvPr/>
+        </p:nvSpPr>
+        <p:spPr>
+          <a:xfrm>
+            <a:off x="640080" y="5056632"/>
+            <a:ext cx="1737360" cy="411480"/>
+          </a:xfrm>
+          <a:prstGeom prst="rect">
+            <a:avLst/>
+          </a:prstGeom>
+          <a:noFill/>
+        </p:spPr>
+        <p:txBody>
+          <a:bodyPr wrap="square">
+            <a:spAutoFit/>
+          </a:bodyPr>
+          <a:lstStyle/>
+          <a:p>
+            <a:pPr>
+              <a:spcAft>
+                <a:spcPts val="455"/>
+              </a:spcAft>
+            </a:pPr>
+            <a:r>
+              <a:rPr sz="1300" b="0">
+                <a:solidFill>
+                  <a:srgbClr val="AAAAAB"/>
+                </a:solidFill>
+                <a:latin typeface="Calibri"/>
+              </a:rPr>
+              <a:t>Code</a:t>
+            </a:r>
+          </a:p>
+        </p:txBody>
+      </p:sp>
+      <p:sp>
+        <p:nvSpPr>
+          <p:cNvPr id="10" name="TextBox 9"/>
+          <p:cNvSpPr txBox="1"/>
+          <p:nvPr/>
+        </p:nvSpPr>
+        <p:spPr>
+          <a:xfrm>
+            <a:off x="2286000" y="5029200"/>
+            <a:ext cx="9418320" cy="411480"/>
+          </a:xfrm>
+          <a:prstGeom prst="rect">
+            <a:avLst/>
+          </a:prstGeom>
+          <a:noFill/>
+        </p:spPr>
+        <p:txBody>
+          <a:bodyPr wrap="none">
+            <a:spAutoFit/>
+          </a:bodyPr>
+          <a:lstStyle/>
+          <a:p>
+            <a:r>
+              <a:rPr sz="1400">
                 <a:solidFill>
                   <a:srgbClr val="FFFFFF"/>
                 </a:solidFill>
                 <a:latin typeface="Consolas"/>
-              </a:defRPr>
-            </a:pPr>
-            <a:r>
-              <a:t>github.com/Stylenecy/seed-bnb/tree/dex/drift/drift</a:t>
-            </a:r>
-          </a:p>
-          <a:p>
-            <a:pPr>
-              <a:spcAft>
-                <a:spcPts val="525"/>
-              </a:spcAft>
-              <a:defRPr sz="1500" b="0">
-                <a:solidFill>
-                  <a:srgbClr val="FFFFFF"/>
+              </a:rPr>
+              <a:t>https://github.com/Stylenecy/seed-bnb/tree/dex/drift/drift</a:t>
+            </a:r>
+          </a:p>
+        </p:txBody>
+      </p:sp>
+      <p:sp>
+        <p:nvSpPr>
+          <p:cNvPr id="11" name="TextBox 10"/>
+          <p:cNvSpPr txBox="1"/>
+          <p:nvPr/>
+        </p:nvSpPr>
+        <p:spPr>
+          <a:xfrm>
+            <a:off x="640080" y="5513832"/>
+            <a:ext cx="1737360" cy="411480"/>
+          </a:xfrm>
+          <a:prstGeom prst="rect">
+            <a:avLst/>
+          </a:prstGeom>
+          <a:noFill/>
+        </p:spPr>
+        <p:txBody>
+          <a:bodyPr wrap="square">
+            <a:spAutoFit/>
+          </a:bodyPr>
+          <a:lstStyle/>
+          <a:p>
+            <a:pPr>
+              <a:spcAft>
+                <a:spcPts val="455"/>
+              </a:spcAft>
+            </a:pPr>
+            <a:r>
+              <a:rPr sz="1300" b="0">
+                <a:solidFill>
+                  <a:srgbClr val="AAAAAB"/>
+                </a:solidFill>
+                <a:latin typeface="Calibri"/>
+              </a:rPr>
+              <a:t>Contract</a:t>
+            </a:r>
+          </a:p>
+        </p:txBody>
+      </p:sp>
+      <p:sp>
+        <p:nvSpPr>
+          <p:cNvPr id="12" name="TextBox 11"/>
+          <p:cNvSpPr txBox="1"/>
+          <p:nvPr/>
+        </p:nvSpPr>
+        <p:spPr>
+          <a:xfrm>
+            <a:off x="2286000" y="5486400"/>
+            <a:ext cx="9418320" cy="411480"/>
+          </a:xfrm>
+          <a:prstGeom prst="rect">
+            <a:avLst/>
+          </a:prstGeom>
+          <a:noFill/>
+        </p:spPr>
+        <p:txBody>
+          <a:bodyPr wrap="none">
+            <a:spAutoFit/>
+          </a:bodyPr>
+          <a:lstStyle/>
+          <a:p>
+            <a:r>
+              <a:rPr sz="1400">
+                <a:solidFill>
+                  <a:srgbClr val="F0B90B"/>
                 </a:solidFill>
                 <a:latin typeface="Consolas"/>
-              </a:defRPr>
-            </a:pPr>
-            <a:r>
-              <a:t>BscScan: 0x8b09ebB8…2aa83D</a:t>
-            </a:r>
-          </a:p>
-          <a:p>
-            <a:pPr>
-              <a:spcAft>
-                <a:spcPts val="525"/>
-              </a:spcAft>
-              <a:defRPr sz="1500" b="0">
-                <a:solidFill>
-                  <a:srgbClr val="FFFFFF"/>
+                <a:hlinkClick r:id="rId3"/>
+              </a:rPr>
+              <a:t>https://testnet.bscscan.com/address/0x8b09ebB85Be8Ed55Bb5132d29eABc567c42aa83D</a:t>
+            </a:r>
+          </a:p>
+        </p:txBody>
+      </p:sp>
+      <p:sp>
+        <p:nvSpPr>
+          <p:cNvPr id="13" name="TextBox 12"/>
+          <p:cNvSpPr txBox="1"/>
+          <p:nvPr/>
+        </p:nvSpPr>
+        <p:spPr>
+          <a:xfrm>
+            <a:off x="640080" y="5971032"/>
+            <a:ext cx="1737360" cy="411480"/>
+          </a:xfrm>
+          <a:prstGeom prst="rect">
+            <a:avLst/>
+          </a:prstGeom>
+          <a:noFill/>
+        </p:spPr>
+        <p:txBody>
+          <a:bodyPr wrap="square">
+            <a:spAutoFit/>
+          </a:bodyPr>
+          <a:lstStyle/>
+          <a:p>
+            <a:pPr>
+              <a:spcAft>
+                <a:spcPts val="455"/>
+              </a:spcAft>
+            </a:pPr>
+            <a:r>
+              <a:rPr sz="1300" b="0">
+                <a:solidFill>
+                  <a:srgbClr val="AAAAAB"/>
+                </a:solidFill>
+                <a:latin typeface="Calibri"/>
+              </a:rPr>
+              <a:t>Source</a:t>
+            </a:r>
+          </a:p>
+        </p:txBody>
+      </p:sp>
+      <p:sp>
+        <p:nvSpPr>
+          <p:cNvPr id="14" name="TextBox 13"/>
+          <p:cNvSpPr txBox="1"/>
+          <p:nvPr/>
+        </p:nvSpPr>
+        <p:spPr>
+          <a:xfrm>
+            <a:off x="2286000" y="5943600"/>
+            <a:ext cx="9418320" cy="411480"/>
+          </a:xfrm>
+          <a:prstGeom prst="rect">
+            <a:avLst/>
+          </a:prstGeom>
+          <a:noFill/>
+        </p:spPr>
+        <p:txBody>
+          <a:bodyPr wrap="none">
+            <a:spAutoFit/>
+          </a:bodyPr>
+          <a:lstStyle/>
+          <a:p>
+            <a:r>
+              <a:rPr sz="1400">
+                <a:solidFill>
+                  <a:srgbClr val="F0B90B"/>
                 </a:solidFill>
                 <a:latin typeface="Consolas"/>
-              </a:defRPr>
-            </a:pPr>
-            <a:r>
-              <a:t>Sourcify: repo.sourcify.dev/97/…</a:t>
+                <a:hlinkClick r:id="rId4"/>
+              </a:rPr>
+              <a:t>https://repo.sourcify.dev/97/0x8b09ebB85Be8Ed55Bb5132d29eABc567c42aa83D</a:t>
             </a:r>
           </a:p>
         </p:txBody>
@@ -4868,14 +5098,14 @@
               <a:spcAft>
                 <a:spcPts val="1260"/>
               </a:spcAft>
-              <a:defRPr sz="3600" b="1">
+            </a:pPr>
+            <a:r>
+              <a:rPr sz="3600" b="1">
                 <a:solidFill>
                   <a:srgbClr val="FFFFFF"/>
                 </a:solidFill>
                 <a:latin typeface="Calibri"/>
-              </a:defRPr>
-            </a:pPr>
-            <a:r>
+              </a:rPr>
               <a:t>The problem</a:t>
             </a:r>
           </a:p>
@@ -4907,14 +5137,14 @@
               <a:spcAft>
                 <a:spcPts val="839"/>
               </a:spcAft>
-              <a:defRPr sz="2400" b="0">
+            </a:pPr>
+            <a:r>
+              <a:rPr sz="2400" b="0">
                 <a:solidFill>
                   <a:srgbClr val="FFFFFF"/>
                 </a:solidFill>
                 <a:latin typeface="Calibri"/>
-              </a:defRPr>
-            </a:pPr>
-            <a:r>
+              </a:rPr>
               <a:t>Trading bots ask users to trust risk rules nobody can see.</a:t>
             </a:r>
           </a:p>
@@ -4923,14 +5153,14 @@
               <a:spcAft>
                 <a:spcPts val="839"/>
               </a:spcAft>
-              <a:defRPr sz="2400" b="0">
+            </a:pPr>
+            <a:r>
+              <a:rPr sz="2400" b="0">
                 <a:solidFill>
                   <a:srgbClr val="FFFFFF"/>
                 </a:solidFill>
                 <a:latin typeface="Calibri"/>
-              </a:defRPr>
-            </a:pPr>
-            <a:r>
+              </a:rPr>
               <a:t>Settings change silently; off-chain decision logs can be rewritten.</a:t>
             </a:r>
           </a:p>
@@ -4962,14 +5192,14 @@
               <a:spcAft>
                 <a:spcPts val="979"/>
               </a:spcAft>
-              <a:defRPr sz="2800" b="1">
+            </a:pPr>
+            <a:r>
+              <a:rPr sz="2800" b="1">
                 <a:solidFill>
                   <a:srgbClr val="FFFFFF"/>
                 </a:solidFill>
                 <a:latin typeface="Calibri"/>
-              </a:defRPr>
-            </a:pPr>
-            <a:r>
+              </a:rPr>
               <a:t>The promise</a:t>
             </a:r>
           </a:p>
@@ -5001,14 +5231,14 @@
               <a:spcAft>
                 <a:spcPts val="839"/>
               </a:spcAft>
-              <a:defRPr sz="2400" b="0">
+            </a:pPr>
+            <a:r>
+              <a:rPr sz="2400" b="0">
                 <a:solidFill>
                   <a:srgbClr val="FFFFFF"/>
                 </a:solidFill>
                 <a:latin typeface="Calibri"/>
-              </a:defRPr>
-            </a:pPr>
-            <a:r>
+              </a:rPr>
               <a:t>Anyone can check what DRIFT's bot is allowed to do right now,</a:t>
             </a:r>
           </a:p>
@@ -5017,14 +5247,14 @@
               <a:spcAft>
                 <a:spcPts val="839"/>
               </a:spcAft>
-              <a:defRPr sz="2400" b="0">
+            </a:pPr>
+            <a:r>
+              <a:rPr sz="2400" b="0">
                 <a:solidFill>
                   <a:srgbClr val="FFFFFF"/>
                 </a:solidFill>
                 <a:latin typeface="Calibri"/>
-              </a:defRPr>
-            </a:pPr>
-            <a:r>
+              </a:rPr>
               <a:t>and every recorded decision is public on BscScan.</a:t>
             </a:r>
           </a:p>
@@ -5082,14 +5312,14 @@
               <a:spcAft>
                 <a:spcPts val="1260"/>
               </a:spcAft>
-              <a:defRPr sz="3600" b="1">
+            </a:pPr>
+            <a:r>
+              <a:rPr sz="3600" b="1">
                 <a:solidFill>
                   <a:srgbClr val="FFFFFF"/>
                 </a:solidFill>
                 <a:latin typeface="Calibri"/>
-              </a:defRPr>
-            </a:pPr>
-            <a:r>
+              </a:rPr>
               <a:t>Who needs it, and how it could pay</a:t>
             </a:r>
           </a:p>
@@ -5121,14 +5351,14 @@
               <a:spcAft>
                 <a:spcPts val="525"/>
               </a:spcAft>
-              <a:defRPr sz="1500" b="1">
+            </a:pPr>
+            <a:r>
+              <a:rPr sz="1500" b="1">
                 <a:solidFill>
                   <a:srgbClr val="FBBF24"/>
                 </a:solidFill>
                 <a:latin typeface="Calibri"/>
-              </a:defRPr>
-            </a:pPr>
-            <a:r>
+              </a:rPr>
               <a:t>HYPOTHESIS: not yet validated with users; no market figures claimed</a:t>
             </a:r>
           </a:p>
@@ -5160,14 +5390,14 @@
               <a:spcAft>
                 <a:spcPts val="839"/>
               </a:spcAft>
-              <a:defRPr sz="2400" b="1">
+            </a:pPr>
+            <a:r>
+              <a:rPr sz="2400" b="1">
                 <a:solidFill>
                   <a:srgbClr val="FFFFFF"/>
                 </a:solidFill>
                 <a:latin typeface="Calibri"/>
-              </a:defRPr>
-            </a:pPr>
-            <a:r>
+              </a:rPr>
               <a:t>Who needs it</a:t>
             </a:r>
           </a:p>
@@ -5199,14 +5429,14 @@
               <a:spcAft>
                 <a:spcPts val="630"/>
               </a:spcAft>
-              <a:defRPr sz="1800" b="0">
+            </a:pPr>
+            <a:r>
+              <a:rPr sz="1800" b="0">
                 <a:solidFill>
                   <a:srgbClr val="FFFFFF"/>
                 </a:solidFill>
                 <a:latin typeface="Calibri"/>
-              </a:defRPr>
-            </a:pPr>
-            <a:r>
+              </a:rPr>
               <a:t>Retail traders who follow or rent bots: proof that the risk stop is real</a:t>
             </a:r>
           </a:p>
@@ -5215,14 +5445,14 @@
               <a:spcAft>
                 <a:spcPts val="630"/>
               </a:spcAft>
-              <a:defRPr sz="1800" b="0">
+            </a:pPr>
+            <a:r>
+              <a:rPr sz="1800" b="0">
                 <a:solidFill>
                   <a:srgbClr val="FFFFFF"/>
                 </a:solidFill>
                 <a:latin typeface="Calibri"/>
-              </a:defRPr>
-            </a:pPr>
-            <a:r>
+              </a:rPr>
               <a:t>Bot builders and signal sellers: a record of discipline a screenshot cannot fake</a:t>
             </a:r>
           </a:p>
@@ -5231,14 +5461,14 @@
               <a:spcAft>
                 <a:spcPts val="630"/>
               </a:spcAft>
-              <a:defRPr sz="1800" b="0">
+            </a:pPr>
+            <a:r>
+              <a:rPr sz="1800" b="0">
                 <a:solidFill>
                   <a:srgbClr val="FFFFFF"/>
                 </a:solidFill>
                 <a:latin typeface="Calibri"/>
-              </a:defRPr>
-            </a:pPr>
-            <a:r>
+              </a:rPr>
               <a:t>Communities and auditors: check a bot's rules without trusting its operator</a:t>
             </a:r>
           </a:p>
@@ -5270,14 +5500,14 @@
               <a:spcAft>
                 <a:spcPts val="839"/>
               </a:spcAft>
-              <a:defRPr sz="2400" b="1">
+            </a:pPr>
+            <a:r>
+              <a:rPr sz="2400" b="1">
                 <a:solidFill>
                   <a:srgbClr val="FFFFFF"/>
                 </a:solidFill>
                 <a:latin typeface="Calibri"/>
-              </a:defRPr>
-            </a:pPr>
-            <a:r>
+              </a:rPr>
               <a:t>How it could pay</a:t>
             </a:r>
           </a:p>
@@ -5309,14 +5539,14 @@
               <a:spcAft>
                 <a:spcPts val="630"/>
               </a:spcAft>
-              <a:defRPr sz="1800" b="0">
+            </a:pPr>
+            <a:r>
+              <a:rPr sz="1800" b="0">
                 <a:solidFill>
                   <a:srgbClr val="FFFFFF"/>
                 </a:solidFill>
                 <a:latin typeface="Calibri"/>
-              </a:defRPr>
-            </a:pPr>
-            <a:r>
+              </a:rPr>
               <a:t>A risk gate per bot: its own MacroGuard plus a public panel, as a monthly service</a:t>
             </a:r>
           </a:p>
@@ -5325,14 +5555,14 @@
               <a:spcAft>
                 <a:spcPts val="630"/>
               </a:spcAft>
-              <a:defRPr sz="1800" b="0">
+            </a:pPr>
+            <a:r>
+              <a:rPr sz="1800" b="0">
                 <a:solidFill>
                   <a:srgbClr val="FFFFFF"/>
                 </a:solidFill>
                 <a:latin typeface="Calibri"/>
-              </a:defRPr>
-            </a:pPr>
-            <a:r>
+              </a:rPr>
               <a:t>The panel link as a trust badge for strategy sellers</a:t>
             </a:r>
           </a:p>
@@ -5341,14 +5571,14 @@
               <a:spcAft>
                 <a:spcPts val="630"/>
               </a:spcAft>
-              <a:defRPr sz="1800" b="0">
+            </a:pPr>
+            <a:r>
+              <a:rPr sz="1800" b="0">
                 <a:solidFill>
                   <a:srgbClr val="FFFFFF"/>
                 </a:solidFill>
                 <a:latin typeface="Calibri"/>
-              </a:defRPr>
-            </a:pPr>
-            <a:r>
+              </a:rPr>
               <a:t>No custody and no performance fee; on-chain cost per decision stays tiny (slide 7)</a:t>
             </a:r>
           </a:p>
@@ -5406,14 +5636,14 @@
               <a:spcAft>
                 <a:spcPts val="1260"/>
               </a:spcAft>
-              <a:defRPr sz="3600" b="1">
+            </a:pPr>
+            <a:r>
+              <a:rPr sz="3600" b="1">
                 <a:solidFill>
                   <a:srgbClr val="FFFFFF"/>
                 </a:solidFill>
                 <a:latin typeface="Calibri"/>
-              </a:defRPr>
-            </a:pPr>
-            <a:r>
+              </a:rPr>
               <a:t>How DRIFT works</a:t>
             </a:r>
           </a:p>
@@ -5445,14 +5675,14 @@
               <a:spcAft>
                 <a:spcPts val="839"/>
               </a:spcAft>
-              <a:defRPr sz="2400" b="1">
+            </a:pPr>
+            <a:r>
+              <a:rPr sz="2400" b="1">
                 <a:solidFill>
                   <a:srgbClr val="9AA8F0"/>
                 </a:solidFill>
                 <a:latin typeface="Calibri"/>
-              </a:defRPr>
-            </a:pPr>
-            <a:r>
+              </a:rPr>
               <a:t>1  Signal</a:t>
             </a:r>
           </a:p>
@@ -5484,14 +5714,14 @@
               <a:spcAft>
                 <a:spcPts val="700"/>
               </a:spcAft>
-              <a:defRPr sz="2000" b="0">
+            </a:pPr>
+            <a:r>
+              <a:rPr sz="2000" b="0">
                 <a:solidFill>
                   <a:srgbClr val="FFFFFF"/>
                 </a:solidFill>
                 <a:latin typeface="Calibri"/>
-              </a:defRPr>
-            </a:pPr>
-            <a:r>
+              </a:rPr>
               <a:t>Python engine: four strategies, point-in-time, no look-ahead</a:t>
             </a:r>
           </a:p>
@@ -5523,14 +5753,14 @@
               <a:spcAft>
                 <a:spcPts val="839"/>
               </a:spcAft>
-              <a:defRPr sz="2400" b="1">
+            </a:pPr>
+            <a:r>
+              <a:rPr sz="2400" b="1">
                 <a:solidFill>
                   <a:srgbClr val="FFFFFF"/>
                 </a:solidFill>
                 <a:latin typeface="Calibri"/>
-              </a:defRPr>
-            </a:pPr>
-            <a:r>
+              </a:rPr>
               <a:t>2  Ask the gate</a:t>
             </a:r>
           </a:p>
@@ -5562,15 +5792,24 @@
               <a:spcAft>
                 <a:spcPts val="700"/>
               </a:spcAft>
-              <a:defRPr sz="2000" b="0">
+            </a:pPr>
+            <a:r>
+              <a:rPr sz="2000" b="0">
                 <a:solidFill>
                   <a:srgbClr val="FFFFFF"/>
                 </a:solidFill>
-                <a:latin typeface="Calibri"/>
-              </a:defRPr>
-            </a:pPr>
-            <a:r>
-              <a:t>MacroGuard.allowed(signal) on BSC Testnet: regime + 20% halt</a:t>
+                <a:latin typeface="Consolas"/>
+              </a:rPr>
+              <a:t>MacroGuard.allowed(signal)</a:t>
+            </a:r>
+            <a:r>
+              <a:rPr sz="2000" b="0">
+                <a:solidFill>
+                  <a:srgbClr val="FFFFFF"/>
+                </a:solidFill>
+                <a:latin typeface="Calibri"/>
+              </a:rPr>
+              <a:t> on BSC Testnet: regime + 20% halt</a:t>
             </a:r>
           </a:p>
         </p:txBody>
@@ -5601,14 +5840,14 @@
               <a:spcAft>
                 <a:spcPts val="839"/>
               </a:spcAft>
-              <a:defRPr sz="2400" b="1">
+            </a:pPr>
+            <a:r>
+              <a:rPr sz="2400" b="1">
                 <a:solidFill>
                   <a:srgbClr val="9AA8F0"/>
                 </a:solidFill>
                 <a:latin typeface="Calibri"/>
-              </a:defRPr>
-            </a:pPr>
-            <a:r>
+              </a:rPr>
               <a:t>3  Trade</a:t>
             </a:r>
           </a:p>
@@ -5640,14 +5879,14 @@
               <a:spcAft>
                 <a:spcPts val="700"/>
               </a:spcAft>
-              <a:defRPr sz="2000" b="0">
+            </a:pPr>
+            <a:r>
+              <a:rPr sz="2000" b="0">
                 <a:solidFill>
                   <a:srgbClr val="FFFFFF"/>
                 </a:solidFill>
                 <a:latin typeface="Calibri"/>
-              </a:defRPr>
-            </a:pPr>
-            <a:r>
+              </a:rPr>
               <a:t>Runner places the order on Bybit testnet (vetoed signals go Flat)</a:t>
             </a:r>
           </a:p>
@@ -5679,14 +5918,14 @@
               <a:spcAft>
                 <a:spcPts val="839"/>
               </a:spcAft>
-              <a:defRPr sz="2400" b="1">
+            </a:pPr>
+            <a:r>
+              <a:rPr sz="2400" b="1">
                 <a:solidFill>
                   <a:srgbClr val="FFFFFF"/>
                 </a:solidFill>
                 <a:latin typeface="Calibri"/>
-              </a:defRPr>
-            </a:pPr>
-            <a:r>
+              </a:rPr>
               <a:t>4  Record</a:t>
             </a:r>
           </a:p>
@@ -5718,15 +5957,24 @@
               <a:spcAft>
                 <a:spcPts val="700"/>
               </a:spcAft>
-              <a:defRPr sz="2000" b="0">
+            </a:pPr>
+            <a:r>
+              <a:rPr sz="2000" b="0">
                 <a:solidFill>
                   <a:srgbClr val="FFFFFF"/>
                 </a:solidFill>
-                <a:latin typeface="Calibri"/>
-              </a:defRPr>
-            </a:pPr>
-            <a:r>
-              <a:t>recordDecision(...) leaves a public receipt; a breach halts the contract</a:t>
+                <a:latin typeface="Consolas"/>
+              </a:rPr>
+              <a:t>recordDecision(...)</a:t>
+            </a:r>
+            <a:r>
+              <a:rPr sz="2000" b="0">
+                <a:solidFill>
+                  <a:srgbClr val="FFFFFF"/>
+                </a:solidFill>
+                <a:latin typeface="Calibri"/>
+              </a:rPr>
+              <a:t> leaves a public receipt; a breach halts it</a:t>
             </a:r>
           </a:p>
         </p:txBody>
@@ -5757,14 +6005,14 @@
               <a:spcAft>
                 <a:spcPts val="489"/>
               </a:spcAft>
-              <a:defRPr sz="1400" b="0">
+            </a:pPr>
+            <a:r>
+              <a:rPr sz="1400" b="0">
                 <a:solidFill>
                   <a:srgbClr val="AAAAAB"/>
                 </a:solidFill>
                 <a:latin typeface="Calibri"/>
-              </a:defRPr>
-            </a:pPr>
-            <a:r>
+              </a:rPr>
               <a:t>Periwinkle: off-chain engine · white: on-chain contract</a:t>
             </a:r>
           </a:p>
@@ -5796,14 +6044,14 @@
               <a:spcAft>
                 <a:spcPts val="630"/>
               </a:spcAft>
-              <a:defRPr sz="1800" b="0">
+            </a:pPr>
+            <a:r>
+              <a:rPr sz="1800" b="0">
                 <a:solidFill>
                   <a:srgbClr val="AAAAAB"/>
                 </a:solidFill>
                 <a:latin typeface="Calibri"/>
-              </a:defRPr>
-            </a:pPr>
-            <a:r>
+              </a:rPr>
               <a:t>The contract never executes orders; it is the public rule and the public record.</a:t>
             </a:r>
           </a:p>
@@ -5861,14 +6109,14 @@
               <a:spcAft>
                 <a:spcPts val="1260"/>
               </a:spcAft>
-              <a:defRPr sz="3600" b="1">
+            </a:pPr>
+            <a:r>
+              <a:rPr sz="3600" b="1">
                 <a:solidFill>
                   <a:srgbClr val="FFFFFF"/>
                 </a:solidFill>
                 <a:latin typeface="Calibri"/>
-              </a:defRPr>
-            </a:pPr>
-            <a:r>
+              </a:rPr>
               <a:t>The panel, and asking the contract</a:t>
             </a:r>
           </a:p>
@@ -5884,6 +6132,7 @@
         </p:nvPicPr>
         <p:blipFill>
           <a:blip r:embed="rId3"/>
+          <a:srcRect l="9700" t="9400" r="9700"/>
           <a:stretch>
             <a:fillRect/>
           </a:stretch>
@@ -5891,7 +6140,7 @@
         <p:spPr>
           <a:xfrm>
             <a:off x="457200" y="1280160"/>
-            <a:ext cx="5577840" cy="3486150"/>
+            <a:ext cx="5577840" cy="3918674"/>
           </a:xfrm>
           <a:prstGeom prst="rect">
             <a:avLst/>
@@ -5915,7 +6164,7 @@
         <p:spPr>
           <a:xfrm>
             <a:off x="6217920" y="1280160"/>
-            <a:ext cx="5486400" cy="2704427"/>
+            <a:ext cx="5486400" cy="2704426"/>
           </a:xfrm>
           <a:prstGeom prst="rect">
             <a:avLst/>
@@ -5930,8 +6179,8 @@
         </p:nvSpPr>
         <p:spPr>
           <a:xfrm>
-            <a:off x="457200" y="4937760"/>
-            <a:ext cx="5577840" cy="1280160"/>
+            <a:off x="457200" y="5349240"/>
+            <a:ext cx="5577840" cy="1097280"/>
           </a:xfrm>
           <a:prstGeom prst="rect">
             <a:avLst/>
@@ -5948,14 +6197,14 @@
               <a:spcAft>
                 <a:spcPts val="560"/>
               </a:spcAft>
-              <a:defRPr sz="1600" b="0">
+            </a:pPr>
+            <a:r>
+              <a:rPr sz="1600" b="0">
                 <a:solidFill>
                   <a:srgbClr val="AAAAAB"/>
                 </a:solidFill>
                 <a:latin typeface="Calibri"/>
-              </a:defRPr>
-            </a:pPr>
-            <a:r>
+              </a:rPr>
               <a:t>Live regime, halt, 20% line and decisions,</a:t>
             </a:r>
           </a:p>
@@ -5964,14 +6213,14 @@
               <a:spcAft>
                 <a:spcPts val="560"/>
               </a:spcAft>
-              <a:defRPr sz="1600" b="0">
+            </a:pPr>
+            <a:r>
+              <a:rPr sz="1600" b="0">
                 <a:solidFill>
                   <a:srgbClr val="AAAAAB"/>
                 </a:solidFill>
                 <a:latin typeface="Calibri"/>
-              </a:defRPr>
-            </a:pPr>
-            <a:r>
+              </a:rPr>
               <a:t>read from BSC Testnet at a named block</a:t>
             </a:r>
           </a:p>
@@ -5985,8 +6234,8 @@
         </p:nvSpPr>
         <p:spPr>
           <a:xfrm>
-            <a:off x="6217920" y="4937760"/>
-            <a:ext cx="5486400" cy="1280160"/>
+            <a:off x="6217920" y="5349240"/>
+            <a:ext cx="5486400" cy="1097280"/>
           </a:xfrm>
           <a:prstGeom prst="rect">
             <a:avLst/>
@@ -6003,14 +6252,14 @@
               <a:spcAft>
                 <a:spcPts val="560"/>
               </a:spcAft>
-              <a:defRPr sz="1600" b="0">
+            </a:pPr>
+            <a:r>
+              <a:rPr sz="1600" b="0">
                 <a:solidFill>
                   <a:srgbClr val="AAAAAB"/>
                 </a:solidFill>
                 <a:latin typeface="Calibri"/>
-              </a:defRPr>
-            </a:pPr>
-            <a:r>
+              </a:rPr>
               <a:t>Long at −25%: Blocked, answered by the live contract</a:t>
             </a:r>
           </a:p>
@@ -6019,15 +6268,33 @@
               <a:spcAft>
                 <a:spcPts val="560"/>
               </a:spcAft>
-              <a:defRPr sz="1600" b="0">
+            </a:pPr>
+            <a:r>
+              <a:rPr sz="1600" b="0">
                 <a:solidFill>
                   <a:srgbClr val="AAAAAB"/>
                 </a:solidFill>
                 <a:latin typeface="Calibri"/>
-              </a:defRPr>
-            </a:pPr>
-            <a:r>
-              <a:t>via eth_call from the agent address (simulation)</a:t>
+              </a:rPr>
+              <a:t>via </a:t>
+            </a:r>
+            <a:r>
+              <a:rPr sz="1600" b="0">
+                <a:solidFill>
+                  <a:srgbClr val="AAAAAB"/>
+                </a:solidFill>
+                <a:latin typeface="Consolas"/>
+              </a:rPr>
+              <a:t>eth_call</a:t>
+            </a:r>
+            <a:r>
+              <a:rPr sz="1600" b="0">
+                <a:solidFill>
+                  <a:srgbClr val="AAAAAB"/>
+                </a:solidFill>
+                <a:latin typeface="Calibri"/>
+              </a:rPr>
+              <a:t> from the agent address (simulation)</a:t>
             </a:r>
           </a:p>
         </p:txBody>
@@ -6084,14 +6351,14 @@
               <a:spcAft>
                 <a:spcPts val="1260"/>
               </a:spcAft>
-              <a:defRPr sz="3600" b="1">
+            </a:pPr>
+            <a:r>
+              <a:rPr sz="3600" b="1">
                 <a:solidFill>
                   <a:srgbClr val="FFFFFF"/>
                 </a:solidFill>
                 <a:latin typeface="Calibri"/>
-              </a:defRPr>
-            </a:pPr>
-            <a:r>
+              </a:rPr>
               <a:t>−25% recorded: the contract halted itself</a:t>
             </a:r>
           </a:p>
@@ -6338,14 +6605,14 @@
               <a:spcAft>
                 <a:spcPts val="489"/>
               </a:spcAft>
-              <a:defRPr sz="1400" b="1">
+            </a:pPr>
+            <a:r>
+              <a:rPr sz="1400" b="1">
                 <a:solidFill>
                   <a:srgbClr val="F0B90B"/>
                 </a:solidFill>
                 <a:latin typeface="Calibri"/>
-              </a:defRPr>
-            </a:pPr>
-            <a:r>
+              </a:rPr>
               <a:t>halt line 20%</a:t>
             </a:r>
           </a:p>
@@ -6377,14 +6644,14 @@
               <a:spcAft>
                 <a:spcPts val="489"/>
               </a:spcAft>
-              <a:defRPr sz="1400" b="0">
+            </a:pPr>
+            <a:r>
+              <a:rPr sz="1400" b="0">
                 <a:solidFill>
                   <a:srgbClr val="34D399"/>
                 </a:solidFill>
                 <a:latin typeface="Calibri"/>
-              </a:defRPr>
-            </a:pPr>
-            <a:r>
+              </a:rPr>
               <a:t>−1%: kept running</a:t>
             </a:r>
           </a:p>
@@ -6416,14 +6683,14 @@
               <a:spcAft>
                 <a:spcPts val="489"/>
               </a:spcAft>
-              <a:defRPr sz="1400" b="0">
+            </a:pPr>
+            <a:r>
+              <a:rPr sz="1400" b="0">
                 <a:solidFill>
                   <a:srgbClr val="FB7185"/>
                 </a:solidFill>
                 <a:latin typeface="Calibri"/>
-              </a:defRPr>
-            </a:pPr>
-            <a:r>
+              </a:rPr>
               <a:t>−25%: halted itself</a:t>
             </a:r>
           </a:p>
@@ -6455,14 +6722,14 @@
               <a:spcAft>
                 <a:spcPts val="560"/>
               </a:spcAft>
-              <a:defRPr sz="1600" b="0">
+            </a:pPr>
+            <a:r>
+              <a:rPr sz="1600" b="0">
                 <a:solidFill>
                   <a:srgbClr val="F0B90B"/>
                 </a:solidFill>
                 <a:latin typeface="Consolas"/>
-              </a:defRPr>
-            </a:pPr>
-            <a:r>
+              </a:rPr>
               <a:t>#134,042,196</a:t>
             </a:r>
           </a:p>
@@ -6494,14 +6761,14 @@
               <a:spcAft>
                 <a:spcPts val="560"/>
               </a:spcAft>
-              <a:defRPr sz="1600" b="0">
+            </a:pPr>
+            <a:r>
+              <a:rPr sz="1600" b="0">
                 <a:solidFill>
                   <a:srgbClr val="FFFFFF"/>
                 </a:solidFill>
                 <a:latin typeface="Consolas"/>
-              </a:defRPr>
-            </a:pPr>
-            <a:r>
+              </a:rPr>
               <a:t>setRegime(RiskOff)</a:t>
             </a:r>
           </a:p>
@@ -6533,14 +6800,14 @@
               <a:spcAft>
                 <a:spcPts val="594"/>
               </a:spcAft>
-              <a:defRPr sz="1700" b="0">
+            </a:pPr>
+            <a:r>
+              <a:rPr sz="1700" b="0">
                 <a:solidFill>
                   <a:srgbClr val="AAAAAB"/>
                 </a:solidFill>
                 <a:latin typeface="Calibri"/>
-              </a:defRPr>
-            </a:pPr>
-            <a:r>
+              </a:rPr>
               <a:t>Long blocked; Short and Flat open</a:t>
             </a:r>
           </a:p>
@@ -6572,14 +6839,14 @@
               <a:spcAft>
                 <a:spcPts val="560"/>
               </a:spcAft>
-              <a:defRPr sz="1600" b="0">
+            </a:pPr>
+            <a:r>
+              <a:rPr sz="1600" b="0">
                 <a:solidFill>
                   <a:srgbClr val="F0B90B"/>
                 </a:solidFill>
                 <a:latin typeface="Consolas"/>
-              </a:defRPr>
-            </a:pPr>
-            <a:r>
+              </a:rPr>
               <a:t>#134,042,256</a:t>
             </a:r>
           </a:p>
@@ -6611,14 +6878,14 @@
               <a:spcAft>
                 <a:spcPts val="560"/>
               </a:spcAft>
-              <a:defRPr sz="1600" b="0">
+            </a:pPr>
+            <a:r>
+              <a:rPr sz="1600" b="0">
                 <a:solidFill>
                   <a:srgbClr val="FFFFFF"/>
                 </a:solidFill>
                 <a:latin typeface="Consolas"/>
-              </a:defRPr>
-            </a:pPr>
-            <a:r>
+              </a:rPr>
               <a:t>recordDecision(BNB, Short, −1%)</a:t>
             </a:r>
           </a:p>
@@ -6650,14 +6917,14 @@
               <a:spcAft>
                 <a:spcPts val="594"/>
               </a:spcAft>
-              <a:defRPr sz="1700" b="0">
+            </a:pPr>
+            <a:r>
+              <a:rPr sz="1700" b="0">
                 <a:solidFill>
                   <a:srgbClr val="34D399"/>
                 </a:solidFill>
                 <a:latin typeface="Calibri"/>
-              </a:defRPr>
-            </a:pPr>
-            <a:r>
+              </a:rPr>
               <a:t>Decision #1, inside the line</a:t>
             </a:r>
           </a:p>
@@ -6732,14 +6999,14 @@
               <a:spcAft>
                 <a:spcPts val="560"/>
               </a:spcAft>
-              <a:defRPr sz="1600" b="0">
+            </a:pPr>
+            <a:r>
+              <a:rPr sz="1600" b="0">
                 <a:solidFill>
                   <a:srgbClr val="F0B90B"/>
                 </a:solidFill>
                 <a:latin typeface="Consolas"/>
-              </a:defRPr>
-            </a:pPr>
-            <a:r>
+              </a:rPr>
               <a:t>#134,042,283</a:t>
             </a:r>
           </a:p>
@@ -6771,14 +7038,14 @@
               <a:spcAft>
                 <a:spcPts val="560"/>
               </a:spcAft>
-              <a:defRPr sz="1600" b="1">
+            </a:pPr>
+            <a:r>
+              <a:rPr sz="1600" b="1">
                 <a:solidFill>
                   <a:srgbClr val="FFFFFF"/>
                 </a:solidFill>
                 <a:latin typeface="Consolas"/>
-              </a:defRPr>
-            </a:pPr>
-            <a:r>
+              </a:rPr>
               <a:t>recordDecision(BNB, Short, −25%)</a:t>
             </a:r>
           </a:p>
@@ -6810,14 +7077,14 @@
               <a:spcAft>
                 <a:spcPts val="594"/>
               </a:spcAft>
-              <a:defRPr sz="1700" b="0">
+            </a:pPr>
+            <a:r>
+              <a:rPr sz="1700" b="0">
                 <a:solidFill>
                   <a:srgbClr val="FB7185"/>
                 </a:solidFill>
                 <a:latin typeface="Calibri"/>
-              </a:defRPr>
-            </a:pPr>
-            <a:r>
+              </a:rPr>
               <a:t>Halted event: only Flat allowed</a:t>
             </a:r>
           </a:p>
@@ -6849,14 +7116,14 @@
               <a:spcAft>
                 <a:spcPts val="560"/>
               </a:spcAft>
-              <a:defRPr sz="1600" b="0">
+            </a:pPr>
+            <a:r>
+              <a:rPr sz="1600" b="0">
                 <a:solidFill>
                   <a:srgbClr val="F0B90B"/>
                 </a:solidFill>
                 <a:latin typeface="Consolas"/>
-              </a:defRPr>
-            </a:pPr>
-            <a:r>
+              </a:rPr>
               <a:t>#134,042,318</a:t>
             </a:r>
           </a:p>
@@ -6888,14 +7155,14 @@
               <a:spcAft>
                 <a:spcPts val="560"/>
               </a:spcAft>
-              <a:defRPr sz="1600" b="0">
+            </a:pPr>
+            <a:r>
+              <a:rPr sz="1600" b="0">
                 <a:solidFill>
                   <a:srgbClr val="FFFFFF"/>
                 </a:solidFill>
                 <a:latin typeface="Consolas"/>
-              </a:defRPr>
-            </a:pPr>
-            <a:r>
+              </a:rPr>
               <a:t>resume()</a:t>
             </a:r>
           </a:p>
@@ -6927,14 +7194,14 @@
               <a:spcAft>
                 <a:spcPts val="594"/>
               </a:spcAft>
-              <a:defRPr sz="1700" b="0">
+            </a:pPr>
+            <a:r>
+              <a:rPr sz="1700" b="0">
                 <a:solidFill>
                   <a:srgbClr val="AAAAAB"/>
                 </a:solidFill>
                 <a:latin typeface="Calibri"/>
-              </a:defRPr>
-            </a:pPr>
-            <a:r>
+              </a:rPr>
               <a:t>Agent-only, on the record</a:t>
             </a:r>
           </a:p>
@@ -6966,14 +7233,14 @@
               <a:spcAft>
                 <a:spcPts val="560"/>
               </a:spcAft>
-              <a:defRPr sz="1600" b="0">
+            </a:pPr>
+            <a:r>
+              <a:rPr sz="1600" b="0">
                 <a:solidFill>
                   <a:srgbClr val="F0B90B"/>
                 </a:solidFill>
                 <a:latin typeface="Consolas"/>
-              </a:defRPr>
-            </a:pPr>
-            <a:r>
+              </a:rPr>
               <a:t>#134,042,328</a:t>
             </a:r>
           </a:p>
@@ -7005,14 +7272,14 @@
               <a:spcAft>
                 <a:spcPts val="560"/>
               </a:spcAft>
-              <a:defRPr sz="1600" b="0">
+            </a:pPr>
+            <a:r>
+              <a:rPr sz="1600" b="0">
                 <a:solidFill>
                   <a:srgbClr val="FFFFFF"/>
                 </a:solidFill>
                 <a:latin typeface="Consolas"/>
-              </a:defRPr>
-            </a:pPr>
-            <a:r>
+              </a:rPr>
               <a:t>setRegime(Neutral)</a:t>
             </a:r>
           </a:p>
@@ -7044,14 +7311,14 @@
               <a:spcAft>
                 <a:spcPts val="594"/>
               </a:spcAft>
-              <a:defRPr sz="1700" b="0">
+            </a:pPr>
+            <a:r>
+              <a:rPr sz="1700" b="0">
                 <a:solidFill>
                   <a:srgbClr val="AAAAAB"/>
                 </a:solidFill>
                 <a:latin typeface="Calibri"/>
-              </a:defRPr>
-            </a:pPr>
-            <a:r>
+              </a:rPr>
               <a:t>Long allowed again; 2 decisions on-chain</a:t>
             </a:r>
           </a:p>
@@ -7083,15 +7350,33 @@
               <a:spcAft>
                 <a:spcPts val="489"/>
               </a:spcAft>
-              <a:defRPr sz="1400" b="0">
+            </a:pPr>
+            <a:r>
+              <a:rPr sz="1400" b="0">
                 <a:solidFill>
                   <a:srgbClr val="AAAAAB"/>
                 </a:solidFill>
                 <a:latin typeface="Calibri"/>
-              </a:defRPr>
-            </a:pPr>
-            <a:r>
-              <a:t>Every row is a transaction with receipt status 1 on BscScan · block 134,042,283 is the halt</a:t>
+              </a:rPr>
+              <a:t>Every row is a transaction with receipt status 1 on BscScan · block </a:t>
+            </a:r>
+            <a:r>
+              <a:rPr sz="1400" b="0">
+                <a:solidFill>
+                  <a:srgbClr val="AAAAAB"/>
+                </a:solidFill>
+                <a:latin typeface="Consolas"/>
+              </a:rPr>
+              <a:t>134,042,283</a:t>
+            </a:r>
+            <a:r>
+              <a:rPr sz="1400" b="0">
+                <a:solidFill>
+                  <a:srgbClr val="AAAAAB"/>
+                </a:solidFill>
+                <a:latin typeface="Calibri"/>
+              </a:rPr>
+              <a:t> is the halt</a:t>
             </a:r>
           </a:p>
         </p:txBody>
@@ -7148,14 +7433,14 @@
               <a:spcAft>
                 <a:spcPts val="1260"/>
               </a:spcAft>
-              <a:defRPr sz="3600" b="1">
+            </a:pPr>
+            <a:r>
+              <a:rPr sz="3600" b="1">
                 <a:solidFill>
                   <a:srgbClr val="FFFFFF"/>
                 </a:solidFill>
                 <a:latin typeface="Calibri"/>
-              </a:defRPr>
-            </a:pPr>
-            <a:r>
+              </a:rPr>
               <a:t>Why BNB Chain</a:t>
             </a:r>
           </a:p>
@@ -7187,14 +7472,14 @@
               <a:spcAft>
                 <a:spcPts val="1400"/>
               </a:spcAft>
-              <a:defRPr sz="4000" b="1">
+            </a:pPr>
+            <a:r>
+              <a:rPr sz="4000" b="1">
                 <a:solidFill>
                   <a:srgbClr val="FFFFFF"/>
                 </a:solidFill>
                 <a:latin typeface="Calibri"/>
-              </a:defRPr>
-            </a:pPr>
-            <a:r>
+              </a:rPr>
               <a:t>≈ 0.0000034 tBNB</a:t>
             </a:r>
           </a:p>
@@ -7226,15 +7511,33 @@
               <a:spcAft>
                 <a:spcPts val="630"/>
               </a:spcAft>
-              <a:defRPr sz="1800" b="0">
+            </a:pPr>
+            <a:r>
+              <a:rPr sz="1800" b="0">
                 <a:solidFill>
                   <a:srgbClr val="AAAAAB"/>
                 </a:solidFill>
                 <a:latin typeface="Calibri"/>
-              </a:defRPr>
-            </a:pPr>
-            <a:r>
-              <a:t>per recorded decision: 33,189–34,323 gas</a:t>
+              </a:rPr>
+              <a:t>per recorded decision: </a:t>
+            </a:r>
+            <a:r>
+              <a:rPr sz="1800" b="0">
+                <a:solidFill>
+                  <a:srgbClr val="AAAAAB"/>
+                </a:solidFill>
+                <a:latin typeface="Consolas"/>
+              </a:rPr>
+              <a:t>33,189–34,323</a:t>
+            </a:r>
+            <a:r>
+              <a:rPr sz="1800" b="0">
+                <a:solidFill>
+                  <a:srgbClr val="AAAAAB"/>
+                </a:solidFill>
+                <a:latin typeface="Calibri"/>
+              </a:rPr>
+              <a:t> gas</a:t>
             </a:r>
           </a:p>
           <a:p>
@@ -7242,15 +7545,33 @@
               <a:spcAft>
                 <a:spcPts val="630"/>
               </a:spcAft>
-              <a:defRPr sz="1800" b="0">
+            </a:pPr>
+            <a:r>
+              <a:rPr sz="1800" b="0">
                 <a:solidFill>
                   <a:srgbClr val="AAAAAB"/>
                 </a:solidFill>
                 <a:latin typeface="Calibri"/>
-              </a:defRPr>
-            </a:pPr>
-            <a:r>
-              <a:t>at 0.1 gwei (our receipts, BSC Testnet)</a:t>
+              </a:rPr>
+              <a:t>at </a:t>
+            </a:r>
+            <a:r>
+              <a:rPr sz="1800" b="0">
+                <a:solidFill>
+                  <a:srgbClr val="AAAAAB"/>
+                </a:solidFill>
+                <a:latin typeface="Consolas"/>
+              </a:rPr>
+              <a:t>0.1</a:t>
+            </a:r>
+            <a:r>
+              <a:rPr sz="1800" b="0">
+                <a:solidFill>
+                  <a:srgbClr val="AAAAAB"/>
+                </a:solidFill>
+                <a:latin typeface="Calibri"/>
+              </a:rPr>
+              <a:t> gwei (our receipts, BSC Testnet)</a:t>
             </a:r>
           </a:p>
         </p:txBody>
@@ -7281,14 +7602,14 @@
               <a:spcAft>
                 <a:spcPts val="1050"/>
               </a:spcAft>
-              <a:defRPr sz="3000" b="1">
+            </a:pPr>
+            <a:r>
+              <a:rPr sz="3000" b="1">
                 <a:solidFill>
                   <a:srgbClr val="FFFFFF"/>
                 </a:solidFill>
                 <a:latin typeface="Calibri"/>
-              </a:defRPr>
-            </a:pPr>
-            <a:r>
+              </a:rPr>
               <a:t>≈ 0.00008 tBNB a day</a:t>
             </a:r>
           </a:p>
@@ -7320,14 +7641,14 @@
               <a:spcAft>
                 <a:spcPts val="630"/>
               </a:spcAft>
-              <a:defRPr sz="1800" b="0">
+            </a:pPr>
+            <a:r>
+              <a:rPr sz="1800" b="0">
                 <a:solidFill>
                   <a:srgbClr val="AAAAAB"/>
                 </a:solidFill>
                 <a:latin typeface="Calibri"/>
-              </a:defRPr>
-            </a:pPr>
-            <a:r>
+              </a:rPr>
               <a:t>for an hourly bot (24 decisions);</a:t>
             </a:r>
           </a:p>
@@ -7336,15 +7657,33 @@
               <a:spcAft>
                 <a:spcPts val="630"/>
               </a:spcAft>
-              <a:defRPr sz="1800" b="0">
+            </a:pPr>
+            <a:r>
+              <a:rPr sz="1800" b="0">
                 <a:solidFill>
                   <a:srgbClr val="AAAAAB"/>
                 </a:solidFill>
                 <a:latin typeface="Calibri"/>
-              </a:defRPr>
-            </a:pPr>
-            <a:r>
-              <a:t>deploy: 449,207 gas ≈ 0.000045 tBNB</a:t>
+              </a:rPr>
+              <a:t>deploy: </a:t>
+            </a:r>
+            <a:r>
+              <a:rPr sz="1800" b="0">
+                <a:solidFill>
+                  <a:srgbClr val="AAAAAB"/>
+                </a:solidFill>
+                <a:latin typeface="Consolas"/>
+              </a:rPr>
+              <a:t>449,207</a:t>
+            </a:r>
+            <a:r>
+              <a:rPr sz="1800" b="0">
+                <a:solidFill>
+                  <a:srgbClr val="AAAAAB"/>
+                </a:solidFill>
+                <a:latin typeface="Calibri"/>
+              </a:rPr>
+              <a:t> gas ≈ 0.000045 tBNB</a:t>
             </a:r>
           </a:p>
         </p:txBody>
@@ -7375,14 +7714,14 @@
               <a:spcAft>
                 <a:spcPts val="839"/>
               </a:spcAft>
-              <a:defRPr sz="2400" b="1">
+            </a:pPr>
+            <a:r>
+              <a:rPr sz="2400" b="1">
                 <a:solidFill>
                   <a:srgbClr val="FFFFFF"/>
                 </a:solidFill>
                 <a:latin typeface="Calibri"/>
-              </a:defRPr>
-            </a:pPr>
-            <a:r>
+              </a:rPr>
               <a:t>What else it gives us</a:t>
             </a:r>
           </a:p>
@@ -7414,15 +7753,24 @@
               <a:spcAft>
                 <a:spcPts val="630"/>
               </a:spcAft>
-              <a:defRPr sz="1800" b="0">
+            </a:pPr>
+            <a:r>
+              <a:rPr sz="1800" b="0">
                 <a:solidFill>
                   <a:srgbClr val="FFFFFF"/>
                 </a:solidFill>
                 <a:latin typeface="Calibri"/>
-              </a:defRPr>
-            </a:pPr>
-            <a:r>
-              <a:t>EVM: Foundry tests and Sourcify verification on chain 97</a:t>
+              </a:rPr>
+              <a:t>EVM: Foundry tests and Sourcify verification on chain </a:t>
+            </a:r>
+            <a:r>
+              <a:rPr sz="1800" b="0">
+                <a:solidFill>
+                  <a:srgbClr val="FFFFFF"/>
+                </a:solidFill>
+                <a:latin typeface="Consolas"/>
+              </a:rPr>
+              <a:t>97</a:t>
             </a:r>
           </a:p>
           <a:p>
@@ -7430,14 +7778,14 @@
               <a:spcAft>
                 <a:spcPts val="630"/>
               </a:spcAft>
-              <a:defRPr sz="1800" b="0">
+            </a:pPr>
+            <a:r>
+              <a:rPr sz="1800" b="0">
                 <a:solidFill>
                   <a:srgbClr val="FFFFFF"/>
                 </a:solidFill>
                 <a:latin typeface="Calibri"/>
-              </a:defRPr>
-            </a:pPr>
-            <a:r>
+              </a:rPr>
               <a:t>Public RPCs a browser can call: the panel needs no backend</a:t>
             </a:r>
           </a:p>
@@ -7446,14 +7794,14 @@
               <a:spcAft>
                 <a:spcPts val="630"/>
               </a:spcAft>
-              <a:defRPr sz="1800" b="0">
+            </a:pPr>
+            <a:r>
+              <a:rPr sz="1800" b="0">
                 <a:solidFill>
                   <a:srgbClr val="FFFFFF"/>
                 </a:solidFill>
                 <a:latin typeface="Calibri"/>
-              </a:defRPr>
-            </a:pPr>
-            <a:r>
+              </a:rPr>
               <a:t>Five smoke-test transactions within 132 blocks</a:t>
             </a:r>
           </a:p>
@@ -7462,15 +7810,33 @@
               <a:spcAft>
                 <a:spcPts val="630"/>
               </a:spcAft>
-              <a:defRPr sz="1800" b="0">
+            </a:pPr>
+            <a:r>
+              <a:rPr sz="1800" b="0">
                 <a:solidFill>
                   <a:srgbClr val="FFFFFF"/>
                 </a:solidFill>
                 <a:latin typeface="Calibri"/>
-              </a:defRPr>
-            </a:pPr>
-            <a:r>
-              <a:t>Mainnet (chain 56) is a config switch; not deployed there</a:t>
+              </a:rPr>
+              <a:t>Mainnet (chain </a:t>
+            </a:r>
+            <a:r>
+              <a:rPr sz="1800" b="0">
+                <a:solidFill>
+                  <a:srgbClr val="FFFFFF"/>
+                </a:solidFill>
+                <a:latin typeface="Consolas"/>
+              </a:rPr>
+              <a:t>56</a:t>
+            </a:r>
+            <a:r>
+              <a:rPr sz="1800" b="0">
+                <a:solidFill>
+                  <a:srgbClr val="FFFFFF"/>
+                </a:solidFill>
+                <a:latin typeface="Calibri"/>
+              </a:rPr>
+              <a:t>) is a config switch; not deployed there</a:t>
             </a:r>
           </a:p>
         </p:txBody>
@@ -7501,14 +7867,14 @@
               <a:spcAft>
                 <a:spcPts val="489"/>
               </a:spcAft>
-              <a:defRPr sz="1400" b="0">
+            </a:pPr>
+            <a:r>
+              <a:rPr sz="1400" b="0">
                 <a:solidFill>
                   <a:srgbClr val="AAAAAB"/>
                 </a:solidFill>
                 <a:latin typeface="Calibri"/>
-              </a:defRPr>
-            </a:pPr>
-            <a:r>
+              </a:rPr>
               <a:t>Testnet gas price, not a mainnet quote. Mainnet is on the roadmap, after an audit.</a:t>
             </a:r>
           </a:p>
@@ -7566,14 +7932,14 @@
               <a:spcAft>
                 <a:spcPts val="1260"/>
               </a:spcAft>
-              <a:defRPr sz="3600" b="1">
+            </a:pPr>
+            <a:r>
+              <a:rPr sz="3600" b="1">
                 <a:solidFill>
                   <a:srgbClr val="FFFFFF"/>
                 </a:solidFill>
                 <a:latin typeface="Calibri"/>
-              </a:defRPr>
-            </a:pPr>
-            <a:r>
+              </a:rPr>
               <a:t>Evidence and current limits</a:t>
             </a:r>
           </a:p>
@@ -7605,14 +7971,14 @@
               <a:spcAft>
                 <a:spcPts val="1189"/>
               </a:spcAft>
-              <a:defRPr sz="3400" b="1">
+            </a:pPr>
+            <a:r>
+              <a:rPr sz="3400" b="1">
                 <a:solidFill>
                   <a:srgbClr val="34D399"/>
                 </a:solidFill>
                 <a:latin typeface="Calibri"/>
-              </a:defRPr>
-            </a:pPr>
-            <a:r>
+              </a:rPr>
               <a:t>30 / 30</a:t>
             </a:r>
           </a:p>
@@ -7644,14 +8010,14 @@
               <a:spcAft>
                 <a:spcPts val="489"/>
               </a:spcAft>
-              <a:defRPr sz="1400" b="0">
+            </a:pPr>
+            <a:r>
+              <a:rPr sz="1400" b="0">
                 <a:solidFill>
                   <a:srgbClr val="FFFFFF"/>
                 </a:solidFill>
                 <a:latin typeface="Calibri"/>
-              </a:defRPr>
-            </a:pPr>
-            <a:r>
+              </a:rPr>
               <a:t>contract tests: unit, fuzz, invariant</a:t>
             </a:r>
           </a:p>
@@ -7660,14 +8026,14 @@
               <a:spcAft>
                 <a:spcPts val="489"/>
               </a:spcAft>
-              <a:defRPr sz="1400" b="0">
+            </a:pPr>
+            <a:r>
+              <a:rPr sz="1400" b="0">
                 <a:solidFill>
                   <a:srgbClr val="FFFFFF"/>
                 </a:solidFill>
                 <a:latin typeface="Calibri"/>
-              </a:defRPr>
-            </a:pPr>
-            <a:r>
+              </a:rPr>
               <a:t>100% coverage of MacroGuard.sol</a:t>
             </a:r>
           </a:p>
@@ -7699,15 +8065,15 @@
               <a:spcAft>
                 <a:spcPts val="1189"/>
               </a:spcAft>
-              <a:defRPr sz="3400" b="1">
+            </a:pPr>
+            <a:r>
+              <a:rPr sz="3400" b="1">
                 <a:solidFill>
                   <a:srgbClr val="34D399"/>
                 </a:solidFill>
                 <a:latin typeface="Calibri"/>
-              </a:defRPr>
-            </a:pPr>
-            <a:r>
-              <a:t>47</a:t>
+              </a:rPr>
+              <a:t>48</a:t>
             </a:r>
           </a:p>
         </p:txBody>
@@ -7738,14 +8104,14 @@
               <a:spcAft>
                 <a:spcPts val="489"/>
               </a:spcAft>
-              <a:defRPr sz="1400" b="0">
+            </a:pPr>
+            <a:r>
+              <a:rPr sz="1400" b="0">
                 <a:solidFill>
                   <a:srgbClr val="FFFFFF"/>
                 </a:solidFill>
                 <a:latin typeface="Calibri"/>
-              </a:defRPr>
-            </a:pPr>
-            <a:r>
+              </a:rPr>
               <a:t>offline engine tests;</a:t>
             </a:r>
           </a:p>
@@ -7754,14 +8120,14 @@
               <a:spcAft>
                 <a:spcPts val="489"/>
               </a:spcAft>
-              <a:defRPr sz="1400" b="0">
+            </a:pPr>
+            <a:r>
+              <a:rPr sz="1400" b="0">
                 <a:solidFill>
                   <a:srgbClr val="FFFFFF"/>
                 </a:solidFill>
                 <a:latin typeface="Calibri"/>
-              </a:defRPr>
-            </a:pPr>
-            <a:r>
+              </a:rPr>
               <a:t>no look-ahead tested as a property</a:t>
             </a:r>
           </a:p>
@@ -7793,14 +8159,14 @@
               <a:spcAft>
                 <a:spcPts val="1189"/>
               </a:spcAft>
-              <a:defRPr sz="3400" b="1">
+            </a:pPr>
+            <a:r>
+              <a:rPr sz="3400" b="1">
                 <a:solidFill>
                   <a:srgbClr val="34D399"/>
                 </a:solidFill>
                 <a:latin typeface="Calibri"/>
-              </a:defRPr>
-            </a:pPr>
-            <a:r>
+              </a:rPr>
               <a:t>15</a:t>
             </a:r>
           </a:p>
@@ -7832,14 +8198,14 @@
               <a:spcAft>
                 <a:spcPts val="489"/>
               </a:spcAft>
-              <a:defRPr sz="1400" b="0">
+            </a:pPr>
+            <a:r>
+              <a:rPr sz="1400" b="0">
                 <a:solidFill>
                   <a:srgbClr val="FFFFFF"/>
                 </a:solidFill>
                 <a:latin typeface="Calibri"/>
-              </a:defRPr>
-            </a:pPr>
-            <a:r>
+              </a:rPr>
               <a:t>web tests: contract reads and the</a:t>
             </a:r>
           </a:p>
@@ -7848,14 +8214,14 @@
               <a:spcAft>
                 <a:spcPts val="489"/>
               </a:spcAft>
-              <a:defRPr sz="1400" b="0">
+            </a:pPr>
+            <a:r>
+              <a:rPr sz="1400" b="0">
                 <a:solidFill>
                   <a:srgbClr val="FFFFFF"/>
                 </a:solidFill>
                 <a:latin typeface="Calibri"/>
-              </a:defRPr>
-            </a:pPr>
-            <a:r>
+              </a:rPr>
               <a:t>what-if encoder against cast</a:t>
             </a:r>
           </a:p>
@@ -7887,14 +8253,14 @@
               <a:spcAft>
                 <a:spcPts val="1189"/>
               </a:spcAft>
-              <a:defRPr sz="3400" b="1">
+            </a:pPr>
+            <a:r>
+              <a:rPr sz="3400" b="1">
                 <a:solidFill>
                   <a:srgbClr val="F0B90B"/>
                 </a:solidFill>
                 <a:latin typeface="Calibri"/>
-              </a:defRPr>
-            </a:pPr>
-            <a:r>
+              </a:rPr>
               <a:t>exact match</a:t>
             </a:r>
           </a:p>
@@ -7926,14 +8292,14 @@
               <a:spcAft>
                 <a:spcPts val="489"/>
               </a:spcAft>
-              <a:defRPr sz="1400" b="0">
+            </a:pPr>
+            <a:r>
+              <a:rPr sz="1400" b="0">
                 <a:solidFill>
                   <a:srgbClr val="FFFFFF"/>
                 </a:solidFill>
                 <a:latin typeface="Calibri"/>
-              </a:defRPr>
-            </a:pPr>
-            <a:r>
+              </a:rPr>
               <a:t>source verified on Sourcify</a:t>
             </a:r>
           </a:p>
@@ -7942,14 +8308,14 @@
               <a:spcAft>
                 <a:spcPts val="489"/>
               </a:spcAft>
-              <a:defRPr sz="1400" b="0">
+            </a:pPr>
+            <a:r>
+              <a:rPr sz="1400" b="0">
                 <a:solidFill>
                   <a:srgbClr val="FFFFFF"/>
                 </a:solidFill>
                 <a:latin typeface="Calibri"/>
-              </a:defRPr>
-            </a:pPr>
-            <a:r>
+              </a:rPr>
               <a:t>6 receipts, all status 1</a:t>
             </a:r>
           </a:p>
@@ -7981,14 +8347,14 @@
               <a:spcAft>
                 <a:spcPts val="769"/>
               </a:spcAft>
-              <a:defRPr sz="2200" b="1">
+            </a:pPr>
+            <a:r>
+              <a:rPr sz="2200" b="1">
                 <a:solidFill>
                   <a:srgbClr val="FBBF24"/>
                 </a:solidFill>
                 <a:latin typeface="Calibri"/>
-              </a:defRPr>
-            </a:pPr>
-            <a:r>
+              </a:rPr>
               <a:t>Limits, said plainly</a:t>
             </a:r>
           </a:p>
@@ -8020,15 +8386,33 @@
               <a:spcAft>
                 <a:spcPts val="560"/>
               </a:spcAft>
-              <a:defRPr sz="1600" b="0">
+            </a:pPr>
+            <a:r>
+              <a:rPr sz="1600" b="0">
                 <a:solidFill>
                   <a:srgbClr val="FFFFFF"/>
                 </a:solidFill>
                 <a:latin typeface="Calibri"/>
-              </a:defRPr>
-            </a:pPr>
-            <a:r>
-              <a:t>The contract never executes orders · the runner fails open if the RPC is down · the agent can resume() at once</a:t>
+              </a:rPr>
+              <a:t>The contract never executes orders · the runner fails open if the RPC is down · the agent can </a:t>
+            </a:r>
+            <a:r>
+              <a:rPr sz="1600" b="0">
+                <a:solidFill>
+                  <a:srgbClr val="FFFFFF"/>
+                </a:solidFill>
+                <a:latin typeface="Consolas"/>
+              </a:rPr>
+              <a:t>resume()</a:t>
+            </a:r>
+            <a:r>
+              <a:rPr sz="1600" b="0">
+                <a:solidFill>
+                  <a:srgbClr val="FFFFFF"/>
+                </a:solidFill>
+                <a:latin typeface="Calibri"/>
+              </a:rPr>
+              <a:t> at once</a:t>
             </a:r>
           </a:p>
           <a:p>
@@ -8036,14 +8420,14 @@
               <a:spcAft>
                 <a:spcPts val="560"/>
               </a:spcAft>
-              <a:defRPr sz="1600" b="0">
+            </a:pPr>
+            <a:r>
+              <a:rPr sz="1600" b="0">
                 <a:solidFill>
                   <a:srgbClr val="FFFFFF"/>
                 </a:solidFill>
                 <a:latin typeface="Calibri"/>
-              </a:defRPr>
-            </a:pPr>
-            <a:r>
+              </a:rPr>
               <a:t>The drawdown is reported by the agent · no live bot tick and no profit claimed; backtests are research</a:t>
             </a:r>
           </a:p>
@@ -8101,14 +8485,14 @@
               <a:spcAft>
                 <a:spcPts val="1260"/>
               </a:spcAft>
-              <a:defRPr sz="3600" b="1">
+            </a:pPr>
+            <a:r>
+              <a:rPr sz="3600" b="1">
                 <a:solidFill>
                   <a:srgbClr val="FFFFFF"/>
                 </a:solidFill>
                 <a:latin typeface="Calibri"/>
-              </a:defRPr>
-            </a:pPr>
-            <a:r>
+              </a:rPr>
               <a:t>What Dex added</a:t>
             </a:r>
           </a:p>
@@ -8140,14 +8524,14 @@
               <a:spcAft>
                 <a:spcPts val="839"/>
               </a:spcAft>
-              <a:defRPr sz="2400" b="1">
+            </a:pPr>
+            <a:r>
+              <a:rPr sz="2400" b="1">
                 <a:solidFill>
                   <a:srgbClr val="AAAAAB"/>
                 </a:solidFill>
                 <a:latin typeface="Calibri"/>
-              </a:defRPr>
-            </a:pPr>
-            <a:r>
+              </a:rPr>
               <a:t>Upstream DRIFT project</a:t>
             </a:r>
           </a:p>
@@ -8179,14 +8563,14 @@
               <a:spcAft>
                 <a:spcPts val="630"/>
               </a:spcAft>
-              <a:defRPr sz="1800" b="0">
+            </a:pPr>
+            <a:r>
+              <a:rPr sz="1800" b="0">
                 <a:solidFill>
                   <a:srgbClr val="FFFFFF"/>
                 </a:solidFill>
                 <a:latin typeface="Calibri"/>
-              </a:defRPr>
-            </a:pPr>
-            <a:r>
+              </a:rPr>
               <a:t>Quant engine, cockpit and MacroGuard.sol</a:t>
             </a:r>
           </a:p>
@@ -8195,14 +8579,14 @@
               <a:spcAft>
                 <a:spcPts val="630"/>
               </a:spcAft>
-              <a:defRPr sz="1800" b="0">
+            </a:pPr>
+            <a:r>
+              <a:rPr sz="1800" b="0">
                 <a:solidFill>
                   <a:srgbClr val="FFFFFF"/>
                 </a:solidFill>
                 <a:latin typeface="Calibri"/>
-              </a:defRPr>
-            </a:pPr>
-            <a:r>
+              </a:rPr>
               <a:t>7 contract tests</a:t>
             </a:r>
           </a:p>
@@ -8211,14 +8595,14 @@
               <a:spcAft>
                 <a:spcPts val="630"/>
               </a:spcAft>
-              <a:defRPr sz="1800" b="0">
+            </a:pPr>
+            <a:r>
+              <a:rPr sz="1800" b="0">
                 <a:solidFill>
                   <a:srgbClr val="FFFFFF"/>
                 </a:solidFill>
                 <a:latin typeface="Calibri"/>
-              </a:defRPr>
-            </a:pPr>
-            <a:r>
+              </a:rPr>
               <a:t>Built for a Mantle hackathon track (June 2026)</a:t>
             </a:r>
           </a:p>
@@ -8227,14 +8611,14 @@
               <a:spcAft>
                 <a:spcPts val="630"/>
               </a:spcAft>
-              <a:defRPr sz="1800" b="0">
+            </a:pPr>
+            <a:r>
+              <a:rPr sz="1800" b="0">
                 <a:solidFill>
                   <a:srgbClr val="FFFFFF"/>
                 </a:solidFill>
                 <a:latin typeface="Calibri"/>
-              </a:defRPr>
-            </a:pPr>
-            <a:r>
+              </a:rPr>
               <a:t>Migrated to BNB Chain in bcc-ukdw/seed-bnb</a:t>
             </a:r>
           </a:p>
@@ -8243,15 +8627,33 @@
               <a:spcAft>
                 <a:spcPts val="630"/>
               </a:spcAft>
-              <a:defRPr sz="1800" b="0">
+            </a:pPr>
+            <a:r>
+              <a:rPr sz="1800" b="0">
                 <a:solidFill>
                   <a:srgbClr val="FFFFFF"/>
                 </a:solidFill>
                 <a:latin typeface="Calibri"/>
-              </a:defRPr>
-            </a:pPr>
-            <a:r>
-              <a:t>(commit 52671ce, 29 Sep 2026)</a:t>
+              </a:rPr>
+              <a:t>(commit </a:t>
+            </a:r>
+            <a:r>
+              <a:rPr sz="1800" b="0">
+                <a:solidFill>
+                  <a:srgbClr val="FFFFFF"/>
+                </a:solidFill>
+                <a:latin typeface="Consolas"/>
+              </a:rPr>
+              <a:t>52671ce</a:t>
+            </a:r>
+            <a:r>
+              <a:rPr sz="1800" b="0">
+                <a:solidFill>
+                  <a:srgbClr val="FFFFFF"/>
+                </a:solidFill>
+                <a:latin typeface="Calibri"/>
+              </a:rPr>
+              <a:t>, 29 Sep 2026)</a:t>
             </a:r>
           </a:p>
         </p:txBody>
@@ -8282,14 +8684,14 @@
               <a:spcAft>
                 <a:spcPts val="839"/>
               </a:spcAft>
-              <a:defRPr sz="2400" b="1">
+            </a:pPr>
+            <a:r>
+              <a:rPr sz="2400" b="1">
                 <a:solidFill>
                   <a:srgbClr val="FFFFFF"/>
                 </a:solidFill>
                 <a:latin typeface="Calibri"/>
-              </a:defRPr>
-            </a:pPr>
-            <a:r>
+              </a:rPr>
               <a:t>Dex's work in this fork</a:t>
             </a:r>
           </a:p>
@@ -8321,14 +8723,14 @@
               <a:spcAft>
                 <a:spcPts val="594"/>
               </a:spcAft>
-              <a:defRPr sz="1700" b="0">
+            </a:pPr>
+            <a:r>
+              <a:rPr sz="1700" b="0">
                 <a:solidFill>
                   <a:srgbClr val="FFFFFF"/>
                 </a:solidFill>
                 <a:latin typeface="Calibri"/>
-              </a:defRPr>
-            </a:pPr>
-            <a:r>
+              </a:rPr>
               <a:t>Own BSC Testnet deploy + 5-tx smoke test (status 1)</a:t>
             </a:r>
           </a:p>
@@ -8337,14 +8739,14 @@
               <a:spcAft>
                 <a:spcPts val="594"/>
               </a:spcAft>
-              <a:defRPr sz="1700" b="0">
+            </a:pPr>
+            <a:r>
+              <a:rPr sz="1700" b="0">
                 <a:solidFill>
                   <a:srgbClr val="FFFFFF"/>
                 </a:solidFill>
                 <a:latin typeface="Calibri"/>
-              </a:defRPr>
-            </a:pPr>
-            <a:r>
+              </a:rPr>
               <a:t>Source verified on Sourcify (exact match)</a:t>
             </a:r>
           </a:p>
@@ -8353,14 +8755,14 @@
               <a:spcAft>
                 <a:spcPts val="594"/>
               </a:spcAft>
-              <a:defRPr sz="1700" b="0">
+            </a:pPr>
+            <a:r>
+              <a:rPr sz="1700" b="0">
                 <a:solidFill>
                   <a:srgbClr val="FFFFFF"/>
                 </a:solidFill>
                 <a:latin typeface="Calibri"/>
-              </a:defRPr>
-            </a:pPr>
-            <a:r>
+              </a:rPr>
               <a:t>Public panel: live browser reads, receipts, limits</a:t>
             </a:r>
           </a:p>
@@ -8369,15 +8771,33 @@
               <a:spcAft>
                 <a:spcPts val="594"/>
               </a:spcAft>
-              <a:defRPr sz="1700" b="0">
+            </a:pPr>
+            <a:r>
+              <a:rPr sz="1700" b="0">
                 <a:solidFill>
                   <a:srgbClr val="FFFFFF"/>
                 </a:solidFill>
                 <a:latin typeface="Calibri"/>
-              </a:defRPr>
-            </a:pPr>
-            <a:r>
-              <a:t>Ask the contract: eth_call what-if, nothing signed</a:t>
+              </a:rPr>
+              <a:t>Ask the contract: </a:t>
+            </a:r>
+            <a:r>
+              <a:rPr sz="1700" b="0">
+                <a:solidFill>
+                  <a:srgbClr val="FFFFFF"/>
+                </a:solidFill>
+                <a:latin typeface="Consolas"/>
+              </a:rPr>
+              <a:t>eth_call</a:t>
+            </a:r>
+            <a:r>
+              <a:rPr sz="1700" b="0">
+                <a:solidFill>
+                  <a:srgbClr val="FFFFFF"/>
+                </a:solidFill>
+                <a:latin typeface="Calibri"/>
+              </a:rPr>
+              <a:t> what-if, nothing signed</a:t>
             </a:r>
           </a:p>
           <a:p>
@@ -8385,15 +8805,15 @@
               <a:spcAft>
                 <a:spcPts val="594"/>
               </a:spcAft>
-              <a:defRPr sz="1700" b="0">
+            </a:pPr>
+            <a:r>
+              <a:rPr sz="1700" b="0">
                 <a:solidFill>
                   <a:srgbClr val="FFFFFF"/>
                 </a:solidFill>
                 <a:latin typeface="Calibri"/>
-              </a:defRPr>
-            </a:pPr>
-            <a:r>
-              <a:t>+23 contract tests, 47 engine tests, 15 web tests, CI</a:t>
+              </a:rPr>
+              <a:t>+23 contract tests, 48 engine tests, 15 web tests, CI</a:t>
             </a:r>
           </a:p>
           <a:p>
@@ -8401,14 +8821,14 @@
               <a:spcAft>
                 <a:spcPts val="594"/>
               </a:spcAft>
-              <a:defRPr sz="1700" b="0">
+            </a:pPr>
+            <a:r>
+              <a:rPr sz="1700" b="0">
                 <a:solidFill>
                   <a:srgbClr val="FFFFFF"/>
                 </a:solidFill>
                 <a:latin typeface="Calibri"/>
-              </a:defRPr>
-            </a:pPr>
-            <a:r>
+              </a:rPr>
               <a:t>Labelled Binance data fallback · threat model</a:t>
             </a:r>
           </a:p>
@@ -8417,14 +8837,14 @@
               <a:spcAft>
                 <a:spcPts val="594"/>
               </a:spcAft>
-              <a:defRPr sz="1700" b="0">
+            </a:pPr>
+            <a:r>
+              <a:rPr sz="1700" b="0">
                 <a:solidFill>
                   <a:srgbClr val="FFFFFF"/>
                 </a:solidFill>
                 <a:latin typeface="Calibri"/>
-              </a:defRPr>
-            </a:pPr>
-            <a:r>
+              </a:rPr>
               <a:t>Landing, visual system, PRD, this deck</a:t>
             </a:r>
           </a:p>
@@ -8456,15 +8876,24 @@
               <a:spcAft>
                 <a:spcPts val="560"/>
               </a:spcAft>
-              <a:defRPr sz="1600" b="0">
+            </a:pPr>
+            <a:r>
+              <a:rPr sz="1600" b="0">
                 <a:solidFill>
                   <a:srgbClr val="AAAAAB"/>
                 </a:solidFill>
+                <a:latin typeface="Calibri"/>
+              </a:rPr>
+              <a:t>Code: </a:t>
+            </a:r>
+            <a:r>
+              <a:rPr sz="1600" b="0">
+                <a:solidFill>
+                  <a:srgbClr val="AAAAAB"/>
+                </a:solidFill>
                 <a:latin typeface="Consolas"/>
-              </a:defRPr>
-            </a:pPr>
-            <a:r>
-              <a:t>Code: github.com/Stylenecy/seed-bnb/tree/dex/drift/drift</a:t>
+              </a:rPr>
+              <a:t>github.com/Stylenecy/seed-bnb/tree/dex/drift/drift</a:t>
             </a:r>
           </a:p>
         </p:txBody>
@@ -8512,10 +8941,10 @@
         <a:srgbClr val="F79646"/>
       </a:accent6>
       <a:hlink>
-        <a:srgbClr val="0000FF"/>
+        <a:srgbClr val="F0B90B"/>
       </a:hlink>
       <a:folHlink>
-        <a:srgbClr val="800080"/>
+        <a:srgbClr val="F0B90B"/>
       </a:folHlink>
     </a:clrScheme>
     <a:fontScheme name="Office">
@@ -8832,10 +9261,10 @@
         <a:srgbClr val="F79646"/>
       </a:accent6>
       <a:hlink>
-        <a:srgbClr val="0000FF"/>
+        <a:srgbClr val="F0B90B"/>
       </a:hlink>
       <a:folHlink>
-        <a:srgbClr val="800080"/>
+        <a:srgbClr val="F0B90B"/>
       </a:folHlink>
     </a:clrScheme>
     <a:fontScheme name="Office">

</xml_diff>

<commit_message>
docs(drift): crop slide 5 at the panel's edge; say which deck links are clickable
The panel screenshot now ends below the verdict cards instead of
cutting through the receipt list, with its caption moved up. Slide 10's
speaker note says that the BscScan and Sourcify links are the clickable
ones. PDF rebuilt.
</commit_message>
<xml_diff>
--- a/docs/submission/DRIFT-pitch.pptx
+++ b/docs/submission/DRIFT-pitch.pptx
@@ -581,7 +581,7 @@
           <a:lstStyle/>
           <a:p>
             <a:r>
-              <a:t>Roadmap items are not built yet. The links are live today and clickable in the deck.</a:t>
+              <a:t>Roadmap items are not built yet. The links are live today; the BscScan and Sourcify links are clickable.</a:t>
             </a:r>
           </a:p>
         </p:txBody>
@@ -6132,7 +6132,7 @@
         </p:nvPicPr>
         <p:blipFill>
           <a:blip r:embed="rId3"/>
-          <a:srcRect l="9700" t="9400" r="9700"/>
+          <a:srcRect l="9700" t="9400" r="9700" b="12000"/>
           <a:stretch>
             <a:fillRect/>
           </a:stretch>
@@ -6140,7 +6140,7 @@
         <p:spPr>
           <a:xfrm>
             <a:off x="457200" y="1280160"/>
-            <a:ext cx="5577840" cy="3918674"/>
+            <a:ext cx="5577840" cy="3399645"/>
           </a:xfrm>
           <a:prstGeom prst="rect">
             <a:avLst/>
@@ -6179,7 +6179,7 @@
         </p:nvSpPr>
         <p:spPr>
           <a:xfrm>
-            <a:off x="457200" y="5349240"/>
+            <a:off x="457200" y="4800600"/>
             <a:ext cx="5577840" cy="1097280"/>
           </a:xfrm>
           <a:prstGeom prst="rect">
@@ -6234,7 +6234,7 @@
         </p:nvSpPr>
         <p:spPr>
           <a:xfrm>
-            <a:off x="6217920" y="5349240"/>
+            <a:off x="6217920" y="4800600"/>
             <a:ext cx="5486400" cy="1097280"/>
           </a:xfrm>
           <a:prstGeom prst="rect">

</xml_diff>